<commit_message>
Restore original flow illustrations in Live Sketchbook v2 deck
Co-Authored-By: Claude Opus 5.5 <noreply@anthropic.com>
Claude-Session: https://claude.ai/code/session_011BBjM7b8Q7Xhvjdp6vDPPC
</commit_message>
<xml_diff>
--- a/live-sketchbook/Live_Sketchbook_Experience_Flow_v2.pptx
+++ b/live-sketchbook/Live_Sketchbook_Experience_Flow_v2.pptx
@@ -116,52 +116,52 @@
   <p:extLst>
     <p:ext uri="{521415D9-36F7-43E2-AB2F-B90AF26B5E84}">
       <p14:sectionLst xmlns:p14="http://schemas.microsoft.com/office/powerpoint/2010/main">
-        <p14:section name="표지" id="{01e800f4-501a-6d53-d5be-7ca192d230f8}">
+        <p14:section name="표지" id="{7e547541-a37b-c20d-5f74-c902a74868b9}">
           <p14:sldIdLst>
             <p14:sldId id="256"/>
           </p14:sldIdLst>
         </p14:section>
-        <p14:section name="요약" id="{2f09740e-4862-db1d-5010-ad0e97f44eeb}">
+        <p14:section name="요약" id="{26a0530c-a904-bf1d-eba8-2f3eae0d01f0}">
           <p14:sldIdLst>
             <p14:sldId id="257"/>
           </p14:sldIdLst>
         </p14:section>
-        <p14:section name="검토" id="{8cf807a2-6bd4-3c94-a7b0-4deb10f30a4d}">
+        <p14:section name="검토" id="{cfdc8497-4f98-08fd-fe2d-7ed90ab3c945}">
           <p14:sldIdLst>
             <p14:sldId id="258"/>
           </p14:sldIdLst>
         </p14:section>
-        <p14:section name="01 Drawing" id="{d58bef77-0a78-7e9e-5f09-cdcb3be36595}">
+        <p14:section name="01 Drawing" id="{97a6d495-6632-7c3a-c116-834f0a93b5be}">
           <p14:sldIdLst>
             <p14:sldId id="259"/>
           </p14:sldIdLst>
         </p14:section>
-        <p14:section name="02 Scan" id="{b27492fa-80dc-d8ef-dbd5-f88947bd746c}">
+        <p14:section name="02 Scan" id="{d4f38992-d195-a9fa-d9ec-ec79c5d4523c}">
           <p14:sldIdLst>
             <p14:sldId id="260"/>
           </p14:sldIdLst>
         </p14:section>
-        <p14:section name="03 Wall" id="{814844ea-c57c-0036-5de8-5bdb1674b8bd}">
+        <p14:section name="03 Wall" id="{07eb5e86-e202-bae4-8591-3beba775cf3f}">
           <p14:sldIdLst>
             <p14:sldId id="261"/>
           </p14:sldIdLst>
         </p14:section>
-        <p14:section name="04 Facade" id="{ea868a10-f850-bdb8-0574-d6c36d4c6881}">
+        <p14:section name="04 Facade" id="{8895220a-406d-f621-078d-45895cda1b3d}">
           <p14:sldIdLst>
             <p14:sldId id="262"/>
           </p14:sldIdLst>
         </p14:section>
-        <p14:section name="05 Archive" id="{51d44acc-2dee-7ff2-7a32-e3559f3bfb66}">
+        <p14:section name="05 Archive" id="{14d488d4-7994-9646-f4c5-542902296132}">
           <p14:sldIdLst>
             <p14:sldId id="263"/>
           </p14:sldIdLst>
         </p14:section>
-        <p14:section name="운영" id="{b6394147-4f6c-01cb-0b8a-59ac14483fca}">
+        <p14:section name="운영" id="{f895c41b-770a-097c-f945-0036cafa1622}">
           <p14:sldIdLst>
             <p14:sldId id="264"/>
           </p14:sldIdLst>
         </p14:section>
-        <p14:section name="다음 단계" id="{41597983-c31e-30e9-1765-23cb5365c690}">
+        <p14:section name="다음 단계" id="{8744fe38-25a4-2f70-d746-6aed07e01bcb}">
           <p14:sldIdLst>
             <p14:sldId id="265"/>
           </p14:sldIdLst>
@@ -5978,18 +5978,54 @@
       </p:sp>
       <p:sp>
         <p:nvSpPr>
-          <p:cNvPr id="5" name="original"/>
+          <p:cNvPr id="5" name="Text 3"/>
+          <p:cNvSpPr txBox="1"/>
+          <p:nvPr/>
+        </p:nvSpPr>
+        <p:spPr>
+          <a:xfrm>
+            <a:off x="548640" y="1965960"/>
+            <a:ext cx="1828800" cy="365760"/>
+          </a:xfrm>
+          <a:prstGeom prst="rect">
+            <a:avLst/>
+          </a:prstGeom>
+          <a:noFill/>
+          <a:ln/>
+        </p:spPr>
+        <p:txBody>
+          <a:bodyPr wrap="square" lIns="0" tIns="0" rIns="0" bIns="0" rtlCol="0" anchor="ctr"/>
+          <a:lstStyle/>
+          <a:p>
+            <a:pPr indent="0" marL="0">
+              <a:buNone/>
+            </a:pPr>
+            <a:r>
+              <a:rPr lang="en-US" sz="1700" b="1" dirty="0">
+                <a:solidFill>
+                  <a:srgbClr val="617287"/>
+                </a:solidFill>
+              </a:rPr>
+              <a:t>원안</a:t>
+            </a:r>
+            <a:endParaRPr lang="en-US" sz="1700" dirty="0"/>
+          </a:p>
+        </p:txBody>
+      </p:sp>
+      <p:sp>
+        <p:nvSpPr>
+          <p:cNvPr id="6" name="original"/>
           <p:cNvSpPr/>
           <p:nvPr/>
         </p:nvSpPr>
         <p:spPr>
           <a:xfrm>
-            <a:off x="548640" y="1965960"/>
-            <a:ext cx="4206240" cy="3794760"/>
+            <a:off x="548640" y="4645152"/>
+            <a:ext cx="4206240" cy="1115568"/>
           </a:xfrm>
           <a:prstGeom prst="roundRect">
             <a:avLst>
-              <a:gd name="adj" fmla="val 2892"/>
+              <a:gd name="adj" fmla="val 9836"/>
             </a:avLst>
           </a:prstGeom>
           <a:solidFill>
@@ -6005,50 +6041,14 @@
       </p:sp>
       <p:sp>
         <p:nvSpPr>
-          <p:cNvPr id="6" name="Text 4"/>
-          <p:cNvSpPr txBox="1"/>
-          <p:nvPr/>
-        </p:nvSpPr>
-        <p:spPr>
-          <a:xfrm>
-            <a:off x="822960" y="2121408"/>
-            <a:ext cx="1828800" cy="365760"/>
-          </a:xfrm>
-          <a:prstGeom prst="rect">
-            <a:avLst/>
-          </a:prstGeom>
-          <a:noFill/>
-          <a:ln/>
-        </p:spPr>
-        <p:txBody>
-          <a:bodyPr wrap="square" lIns="0" tIns="0" rIns="0" bIns="0" rtlCol="0" anchor="ctr"/>
-          <a:lstStyle/>
-          <a:p>
-            <a:pPr indent="0" marL="0">
-              <a:buNone/>
-            </a:pPr>
-            <a:r>
-              <a:rPr lang="en-US" sz="1700" b="1" dirty="0">
-                <a:solidFill>
-                  <a:srgbClr val="617287"/>
-                </a:solidFill>
-              </a:rPr>
-              <a:t>원안</a:t>
-            </a:r>
-            <a:endParaRPr lang="en-US" sz="1700" dirty="0"/>
-          </a:p>
-        </p:txBody>
-      </p:sp>
-      <p:sp>
-        <p:nvSpPr>
           <p:cNvPr id="7" name="chip-1-1"/>
           <p:cNvSpPr txBox="1"/>
           <p:nvPr/>
         </p:nvSpPr>
         <p:spPr>
           <a:xfrm>
-            <a:off x="822960" y="2651760"/>
-            <a:ext cx="566928" cy="292608"/>
+            <a:off x="685800" y="4773168"/>
+            <a:ext cx="502920" cy="292608"/>
           </a:xfrm>
           <a:prstGeom prst="roundRect">
             <a:avLst>
@@ -6087,8 +6087,8 @@
         </p:nvSpPr>
         <p:spPr>
           <a:xfrm>
-            <a:off x="1508760" y="2615184"/>
-            <a:ext cx="3108960" cy="365760"/>
+            <a:off x="1280160" y="4718304"/>
+            <a:ext cx="3383280" cy="457200"/>
           </a:xfrm>
           <a:prstGeom prst="rect">
             <a:avLst/>
@@ -6104,63 +6104,38 @@
               <a:buNone/>
             </a:pPr>
             <a:r>
-              <a:rPr lang="en-US" sz="1500" b="1" dirty="0">
+              <a:rPr lang="en-US" sz="1100" b="1" dirty="0">
                 <a:solidFill>
                   <a:srgbClr val="16243A"/>
                 </a:solidFill>
               </a:rPr>
-              <a:t>체험 방식</a:t>
-            </a:r>
-            <a:endParaRPr lang="en-US" sz="1500" dirty="0"/>
-          </a:p>
-        </p:txBody>
-      </p:sp>
-      <p:sp>
-        <p:nvSpPr>
-          <p:cNvPr id="9" name="Text 7"/>
-          <p:cNvSpPr txBox="1"/>
-          <p:nvPr/>
-        </p:nvSpPr>
-        <p:spPr>
-          <a:xfrm>
-            <a:off x="822960" y="3063240"/>
-            <a:ext cx="3703320" cy="960120"/>
-          </a:xfrm>
-          <a:prstGeom prst="rect">
-            <a:avLst/>
-          </a:prstGeom>
-          <a:noFill/>
-          <a:ln/>
-        </p:spPr>
-        <p:txBody>
-          <a:bodyPr wrap="square" lIns="0" tIns="0" rIns="0" bIns="0" rtlCol="0" anchor="t"/>
-          <a:lstStyle/>
-          <a:p>
+              <a:t>체험 방식  </a:t>
+            </a:r>
             <a:pPr indent="0" marL="0">
               <a:buNone/>
             </a:pPr>
             <a:r>
-              <a:rPr lang="en-US" sz="1300" dirty="0">
+              <a:rPr lang="en-US" sz="1100" dirty="0">
                 <a:solidFill>
                   <a:srgbClr val="617287"/>
                 </a:solidFill>
               </a:rPr>
-              <a:t>종이 + 크레용 드로잉 / 점토를 활용한 유료 체험 옵션</a:t>
-            </a:r>
-            <a:endParaRPr lang="en-US" sz="1300" dirty="0"/>
-          </a:p>
-        </p:txBody>
-      </p:sp>
-      <p:sp>
-        <p:nvSpPr>
-          <p:cNvPr id="10" name="chip-1-2"/>
-          <p:cNvSpPr txBox="1"/>
-          <p:nvPr/>
-        </p:nvSpPr>
-        <p:spPr>
-          <a:xfrm>
-            <a:off x="822960" y="4160520"/>
-            <a:ext cx="566928" cy="292608"/>
+              <a:t>종이 + 크레용 / 점토 유료 옵션</a:t>
+            </a:r>
+            <a:endParaRPr lang="en-US" sz="1100" dirty="0"/>
+          </a:p>
+        </p:txBody>
+      </p:sp>
+      <p:sp>
+        <p:nvSpPr>
+          <p:cNvPr id="9" name="chip-1-2"/>
+          <p:cNvSpPr txBox="1"/>
+          <p:nvPr/>
+        </p:nvSpPr>
+        <p:spPr>
+          <a:xfrm>
+            <a:off x="685800" y="5276088"/>
+            <a:ext cx="502920" cy="292608"/>
           </a:xfrm>
           <a:prstGeom prst="roundRect">
             <a:avLst>
@@ -6193,79 +6168,54 @@
       </p:sp>
       <p:sp>
         <p:nvSpPr>
+          <p:cNvPr id="10" name="Text 8"/>
+          <p:cNvSpPr txBox="1"/>
+          <p:nvPr/>
+        </p:nvSpPr>
+        <p:spPr>
+          <a:xfrm>
+            <a:off x="1280160" y="5221224"/>
+            <a:ext cx="3383280" cy="457200"/>
+          </a:xfrm>
+          <a:prstGeom prst="rect">
+            <a:avLst/>
+          </a:prstGeom>
+          <a:noFill/>
+          <a:ln/>
+        </p:spPr>
+        <p:txBody>
+          <a:bodyPr wrap="square" lIns="0" tIns="0" rIns="0" bIns="0" rtlCol="0" anchor="ctr"/>
+          <a:lstStyle/>
+          <a:p>
+            <a:pPr indent="0" marL="0">
+              <a:buNone/>
+            </a:pPr>
+            <a:r>
+              <a:rPr lang="en-US" sz="1100" b="1" dirty="0">
+                <a:solidFill>
+                  <a:srgbClr val="16243A"/>
+                </a:solidFill>
+              </a:rPr>
+              <a:t>Draw Me! 도안  </a:t>
+            </a:r>
+            <a:pPr indent="0" marL="0">
+              <a:buNone/>
+            </a:pPr>
+            <a:r>
+              <a:rPr lang="en-US" sz="1100" dirty="0">
+                <a:solidFill>
+                  <a:srgbClr val="617287"/>
+                </a:solidFill>
+              </a:rPr>
+              <a:t>A4 가이드 도안 · A안 얼굴 · 몸통 · 팔 · 다리 / B안 얼굴만</a:t>
+            </a:r>
+            <a:endParaRPr lang="en-US" sz="1100" dirty="0"/>
+          </a:p>
+        </p:txBody>
+      </p:sp>
+      <p:sp>
+        <p:nvSpPr>
           <p:cNvPr id="11" name="Text 9"/>
-          <p:cNvSpPr txBox="1"/>
-          <p:nvPr/>
-        </p:nvSpPr>
-        <p:spPr>
-          <a:xfrm>
-            <a:off x="1508760" y="4123944"/>
-            <a:ext cx="3108960" cy="365760"/>
-          </a:xfrm>
-          <a:prstGeom prst="rect">
-            <a:avLst/>
-          </a:prstGeom>
-          <a:noFill/>
-          <a:ln/>
-        </p:spPr>
-        <p:txBody>
-          <a:bodyPr wrap="square" lIns="0" tIns="0" rIns="0" bIns="0" rtlCol="0" anchor="ctr"/>
-          <a:lstStyle/>
-          <a:p>
-            <a:pPr indent="0" marL="0">
-              <a:buNone/>
-            </a:pPr>
-            <a:r>
-              <a:rPr lang="en-US" sz="1500" b="1" dirty="0">
-                <a:solidFill>
-                  <a:srgbClr val="16243A"/>
-                </a:solidFill>
-              </a:rPr>
-              <a:t>Draw Me! 도안</a:t>
-            </a:r>
-            <a:endParaRPr lang="en-US" sz="1500" dirty="0"/>
-          </a:p>
-        </p:txBody>
-      </p:sp>
-      <p:sp>
-        <p:nvSpPr>
-          <p:cNvPr id="12" name="Text 10"/>
-          <p:cNvSpPr txBox="1"/>
-          <p:nvPr/>
-        </p:nvSpPr>
-        <p:spPr>
-          <a:xfrm>
-            <a:off x="822960" y="4572000"/>
-            <a:ext cx="3703320" cy="960120"/>
-          </a:xfrm>
-          <a:prstGeom prst="rect">
-            <a:avLst/>
-          </a:prstGeom>
-          <a:noFill/>
-          <a:ln/>
-        </p:spPr>
-        <p:txBody>
-          <a:bodyPr wrap="square" lIns="0" tIns="0" rIns="0" bIns="0" rtlCol="0" anchor="t"/>
-          <a:lstStyle/>
-          <a:p>
-            <a:pPr indent="0" marL="0">
-              <a:buNone/>
-            </a:pPr>
-            <a:r>
-              <a:rPr lang="en-US" sz="1300" dirty="0">
-                <a:solidFill>
-                  <a:srgbClr val="617287"/>
-                </a:solidFill>
-              </a:rPr>
-              <a:t>A4 가이드 도안 · A안 얼굴 · 몸통 · 팔 · 다리 영역 가이드 · B안 얼굴만 그리는 심플 옵션</a:t>
-            </a:r>
-            <a:endParaRPr lang="en-US" sz="1300" dirty="0"/>
-          </a:p>
-        </p:txBody>
-      </p:sp>
-      <p:sp>
-        <p:nvSpPr>
-          <p:cNvPr id="13" name="Text 11"/>
           <p:cNvSpPr txBox="1"/>
           <p:nvPr/>
         </p:nvSpPr>
@@ -6301,7 +6251,7 @@
       </p:sp>
       <p:sp>
         <p:nvSpPr>
-          <p:cNvPr id="14" name="prop-0"/>
+          <p:cNvPr id="12" name="prop-0"/>
           <p:cNvSpPr/>
           <p:nvPr/>
         </p:nvSpPr>
@@ -6328,7 +6278,7 @@
       </p:sp>
       <p:sp>
         <p:nvSpPr>
-          <p:cNvPr id="15" name="chip-체험"/>
+          <p:cNvPr id="13" name="chip-체험"/>
           <p:cNvSpPr txBox="1"/>
           <p:nvPr/>
         </p:nvSpPr>
@@ -6368,7 +6318,7 @@
       </p:sp>
       <p:sp>
         <p:nvSpPr>
-          <p:cNvPr id="16" name="Text 14"/>
+          <p:cNvPr id="14" name="Text 12"/>
           <p:cNvSpPr txBox="1"/>
           <p:nvPr/>
         </p:nvSpPr>
@@ -6404,7 +6354,7 @@
       </p:sp>
       <p:sp>
         <p:nvSpPr>
-          <p:cNvPr id="17" name="Text 15"/>
+          <p:cNvPr id="15" name="Text 13"/>
           <p:cNvSpPr txBox="1"/>
           <p:nvPr/>
         </p:nvSpPr>
@@ -6440,7 +6390,7 @@
       </p:sp>
       <p:sp>
         <p:nvSpPr>
-          <p:cNvPr id="18" name="prop-1"/>
+          <p:cNvPr id="16" name="prop-1"/>
           <p:cNvSpPr/>
           <p:nvPr/>
         </p:nvSpPr>
@@ -6467,7 +6417,7 @@
       </p:sp>
       <p:sp>
         <p:nvSpPr>
-          <p:cNvPr id="19" name="chip-체험"/>
+          <p:cNvPr id="17" name="chip-체험"/>
           <p:cNvSpPr txBox="1"/>
           <p:nvPr/>
         </p:nvSpPr>
@@ -6507,7 +6457,7 @@
       </p:sp>
       <p:sp>
         <p:nvSpPr>
-          <p:cNvPr id="20" name="Text 18"/>
+          <p:cNvPr id="18" name="Text 16"/>
           <p:cNvSpPr txBox="1"/>
           <p:nvPr/>
         </p:nvSpPr>
@@ -6543,7 +6493,7 @@
       </p:sp>
       <p:sp>
         <p:nvSpPr>
-          <p:cNvPr id="21" name="Text 19"/>
+          <p:cNvPr id="19" name="Text 17"/>
           <p:cNvSpPr txBox="1"/>
           <p:nvPr/>
         </p:nvSpPr>
@@ -6579,7 +6529,7 @@
       </p:sp>
       <p:sp>
         <p:nvSpPr>
-          <p:cNvPr id="22" name="prop-2"/>
+          <p:cNvPr id="20" name="prop-2"/>
           <p:cNvSpPr/>
           <p:nvPr/>
         </p:nvSpPr>
@@ -6606,7 +6556,7 @@
       </p:sp>
       <p:sp>
         <p:nvSpPr>
-          <p:cNvPr id="23" name="chip-운영"/>
+          <p:cNvPr id="21" name="chip-운영"/>
           <p:cNvSpPr txBox="1"/>
           <p:nvPr/>
         </p:nvSpPr>
@@ -6646,7 +6596,7 @@
       </p:sp>
       <p:sp>
         <p:nvSpPr>
-          <p:cNvPr id="24" name="Text 22"/>
+          <p:cNvPr id="22" name="Text 20"/>
           <p:cNvSpPr txBox="1"/>
           <p:nvPr/>
         </p:nvSpPr>
@@ -6682,7 +6632,7 @@
       </p:sp>
       <p:sp>
         <p:nvSpPr>
-          <p:cNvPr id="25" name="Text 23"/>
+          <p:cNvPr id="23" name="Text 21"/>
           <p:cNvSpPr txBox="1"/>
           <p:nvPr/>
         </p:nvSpPr>
@@ -6718,7 +6668,7 @@
       </p:sp>
       <p:sp>
         <p:nvSpPr>
-          <p:cNvPr id="26" name="prop-3"/>
+          <p:cNvPr id="24" name="prop-3"/>
           <p:cNvSpPr/>
           <p:nvPr/>
         </p:nvSpPr>
@@ -6745,7 +6695,7 @@
       </p:sp>
       <p:sp>
         <p:nvSpPr>
-          <p:cNvPr id="27" name="chip-운영"/>
+          <p:cNvPr id="25" name="chip-운영"/>
           <p:cNvSpPr txBox="1"/>
           <p:nvPr/>
         </p:nvSpPr>
@@ -6785,7 +6735,7 @@
       </p:sp>
       <p:sp>
         <p:nvSpPr>
-          <p:cNvPr id="28" name="Text 26"/>
+          <p:cNvPr id="26" name="Text 24"/>
           <p:cNvSpPr txBox="1"/>
           <p:nvPr/>
         </p:nvSpPr>
@@ -6821,7 +6771,7 @@
       </p:sp>
       <p:sp>
         <p:nvSpPr>
-          <p:cNvPr id="29" name="Text 27"/>
+          <p:cNvPr id="27" name="Text 25"/>
           <p:cNvSpPr txBox="1"/>
           <p:nvPr/>
         </p:nvSpPr>
@@ -6857,7 +6807,7 @@
       </p:sp>
       <p:sp>
         <p:nvSpPr>
-          <p:cNvPr id="30" name="Text 28"/>
+          <p:cNvPr id="28" name="Text 26"/>
           <p:cNvSpPr txBox="1"/>
           <p:nvPr/>
         </p:nvSpPr>
@@ -6947,6 +6897,451 @@
           </a:p>
         </p:txBody>
       </p:sp>
+      <p:grpSp>
+        <p:nvGrpSpPr>
+          <p:cNvPr id="900" name="원안 그림"/>
+          <p:cNvGrpSpPr/>
+          <p:nvPr/>
+        </p:nvGrpSpPr>
+        <p:grpSpPr>
+          <a:xfrm>
+            <a:off x="930029" y="2331720"/>
+            <a:ext cx="3443462" cy="2212848"/>
+            <a:chOff x="6108192" y="2313432"/>
+            <a:chExt cx="5577840" cy="3584448"/>
+          </a:xfrm>
+        </p:grpSpPr>
+        <p:sp>
+          <p:nvSpPr>
+            <p:cNvPr id="901" name="Shape 18"/>
+            <p:cNvSpPr/>
+            <p:nvPr/>
+          </p:nvSpPr>
+          <p:spPr>
+            <a:xfrm>
+              <a:off x="6108192" y="2313432"/>
+              <a:ext cx="5577840" cy="3584448"/>
+            </a:xfrm>
+            <a:prstGeom prst="roundRect">
+              <a:avLst>
+                <a:gd name="adj" fmla="val 2551"/>
+              </a:avLst>
+            </a:prstGeom>
+            <a:solidFill>
+              <a:srgbClr val="EAF5F1"/>
+            </a:solidFill>
+            <a:ln w="12700">
+              <a:solidFill>
+                <a:srgbClr val="EAF5F1">
+                  <a:alpha val="0"/>
+                </a:srgbClr>
+              </a:solidFill>
+              <a:prstDash val="solid"/>
+            </a:ln>
+          </p:spPr>
+        </p:sp>
+        <p:sp>
+          <p:nvSpPr>
+            <p:cNvPr id="902" name="Shape 19"/>
+            <p:cNvSpPr/>
+            <p:nvPr/>
+          </p:nvSpPr>
+          <p:spPr>
+            <a:xfrm rot="-300000">
+              <a:off x="6839712" y="2615184"/>
+              <a:ext cx="2176272" cy="3008376"/>
+            </a:xfrm>
+            <a:prstGeom prst="roundRect">
+              <a:avLst>
+                <a:gd name="adj" fmla="val 4202"/>
+              </a:avLst>
+            </a:prstGeom>
+            <a:solidFill>
+              <a:srgbClr val="FFFFFF"/>
+            </a:solidFill>
+            <a:ln w="12700">
+              <a:solidFill>
+                <a:srgbClr val="D3E1DC"/>
+              </a:solidFill>
+              <a:prstDash val="solid"/>
+            </a:ln>
+          </p:spPr>
+        </p:sp>
+        <p:sp>
+          <p:nvSpPr>
+            <p:cNvPr id="903" name="Text 20"/>
+            <p:cNvSpPr/>
+            <p:nvPr/>
+          </p:nvSpPr>
+          <p:spPr>
+            <a:xfrm>
+              <a:off x="7123176" y="2862072"/>
+              <a:ext cx="1645920" cy="320040"/>
+            </a:xfrm>
+            <a:prstGeom prst="rect">
+              <a:avLst/>
+            </a:prstGeom>
+            <a:noFill/>
+            <a:ln/>
+          </p:spPr>
+          <p:txBody>
+            <a:bodyPr wrap="square" lIns="0" tIns="0" rIns="0" bIns="0" rtlCol="0" anchor="ctr">
+              <a:normAutofit/>
+            </a:bodyPr>
+            <a:lstStyle/>
+            <a:p>
+              <a:pPr indent="0" marL="0">
+                <a:buNone/>
+              </a:pPr>
+              <a:r>
+                <a:rPr lang="en-US" sz="1100" b="1" dirty="0">
+                  <a:solidFill>
+                    <a:srgbClr val="16243A"/>
+                  </a:solidFill>
+                  <a:latin typeface="Malgun Gothic" pitchFamily="34" charset="0"/>
+                  <a:ea typeface="Malgun Gothic" pitchFamily="34" charset="-122"/>
+                  <a:cs typeface="Malgun Gothic" pitchFamily="34" charset="-120"/>
+                </a:rPr>
+                <a:t>Draw Me!</a:t>
+              </a:r>
+              <a:endParaRPr lang="en-US" sz="1100" dirty="0"/>
+            </a:p>
+          </p:txBody>
+        </p:sp>
+        <p:sp>
+          <p:nvSpPr>
+            <p:cNvPr id="904" name="Shape 21"/>
+            <p:cNvSpPr/>
+            <p:nvPr/>
+          </p:nvSpPr>
+          <p:spPr>
+            <a:xfrm>
+              <a:off x="7770571" y="3392424"/>
+              <a:ext cx="594360" cy="594360"/>
+            </a:xfrm>
+            <a:prstGeom prst="ellipse">
+              <a:avLst>
+                <a:gd name="adj" fmla="val 15385"/>
+              </a:avLst>
+            </a:prstGeom>
+            <a:solidFill>
+              <a:srgbClr val="FDE6A5"/>
+            </a:solidFill>
+            <a:ln w="12700">
+              <a:solidFill>
+                <a:srgbClr val="FDE6A5">
+                  <a:alpha val="0"/>
+                </a:srgbClr>
+              </a:solidFill>
+              <a:prstDash val="solid"/>
+            </a:ln>
+          </p:spPr>
+        </p:sp>
+        <p:sp>
+          <p:nvSpPr>
+            <p:cNvPr id="905" name="Shape 22"/>
+            <p:cNvSpPr/>
+            <p:nvPr/>
+          </p:nvSpPr>
+          <p:spPr>
+            <a:xfrm rot="10800000">
+              <a:off x="7675474" y="3915461"/>
+              <a:ext cx="808330" cy="903427"/>
+            </a:xfrm>
+            <a:prstGeom prst="arc">
+              <a:avLst>
+                <a:gd name="adj" fmla="val 11312"/>
+              </a:avLst>
+            </a:prstGeom>
+            <a:solidFill>
+              <a:srgbClr val="F7DDE5"/>
+            </a:solidFill>
+            <a:ln w="12700">
+              <a:solidFill>
+                <a:srgbClr val="F7DDE5"/>
+              </a:solidFill>
+              <a:prstDash val="solid"/>
+            </a:ln>
+          </p:spPr>
+        </p:sp>
+        <p:sp>
+          <p:nvSpPr>
+            <p:cNvPr id="906" name="Shape 23"/>
+            <p:cNvSpPr/>
+            <p:nvPr/>
+          </p:nvSpPr>
+          <p:spPr>
+            <a:xfrm>
+              <a:off x="7711135" y="4176979"/>
+              <a:ext cx="653796" cy="118872"/>
+            </a:xfrm>
+            <a:prstGeom prst="line">
+              <a:avLst>
+                <a:gd name="adj" fmla="val 76923"/>
+              </a:avLst>
+            </a:prstGeom>
+            <a:solidFill>
+              <a:srgbClr val="16243A"/>
+            </a:solidFill>
+            <a:ln w="38100">
+              <a:solidFill>
+                <a:srgbClr val="16243A"/>
+              </a:solidFill>
+              <a:prstDash val="solid"/>
+            </a:ln>
+          </p:spPr>
+        </p:sp>
+        <p:sp>
+          <p:nvSpPr>
+            <p:cNvPr id="907" name="Shape 24"/>
+            <p:cNvSpPr/>
+            <p:nvPr/>
+          </p:nvSpPr>
+          <p:spPr>
+            <a:xfrm>
+              <a:off x="7782458" y="4676242"/>
+              <a:ext cx="-166421" cy="427939"/>
+            </a:xfrm>
+            <a:prstGeom prst="line">
+              <a:avLst>
+                <a:gd name="adj" fmla="val -54945"/>
+              </a:avLst>
+            </a:prstGeom>
+            <a:solidFill>
+              <a:srgbClr val="16243A"/>
+            </a:solidFill>
+            <a:ln w="38100">
+              <a:solidFill>
+                <a:srgbClr val="16243A"/>
+              </a:solidFill>
+              <a:prstDash val="solid"/>
+            </a:ln>
+          </p:spPr>
+        </p:sp>
+        <p:sp>
+          <p:nvSpPr>
+            <p:cNvPr id="908" name="Shape 25"/>
+            <p:cNvSpPr/>
+            <p:nvPr/>
+          </p:nvSpPr>
+          <p:spPr>
+            <a:xfrm>
+              <a:off x="8234172" y="4676242"/>
+              <a:ext cx="166421" cy="427939"/>
+            </a:xfrm>
+            <a:prstGeom prst="line">
+              <a:avLst>
+                <a:gd name="adj" fmla="val 54945"/>
+              </a:avLst>
+            </a:prstGeom>
+            <a:solidFill>
+              <a:srgbClr val="16243A"/>
+            </a:solidFill>
+            <a:ln w="38100">
+              <a:solidFill>
+                <a:srgbClr val="16243A"/>
+              </a:solidFill>
+              <a:prstDash val="solid"/>
+            </a:ln>
+          </p:spPr>
+        </p:sp>
+        <p:sp>
+          <p:nvSpPr>
+            <p:cNvPr id="909" name="Shape 26"/>
+            <p:cNvSpPr/>
+            <p:nvPr/>
+          </p:nvSpPr>
+          <p:spPr>
+            <a:xfrm>
+              <a:off x="7925105" y="3653942"/>
+              <a:ext cx="41605" cy="41605"/>
+            </a:xfrm>
+            <a:prstGeom prst="ellipse">
+              <a:avLst>
+                <a:gd name="adj" fmla="val 219781"/>
+              </a:avLst>
+            </a:prstGeom>
+            <a:solidFill>
+              <a:srgbClr val="16243A"/>
+            </a:solidFill>
+            <a:ln w="12700">
+              <a:solidFill>
+                <a:srgbClr val="16243A">
+                  <a:alpha val="0"/>
+                </a:srgbClr>
+              </a:solidFill>
+              <a:prstDash val="solid"/>
+            </a:ln>
+          </p:spPr>
+        </p:sp>
+        <p:sp>
+          <p:nvSpPr>
+            <p:cNvPr id="910" name="Shape 27"/>
+            <p:cNvSpPr/>
+            <p:nvPr/>
+          </p:nvSpPr>
+          <p:spPr>
+            <a:xfrm>
+              <a:off x="8127187" y="3653942"/>
+              <a:ext cx="41605" cy="41605"/>
+            </a:xfrm>
+            <a:prstGeom prst="ellipse">
+              <a:avLst>
+                <a:gd name="adj" fmla="val 219781"/>
+              </a:avLst>
+            </a:prstGeom>
+            <a:solidFill>
+              <a:srgbClr val="16243A"/>
+            </a:solidFill>
+            <a:ln w="12700">
+              <a:solidFill>
+                <a:srgbClr val="16243A">
+                  <a:alpha val="0"/>
+                </a:srgbClr>
+              </a:solidFill>
+              <a:prstDash val="solid"/>
+            </a:ln>
+          </p:spPr>
+        </p:sp>
+        <p:sp>
+          <p:nvSpPr>
+            <p:cNvPr id="911" name="Shape 28"/>
+            <p:cNvSpPr/>
+            <p:nvPr/>
+          </p:nvSpPr>
+          <p:spPr>
+            <a:xfrm rot="360000">
+              <a:off x="9262872" y="2898648"/>
+              <a:ext cx="1755648" cy="2377440"/>
+            </a:xfrm>
+            <a:prstGeom prst="roundRect">
+              <a:avLst>
+                <a:gd name="adj" fmla="val 5208"/>
+              </a:avLst>
+            </a:prstGeom>
+            <a:solidFill>
+              <a:srgbClr val="FFFFFF"/>
+            </a:solidFill>
+            <a:ln w="12700">
+              <a:solidFill>
+                <a:srgbClr val="DFE6EB"/>
+              </a:solidFill>
+              <a:prstDash val="solid"/>
+            </a:ln>
+          </p:spPr>
+        </p:sp>
+        <p:sp>
+          <p:nvSpPr>
+            <p:cNvPr id="912" name="Text 29"/>
+            <p:cNvSpPr/>
+            <p:nvPr/>
+          </p:nvSpPr>
+          <p:spPr>
+            <a:xfrm>
+              <a:off x="9619488" y="3136392"/>
+              <a:ext cx="1005840" cy="274320"/>
+            </a:xfrm>
+            <a:prstGeom prst="rect">
+              <a:avLst/>
+            </a:prstGeom>
+            <a:noFill/>
+            <a:ln/>
+          </p:spPr>
+          <p:txBody>
+            <a:bodyPr wrap="square" lIns="0" tIns="0" rIns="0" bIns="0" rtlCol="0" anchor="ctr">
+              <a:normAutofit/>
+            </a:bodyPr>
+            <a:lstStyle/>
+            <a:p>
+              <a:pPr algn="ctr" indent="0" marL="0">
+                <a:buNone/>
+              </a:pPr>
+              <a:r>
+                <a:rPr lang="en-US" sz="900" b="1" dirty="0">
+                  <a:solidFill>
+                    <a:srgbClr val="617287"/>
+                  </a:solidFill>
+                  <a:latin typeface="Malgun Gothic" pitchFamily="34" charset="0"/>
+                  <a:ea typeface="Malgun Gothic" pitchFamily="34" charset="-122"/>
+                  <a:cs typeface="Malgun Gothic" pitchFamily="34" charset="-120"/>
+                </a:rPr>
+                <a:t>FACE</a:t>
+              </a:r>
+              <a:endParaRPr lang="en-US" sz="900" dirty="0"/>
+            </a:p>
+          </p:txBody>
+        </p:sp>
+        <p:sp>
+          <p:nvSpPr>
+            <p:cNvPr id="913" name="Shape 30"/>
+            <p:cNvSpPr/>
+            <p:nvPr/>
+          </p:nvSpPr>
+          <p:spPr>
+            <a:xfrm>
+              <a:off x="9637776" y="3675888"/>
+              <a:ext cx="996696" cy="1042416"/>
+            </a:xfrm>
+            <a:prstGeom prst="ellipse">
+              <a:avLst>
+                <a:gd name="adj" fmla="val 9174"/>
+              </a:avLst>
+            </a:prstGeom>
+            <a:solidFill>
+              <a:srgbClr val="FDE6A5"/>
+            </a:solidFill>
+            <a:ln w="12700">
+              <a:solidFill>
+                <a:srgbClr val="FDE6A5">
+                  <a:alpha val="0"/>
+                </a:srgbClr>
+              </a:solidFill>
+              <a:prstDash val="solid"/>
+            </a:ln>
+          </p:spPr>
+        </p:sp>
+        <p:sp>
+          <p:nvSpPr>
+            <p:cNvPr id="914" name="Text 31"/>
+            <p:cNvSpPr/>
+            <p:nvPr/>
+          </p:nvSpPr>
+          <p:spPr>
+            <a:xfrm>
+              <a:off x="7479792" y="5550408"/>
+              <a:ext cx="2871216" cy="265176"/>
+            </a:xfrm>
+            <a:prstGeom prst="rect">
+              <a:avLst/>
+            </a:prstGeom>
+            <a:noFill/>
+            <a:ln/>
+          </p:spPr>
+          <p:txBody>
+            <a:bodyPr wrap="square" lIns="0" tIns="0" rIns="0" bIns="0" rtlCol="0" anchor="ctr">
+              <a:normAutofit/>
+            </a:bodyPr>
+            <a:lstStyle/>
+            <a:p>
+              <a:pPr algn="ctr" indent="0" marL="0">
+                <a:buNone/>
+              </a:pPr>
+              <a:r>
+                <a:rPr lang="en-US" sz="700" dirty="0">
+                  <a:solidFill>
+                    <a:srgbClr val="617287"/>
+                  </a:solidFill>
+                  <a:latin typeface="Malgun Gothic" pitchFamily="34" charset="0"/>
+                  <a:ea typeface="Malgun Gothic" pitchFamily="34" charset="-122"/>
+                  <a:cs typeface="Malgun Gothic" pitchFamily="34" charset="-120"/>
+                </a:rPr>
+                <a:t>A / B 도안 옵션</a:t>
+              </a:r>
+              <a:endParaRPr lang="en-US" sz="700" dirty="0"/>
+            </a:p>
+          </p:txBody>
+        </p:sp>
+      </p:grpSp>
     </p:spTree>
   </p:cSld>
   <p:clrMapOvr>
@@ -7086,18 +7481,54 @@
       </p:sp>
       <p:sp>
         <p:nvSpPr>
-          <p:cNvPr id="5" name="original"/>
+          <p:cNvPr id="5" name="Text 3"/>
+          <p:cNvSpPr txBox="1"/>
+          <p:nvPr/>
+        </p:nvSpPr>
+        <p:spPr>
+          <a:xfrm>
+            <a:off x="548640" y="1965960"/>
+            <a:ext cx="1828800" cy="365760"/>
+          </a:xfrm>
+          <a:prstGeom prst="rect">
+            <a:avLst/>
+          </a:prstGeom>
+          <a:noFill/>
+          <a:ln/>
+        </p:spPr>
+        <p:txBody>
+          <a:bodyPr wrap="square" lIns="0" tIns="0" rIns="0" bIns="0" rtlCol="0" anchor="ctr"/>
+          <a:lstStyle/>
+          <a:p>
+            <a:pPr indent="0" marL="0">
+              <a:buNone/>
+            </a:pPr>
+            <a:r>
+              <a:rPr lang="en-US" sz="1700" b="1" dirty="0">
+                <a:solidFill>
+                  <a:srgbClr val="617287"/>
+                </a:solidFill>
+              </a:rPr>
+              <a:t>원안</a:t>
+            </a:r>
+            <a:endParaRPr lang="en-US" sz="1700" dirty="0"/>
+          </a:p>
+        </p:txBody>
+      </p:sp>
+      <p:sp>
+        <p:nvSpPr>
+          <p:cNvPr id="6" name="original"/>
           <p:cNvSpPr/>
           <p:nvPr/>
         </p:nvSpPr>
         <p:spPr>
           <a:xfrm>
-            <a:off x="548640" y="1965960"/>
-            <a:ext cx="4206240" cy="3794760"/>
+            <a:off x="548640" y="4645152"/>
+            <a:ext cx="4206240" cy="1115568"/>
           </a:xfrm>
           <a:prstGeom prst="roundRect">
             <a:avLst>
-              <a:gd name="adj" fmla="val 2892"/>
+              <a:gd name="adj" fmla="val 9836"/>
             </a:avLst>
           </a:prstGeom>
           <a:solidFill>
@@ -7113,50 +7544,14 @@
       </p:sp>
       <p:sp>
         <p:nvSpPr>
-          <p:cNvPr id="6" name="Text 4"/>
-          <p:cNvSpPr txBox="1"/>
-          <p:nvPr/>
-        </p:nvSpPr>
-        <p:spPr>
-          <a:xfrm>
-            <a:off x="822960" y="2121408"/>
-            <a:ext cx="1828800" cy="365760"/>
-          </a:xfrm>
-          <a:prstGeom prst="rect">
-            <a:avLst/>
-          </a:prstGeom>
-          <a:noFill/>
-          <a:ln/>
-        </p:spPr>
-        <p:txBody>
-          <a:bodyPr wrap="square" lIns="0" tIns="0" rIns="0" bIns="0" rtlCol="0" anchor="ctr"/>
-          <a:lstStyle/>
-          <a:p>
-            <a:pPr indent="0" marL="0">
-              <a:buNone/>
-            </a:pPr>
-            <a:r>
-              <a:rPr lang="en-US" sz="1700" b="1" dirty="0">
-                <a:solidFill>
-                  <a:srgbClr val="617287"/>
-                </a:solidFill>
-              </a:rPr>
-              <a:t>원안</a:t>
-            </a:r>
-            <a:endParaRPr lang="en-US" sz="1700" dirty="0"/>
-          </a:p>
-        </p:txBody>
-      </p:sp>
-      <p:sp>
-        <p:nvSpPr>
           <p:cNvPr id="7" name="chip-2-1"/>
           <p:cNvSpPr txBox="1"/>
           <p:nvPr/>
         </p:nvSpPr>
         <p:spPr>
           <a:xfrm>
-            <a:off x="822960" y="2651760"/>
-            <a:ext cx="566928" cy="292608"/>
+            <a:off x="685800" y="4773168"/>
+            <a:ext cx="502920" cy="292608"/>
           </a:xfrm>
           <a:prstGeom prst="roundRect">
             <a:avLst>
@@ -7195,8 +7590,8 @@
         </p:nvSpPr>
         <p:spPr>
           <a:xfrm>
-            <a:off x="1508760" y="2615184"/>
-            <a:ext cx="3108960" cy="365760"/>
+            <a:off x="1280160" y="4718304"/>
+            <a:ext cx="3383280" cy="457200"/>
           </a:xfrm>
           <a:prstGeom prst="rect">
             <a:avLst/>
@@ -7212,63 +7607,38 @@
               <a:buNone/>
             </a:pPr>
             <a:r>
-              <a:rPr lang="en-US" sz="1500" b="1" dirty="0">
+              <a:rPr lang="en-US" sz="1100" b="1" dirty="0">
                 <a:solidFill>
                   <a:srgbClr val="16243A"/>
                 </a:solidFill>
               </a:rPr>
-              <a:t>스캔 · 캐릭터 변환</a:t>
-            </a:r>
-            <a:endParaRPr lang="en-US" sz="1500" dirty="0"/>
-          </a:p>
-        </p:txBody>
-      </p:sp>
-      <p:sp>
-        <p:nvSpPr>
-          <p:cNvPr id="9" name="Text 7"/>
-          <p:cNvSpPr txBox="1"/>
-          <p:nvPr/>
-        </p:nvSpPr>
-        <p:spPr>
-          <a:xfrm>
-            <a:off x="822960" y="3063240"/>
-            <a:ext cx="3703320" cy="960120"/>
-          </a:xfrm>
-          <a:prstGeom prst="rect">
-            <a:avLst/>
-          </a:prstGeom>
-          <a:noFill/>
-          <a:ln/>
-        </p:spPr>
-        <p:txBody>
-          <a:bodyPr wrap="square" lIns="0" tIns="0" rIns="0" bIns="0" rtlCol="0" anchor="t"/>
-          <a:lstStyle/>
-          <a:p>
+              <a:t>스캔 · 캐릭터 변환  </a:t>
+            </a:r>
             <a:pPr indent="0" marL="0">
               <a:buNone/>
             </a:pPr>
             <a:r>
-              <a:rPr lang="en-US" sz="1300" dirty="0">
+              <a:rPr lang="en-US" sz="1100" dirty="0">
                 <a:solidFill>
                   <a:srgbClr val="617287"/>
                 </a:solidFill>
               </a:rPr>
-              <a:t>완성된 그림을 스캔하여 2D 또는 3D 캐릭터로 변환</a:t>
-            </a:r>
-            <a:endParaRPr lang="en-US" sz="1300" dirty="0"/>
-          </a:p>
-        </p:txBody>
-      </p:sp>
-      <p:sp>
-        <p:nvSpPr>
-          <p:cNvPr id="10" name="chip-2-2"/>
-          <p:cNvSpPr txBox="1"/>
-          <p:nvPr/>
-        </p:nvSpPr>
-        <p:spPr>
-          <a:xfrm>
-            <a:off x="822960" y="4160520"/>
-            <a:ext cx="566928" cy="292608"/>
+              <a:t>그림을 스캔해 2D 또는 3D 캐릭터로 변환</a:t>
+            </a:r>
+            <a:endParaRPr lang="en-US" sz="1100" dirty="0"/>
+          </a:p>
+        </p:txBody>
+      </p:sp>
+      <p:sp>
+        <p:nvSpPr>
+          <p:cNvPr id="9" name="chip-2-2"/>
+          <p:cNvSpPr txBox="1"/>
+          <p:nvPr/>
+        </p:nvSpPr>
+        <p:spPr>
+          <a:xfrm>
+            <a:off x="685800" y="5276088"/>
+            <a:ext cx="502920" cy="292608"/>
           </a:xfrm>
           <a:prstGeom prst="roundRect">
             <a:avLst>
@@ -7301,79 +7671,54 @@
       </p:sp>
       <p:sp>
         <p:nvSpPr>
+          <p:cNvPr id="10" name="Text 8"/>
+          <p:cNvSpPr txBox="1"/>
+          <p:nvPr/>
+        </p:nvSpPr>
+        <p:spPr>
+          <a:xfrm>
+            <a:off x="1280160" y="5221224"/>
+            <a:ext cx="3383280" cy="457200"/>
+          </a:xfrm>
+          <a:prstGeom prst="rect">
+            <a:avLst/>
+          </a:prstGeom>
+          <a:noFill/>
+          <a:ln/>
+        </p:spPr>
+        <p:txBody>
+          <a:bodyPr wrap="square" lIns="0" tIns="0" rIns="0" bIns="0" rtlCol="0" anchor="ctr"/>
+          <a:lstStyle/>
+          <a:p>
+            <a:pPr indent="0" marL="0">
+              <a:buNone/>
+            </a:pPr>
+            <a:r>
+              <a:rPr lang="en-US" sz="1100" b="1" dirty="0">
+                <a:solidFill>
+                  <a:srgbClr val="16243A"/>
+                </a:solidFill>
+              </a:rPr>
+              <a:t>+ α 표정 커스터마이징  </a:t>
+            </a:r>
+            <a:pPr indent="0" marL="0">
+              <a:buNone/>
+            </a:pPr>
+            <a:r>
+              <a:rPr lang="en-US" sz="1100" dirty="0">
+                <a:solidFill>
+                  <a:srgbClr val="617287"/>
+                </a:solidFill>
+              </a:rPr>
+              <a:t>터치 모니터에서 눈 · 코 · 입 선택 · 보정 검토</a:t>
+            </a:r>
+            <a:endParaRPr lang="en-US" sz="1100" dirty="0"/>
+          </a:p>
+        </p:txBody>
+      </p:sp>
+      <p:sp>
+        <p:nvSpPr>
           <p:cNvPr id="11" name="Text 9"/>
-          <p:cNvSpPr txBox="1"/>
-          <p:nvPr/>
-        </p:nvSpPr>
-        <p:spPr>
-          <a:xfrm>
-            <a:off x="1508760" y="4123944"/>
-            <a:ext cx="3108960" cy="365760"/>
-          </a:xfrm>
-          <a:prstGeom prst="rect">
-            <a:avLst/>
-          </a:prstGeom>
-          <a:noFill/>
-          <a:ln/>
-        </p:spPr>
-        <p:txBody>
-          <a:bodyPr wrap="square" lIns="0" tIns="0" rIns="0" bIns="0" rtlCol="0" anchor="ctr"/>
-          <a:lstStyle/>
-          <a:p>
-            <a:pPr indent="0" marL="0">
-              <a:buNone/>
-            </a:pPr>
-            <a:r>
-              <a:rPr lang="en-US" sz="1500" b="1" dirty="0">
-                <a:solidFill>
-                  <a:srgbClr val="16243A"/>
-                </a:solidFill>
-              </a:rPr>
-              <a:t>+ α 표정 커스터마이징</a:t>
-            </a:r>
-            <a:endParaRPr lang="en-US" sz="1500" dirty="0"/>
-          </a:p>
-        </p:txBody>
-      </p:sp>
-      <p:sp>
-        <p:nvSpPr>
-          <p:cNvPr id="12" name="Text 10"/>
-          <p:cNvSpPr txBox="1"/>
-          <p:nvPr/>
-        </p:nvSpPr>
-        <p:spPr>
-          <a:xfrm>
-            <a:off x="822960" y="4572000"/>
-            <a:ext cx="3703320" cy="960120"/>
-          </a:xfrm>
-          <a:prstGeom prst="rect">
-            <a:avLst/>
-          </a:prstGeom>
-          <a:noFill/>
-          <a:ln/>
-        </p:spPr>
-        <p:txBody>
-          <a:bodyPr wrap="square" lIns="0" tIns="0" rIns="0" bIns="0" rtlCol="0" anchor="t"/>
-          <a:lstStyle/>
-          <a:p>
-            <a:pPr indent="0" marL="0">
-              <a:buNone/>
-            </a:pPr>
-            <a:r>
-              <a:rPr lang="en-US" sz="1300" dirty="0">
-                <a:solidFill>
-                  <a:srgbClr val="617287"/>
-                </a:solidFill>
-              </a:rPr>
-              <a:t>터치 모니터에서 눈 · 코 · 입 등 표정 요소를 선택하거나 보정하는 방식 검토</a:t>
-            </a:r>
-            <a:endParaRPr lang="en-US" sz="1300" dirty="0"/>
-          </a:p>
-        </p:txBody>
-      </p:sp>
-      <p:sp>
-        <p:nvSpPr>
-          <p:cNvPr id="13" name="Text 11"/>
           <p:cNvSpPr txBox="1"/>
           <p:nvPr/>
         </p:nvSpPr>
@@ -7409,7 +7754,7 @@
       </p:sp>
       <p:sp>
         <p:nvSpPr>
-          <p:cNvPr id="14" name="prop-0"/>
+          <p:cNvPr id="12" name="prop-0"/>
           <p:cNvSpPr/>
           <p:nvPr/>
         </p:nvSpPr>
@@ -7436,7 +7781,7 @@
       </p:sp>
       <p:sp>
         <p:nvSpPr>
-          <p:cNvPr id="15" name="chip-연출"/>
+          <p:cNvPr id="13" name="chip-연출"/>
           <p:cNvSpPr txBox="1"/>
           <p:nvPr/>
         </p:nvSpPr>
@@ -7476,7 +7821,7 @@
       </p:sp>
       <p:sp>
         <p:nvSpPr>
-          <p:cNvPr id="16" name="Text 14"/>
+          <p:cNvPr id="14" name="Text 12"/>
           <p:cNvSpPr txBox="1"/>
           <p:nvPr/>
         </p:nvSpPr>
@@ -7512,7 +7857,7 @@
       </p:sp>
       <p:sp>
         <p:nvSpPr>
-          <p:cNvPr id="17" name="Text 15"/>
+          <p:cNvPr id="15" name="Text 13"/>
           <p:cNvSpPr txBox="1"/>
           <p:nvPr/>
         </p:nvSpPr>
@@ -7548,7 +7893,7 @@
       </p:sp>
       <p:sp>
         <p:nvSpPr>
-          <p:cNvPr id="18" name="prop-1"/>
+          <p:cNvPr id="16" name="prop-1"/>
           <p:cNvSpPr/>
           <p:nvPr/>
         </p:nvSpPr>
@@ -7575,7 +7920,7 @@
       </p:sp>
       <p:sp>
         <p:nvSpPr>
-          <p:cNvPr id="19" name="chip-체험"/>
+          <p:cNvPr id="17" name="chip-체험"/>
           <p:cNvSpPr txBox="1"/>
           <p:nvPr/>
         </p:nvSpPr>
@@ -7615,7 +7960,7 @@
       </p:sp>
       <p:sp>
         <p:nvSpPr>
-          <p:cNvPr id="20" name="Text 18"/>
+          <p:cNvPr id="18" name="Text 16"/>
           <p:cNvSpPr txBox="1"/>
           <p:nvPr/>
         </p:nvSpPr>
@@ -7651,7 +7996,7 @@
       </p:sp>
       <p:sp>
         <p:nvSpPr>
-          <p:cNvPr id="21" name="Text 19"/>
+          <p:cNvPr id="19" name="Text 17"/>
           <p:cNvSpPr txBox="1"/>
           <p:nvPr/>
         </p:nvSpPr>
@@ -7687,7 +8032,7 @@
       </p:sp>
       <p:sp>
         <p:nvSpPr>
-          <p:cNvPr id="22" name="prop-2"/>
+          <p:cNvPr id="20" name="prop-2"/>
           <p:cNvSpPr/>
           <p:nvPr/>
         </p:nvSpPr>
@@ -7714,7 +8059,7 @@
       </p:sp>
       <p:sp>
         <p:nvSpPr>
-          <p:cNvPr id="23" name="chip-운영"/>
+          <p:cNvPr id="21" name="chip-운영"/>
           <p:cNvSpPr txBox="1"/>
           <p:nvPr/>
         </p:nvSpPr>
@@ -7754,7 +8099,7 @@
       </p:sp>
       <p:sp>
         <p:nvSpPr>
-          <p:cNvPr id="24" name="Text 22"/>
+          <p:cNvPr id="22" name="Text 20"/>
           <p:cNvSpPr txBox="1"/>
           <p:nvPr/>
         </p:nvSpPr>
@@ -7790,7 +8135,7 @@
       </p:sp>
       <p:sp>
         <p:nvSpPr>
-          <p:cNvPr id="25" name="Text 23"/>
+          <p:cNvPr id="23" name="Text 21"/>
           <p:cNvSpPr txBox="1"/>
           <p:nvPr/>
         </p:nvSpPr>
@@ -7826,7 +8171,7 @@
       </p:sp>
       <p:sp>
         <p:nvSpPr>
-          <p:cNvPr id="26" name="prop-3"/>
+          <p:cNvPr id="24" name="prop-3"/>
           <p:cNvSpPr/>
           <p:nvPr/>
         </p:nvSpPr>
@@ -7853,7 +8198,7 @@
       </p:sp>
       <p:sp>
         <p:nvSpPr>
-          <p:cNvPr id="27" name="chip-연출"/>
+          <p:cNvPr id="25" name="chip-연출"/>
           <p:cNvSpPr txBox="1"/>
           <p:nvPr/>
         </p:nvSpPr>
@@ -7893,7 +8238,7 @@
       </p:sp>
       <p:sp>
         <p:nvSpPr>
-          <p:cNvPr id="28" name="Text 26"/>
+          <p:cNvPr id="26" name="Text 24"/>
           <p:cNvSpPr txBox="1"/>
           <p:nvPr/>
         </p:nvSpPr>
@@ -7929,7 +8274,7 @@
       </p:sp>
       <p:sp>
         <p:nvSpPr>
-          <p:cNvPr id="29" name="Text 27"/>
+          <p:cNvPr id="27" name="Text 25"/>
           <p:cNvSpPr txBox="1"/>
           <p:nvPr/>
         </p:nvSpPr>
@@ -7965,7 +8310,7 @@
       </p:sp>
       <p:sp>
         <p:nvSpPr>
-          <p:cNvPr id="30" name="Text 28"/>
+          <p:cNvPr id="28" name="Text 26"/>
           <p:cNvSpPr txBox="1"/>
           <p:nvPr/>
         </p:nvSpPr>
@@ -8055,6 +8400,636 @@
           </a:p>
         </p:txBody>
       </p:sp>
+      <p:grpSp>
+        <p:nvGrpSpPr>
+          <p:cNvPr id="900" name="원안 그림"/>
+          <p:cNvGrpSpPr/>
+          <p:nvPr/>
+        </p:nvGrpSpPr>
+        <p:grpSpPr>
+          <a:xfrm>
+            <a:off x="876199" y="2331720"/>
+            <a:ext cx="3551122" cy="2212848"/>
+            <a:chOff x="6144768" y="2331720"/>
+            <a:chExt cx="5532120" cy="3447288"/>
+          </a:xfrm>
+        </p:grpSpPr>
+        <p:sp>
+          <p:nvSpPr>
+            <p:cNvPr id="901" name="Shape 18"/>
+            <p:cNvSpPr/>
+            <p:nvPr/>
+          </p:nvSpPr>
+          <p:spPr>
+            <a:xfrm>
+              <a:off x="6144768" y="2331720"/>
+              <a:ext cx="5532120" cy="3447288"/>
+            </a:xfrm>
+            <a:prstGeom prst="roundRect">
+              <a:avLst>
+                <a:gd name="adj" fmla="val 2653"/>
+              </a:avLst>
+            </a:prstGeom>
+            <a:solidFill>
+              <a:srgbClr val="EAF1F8"/>
+            </a:solidFill>
+            <a:ln w="12700">
+              <a:solidFill>
+                <a:srgbClr val="EAF1F8">
+                  <a:alpha val="0"/>
+                </a:srgbClr>
+              </a:solidFill>
+              <a:prstDash val="solid"/>
+            </a:ln>
+          </p:spPr>
+        </p:sp>
+        <p:sp>
+          <p:nvSpPr>
+            <p:cNvPr id="902" name="Shape 19"/>
+            <p:cNvSpPr/>
+            <p:nvPr/>
+          </p:nvSpPr>
+          <p:spPr>
+            <a:xfrm>
+              <a:off x="6455664" y="2926080"/>
+              <a:ext cx="1554480" cy="2139696"/>
+            </a:xfrm>
+            <a:prstGeom prst="roundRect">
+              <a:avLst>
+                <a:gd name="adj" fmla="val 5882"/>
+              </a:avLst>
+            </a:prstGeom>
+            <a:solidFill>
+              <a:srgbClr val="FFFFFF"/>
+            </a:solidFill>
+            <a:ln w="12700">
+              <a:solidFill>
+                <a:srgbClr val="DFE6EB"/>
+              </a:solidFill>
+              <a:prstDash val="solid"/>
+            </a:ln>
+          </p:spPr>
+        </p:sp>
+        <p:sp>
+          <p:nvSpPr>
+            <p:cNvPr id="903" name="Shape 20"/>
+            <p:cNvSpPr/>
+            <p:nvPr/>
+          </p:nvSpPr>
+          <p:spPr>
+            <a:xfrm>
+              <a:off x="6926031" y="3337560"/>
+              <a:ext cx="361188" cy="361188"/>
+            </a:xfrm>
+            <a:prstGeom prst="ellipse">
+              <a:avLst>
+                <a:gd name="adj" fmla="val 25316"/>
+              </a:avLst>
+            </a:prstGeom>
+            <a:solidFill>
+              <a:srgbClr val="FDE6A5"/>
+            </a:solidFill>
+            <a:ln w="12700">
+              <a:solidFill>
+                <a:srgbClr val="FDE6A5">
+                  <a:alpha val="0"/>
+                </a:srgbClr>
+              </a:solidFill>
+              <a:prstDash val="solid"/>
+            </a:ln>
+          </p:spPr>
+        </p:sp>
+        <p:sp>
+          <p:nvSpPr>
+            <p:cNvPr id="904" name="Shape 21"/>
+            <p:cNvSpPr/>
+            <p:nvPr/>
+          </p:nvSpPr>
+          <p:spPr>
+            <a:xfrm rot="10800000">
+              <a:off x="6868241" y="3655405"/>
+              <a:ext cx="491216" cy="549006"/>
+            </a:xfrm>
+            <a:prstGeom prst="arc">
+              <a:avLst>
+                <a:gd name="adj" fmla="val 18615"/>
+              </a:avLst>
+            </a:prstGeom>
+            <a:solidFill>
+              <a:srgbClr val="F7DDE5"/>
+            </a:solidFill>
+            <a:ln w="12700">
+              <a:solidFill>
+                <a:srgbClr val="F7DDE5"/>
+              </a:solidFill>
+              <a:prstDash val="solid"/>
+            </a:ln>
+          </p:spPr>
+        </p:sp>
+        <p:sp>
+          <p:nvSpPr>
+            <p:cNvPr id="905" name="Shape 22"/>
+            <p:cNvSpPr/>
+            <p:nvPr/>
+          </p:nvSpPr>
+          <p:spPr>
+            <a:xfrm>
+              <a:off x="6889913" y="3814328"/>
+              <a:ext cx="397307" cy="72238"/>
+            </a:xfrm>
+            <a:prstGeom prst="line">
+              <a:avLst>
+                <a:gd name="adj" fmla="val 126582"/>
+              </a:avLst>
+            </a:prstGeom>
+            <a:solidFill>
+              <a:srgbClr val="16243A"/>
+            </a:solidFill>
+            <a:ln w="38100">
+              <a:solidFill>
+                <a:srgbClr val="16243A"/>
+              </a:solidFill>
+              <a:prstDash val="solid"/>
+            </a:ln>
+          </p:spPr>
+        </p:sp>
+        <p:sp>
+          <p:nvSpPr>
+            <p:cNvPr id="906" name="Shape 23"/>
+            <p:cNvSpPr/>
+            <p:nvPr/>
+          </p:nvSpPr>
+          <p:spPr>
+            <a:xfrm>
+              <a:off x="6933255" y="4117726"/>
+              <a:ext cx="-101133" cy="260055"/>
+            </a:xfrm>
+            <a:prstGeom prst="line">
+              <a:avLst>
+                <a:gd name="adj" fmla="val -90416"/>
+              </a:avLst>
+            </a:prstGeom>
+            <a:solidFill>
+              <a:srgbClr val="16243A"/>
+            </a:solidFill>
+            <a:ln w="38100">
+              <a:solidFill>
+                <a:srgbClr val="16243A"/>
+              </a:solidFill>
+              <a:prstDash val="solid"/>
+            </a:ln>
+          </p:spPr>
+        </p:sp>
+        <p:sp>
+          <p:nvSpPr>
+            <p:cNvPr id="907" name="Shape 24"/>
+            <p:cNvSpPr/>
+            <p:nvPr/>
+          </p:nvSpPr>
+          <p:spPr>
+            <a:xfrm>
+              <a:off x="7207758" y="4117726"/>
+              <a:ext cx="101133" cy="260055"/>
+            </a:xfrm>
+            <a:prstGeom prst="line">
+              <a:avLst>
+                <a:gd name="adj" fmla="val 90416"/>
+              </a:avLst>
+            </a:prstGeom>
+            <a:solidFill>
+              <a:srgbClr val="16243A"/>
+            </a:solidFill>
+            <a:ln w="38100">
+              <a:solidFill>
+                <a:srgbClr val="16243A"/>
+              </a:solidFill>
+              <a:prstDash val="solid"/>
+            </a:ln>
+          </p:spPr>
+        </p:sp>
+        <p:sp>
+          <p:nvSpPr>
+            <p:cNvPr id="908" name="Shape 25"/>
+            <p:cNvSpPr/>
+            <p:nvPr/>
+          </p:nvSpPr>
+          <p:spPr>
+            <a:xfrm>
+              <a:off x="7019940" y="3496483"/>
+              <a:ext cx="25283" cy="25283"/>
+            </a:xfrm>
+            <a:prstGeom prst="ellipse">
+              <a:avLst>
+                <a:gd name="adj" fmla="val 361666"/>
+              </a:avLst>
+            </a:prstGeom>
+            <a:solidFill>
+              <a:srgbClr val="16243A"/>
+            </a:solidFill>
+            <a:ln w="12700">
+              <a:solidFill>
+                <a:srgbClr val="16243A">
+                  <a:alpha val="0"/>
+                </a:srgbClr>
+              </a:solidFill>
+              <a:prstDash val="solid"/>
+            </a:ln>
+          </p:spPr>
+        </p:sp>
+        <p:sp>
+          <p:nvSpPr>
+            <p:cNvPr id="909" name="Shape 26"/>
+            <p:cNvSpPr/>
+            <p:nvPr/>
+          </p:nvSpPr>
+          <p:spPr>
+            <a:xfrm>
+              <a:off x="7142744" y="3496483"/>
+              <a:ext cx="25283" cy="25283"/>
+            </a:xfrm>
+            <a:prstGeom prst="ellipse">
+              <a:avLst>
+                <a:gd name="adj" fmla="val 361666"/>
+              </a:avLst>
+            </a:prstGeom>
+            <a:solidFill>
+              <a:srgbClr val="16243A"/>
+            </a:solidFill>
+            <a:ln w="12700">
+              <a:solidFill>
+                <a:srgbClr val="16243A">
+                  <a:alpha val="0"/>
+                </a:srgbClr>
+              </a:solidFill>
+              <a:prstDash val="solid"/>
+            </a:ln>
+          </p:spPr>
+        </p:sp>
+        <p:sp>
+          <p:nvSpPr>
+            <p:cNvPr id="910" name="Shape 27"/>
+            <p:cNvSpPr/>
+            <p:nvPr/>
+          </p:nvSpPr>
+          <p:spPr>
+            <a:xfrm>
+              <a:off x="8183880" y="3813048"/>
+              <a:ext cx="548640" cy="685800"/>
+            </a:xfrm>
+            <a:prstGeom prst="chevron">
+              <a:avLst>
+                <a:gd name="adj" fmla="val 16667"/>
+              </a:avLst>
+            </a:prstGeom>
+            <a:solidFill>
+              <a:srgbClr val="5DCDC1"/>
+            </a:solidFill>
+            <a:ln w="12700">
+              <a:solidFill>
+                <a:srgbClr val="5DCDC1">
+                  <a:alpha val="0"/>
+                </a:srgbClr>
+              </a:solidFill>
+              <a:prstDash val="solid"/>
+            </a:ln>
+          </p:spPr>
+        </p:sp>
+        <p:sp>
+          <p:nvSpPr>
+            <p:cNvPr id="911" name="Shape 28"/>
+            <p:cNvSpPr/>
+            <p:nvPr/>
+          </p:nvSpPr>
+          <p:spPr>
+            <a:xfrm>
+              <a:off x="8942832" y="2843784"/>
+              <a:ext cx="2249424" cy="2340864"/>
+            </a:xfrm>
+            <a:prstGeom prst="roundRect">
+              <a:avLst>
+                <a:gd name="adj" fmla="val 4065"/>
+              </a:avLst>
+            </a:prstGeom>
+            <a:solidFill>
+              <a:srgbClr val="16243A"/>
+            </a:solidFill>
+            <a:ln w="12700">
+              <a:solidFill>
+                <a:srgbClr val="16243A">
+                  <a:alpha val="0"/>
+                </a:srgbClr>
+              </a:solidFill>
+              <a:prstDash val="solid"/>
+            </a:ln>
+          </p:spPr>
+        </p:sp>
+        <p:sp>
+          <p:nvSpPr>
+            <p:cNvPr id="912" name="Shape 29"/>
+            <p:cNvSpPr/>
+            <p:nvPr/>
+          </p:nvSpPr>
+          <p:spPr>
+            <a:xfrm>
+              <a:off x="9089136" y="2999232"/>
+              <a:ext cx="1947672" cy="1874520"/>
+            </a:xfrm>
+            <a:prstGeom prst="roundRect">
+              <a:avLst>
+                <a:gd name="adj" fmla="val 4878"/>
+              </a:avLst>
+            </a:prstGeom>
+            <a:solidFill>
+              <a:srgbClr val="D8EFF0"/>
+            </a:solidFill>
+            <a:ln w="12700">
+              <a:solidFill>
+                <a:srgbClr val="D8EFF0">
+                  <a:alpha val="0"/>
+                </a:srgbClr>
+              </a:solidFill>
+              <a:prstDash val="solid"/>
+            </a:ln>
+          </p:spPr>
+        </p:sp>
+        <p:sp>
+          <p:nvSpPr>
+            <p:cNvPr id="913" name="Shape 30"/>
+            <p:cNvSpPr/>
+            <p:nvPr/>
+          </p:nvSpPr>
+          <p:spPr>
+            <a:xfrm>
+              <a:off x="9792858" y="3182112"/>
+              <a:ext cx="393192" cy="393192"/>
+            </a:xfrm>
+            <a:prstGeom prst="ellipse">
+              <a:avLst>
+                <a:gd name="adj" fmla="val 23256"/>
+              </a:avLst>
+            </a:prstGeom>
+            <a:solidFill>
+              <a:srgbClr val="FDE6A5"/>
+            </a:solidFill>
+            <a:ln w="12700">
+              <a:solidFill>
+                <a:srgbClr val="FDE6A5">
+                  <a:alpha val="0"/>
+                </a:srgbClr>
+              </a:solidFill>
+              <a:prstDash val="solid"/>
+            </a:ln>
+          </p:spPr>
+        </p:sp>
+        <p:sp>
+          <p:nvSpPr>
+            <p:cNvPr id="914" name="Shape 31"/>
+            <p:cNvSpPr/>
+            <p:nvPr/>
+          </p:nvSpPr>
+          <p:spPr>
+            <a:xfrm rot="10800000">
+              <a:off x="9729948" y="3528121"/>
+              <a:ext cx="534741" cy="597652"/>
+            </a:xfrm>
+            <a:prstGeom prst="arc">
+              <a:avLst>
+                <a:gd name="adj" fmla="val 17100"/>
+              </a:avLst>
+            </a:prstGeom>
+            <a:solidFill>
+              <a:srgbClr val="F7DDE5"/>
+            </a:solidFill>
+            <a:ln w="12700">
+              <a:solidFill>
+                <a:srgbClr val="F7DDE5"/>
+              </a:solidFill>
+              <a:prstDash val="solid"/>
+            </a:ln>
+          </p:spPr>
+        </p:sp>
+        <p:sp>
+          <p:nvSpPr>
+            <p:cNvPr id="915" name="Shape 32"/>
+            <p:cNvSpPr/>
+            <p:nvPr/>
+          </p:nvSpPr>
+          <p:spPr>
+            <a:xfrm>
+              <a:off x="9753539" y="3701125"/>
+              <a:ext cx="432511" cy="78638"/>
+            </a:xfrm>
+            <a:prstGeom prst="line">
+              <a:avLst>
+                <a:gd name="adj" fmla="val 116280"/>
+              </a:avLst>
+            </a:prstGeom>
+            <a:solidFill>
+              <a:srgbClr val="16243A"/>
+            </a:solidFill>
+            <a:ln w="38100">
+              <a:solidFill>
+                <a:srgbClr val="16243A"/>
+              </a:solidFill>
+              <a:prstDash val="solid"/>
+            </a:ln>
+          </p:spPr>
+        </p:sp>
+        <p:sp>
+          <p:nvSpPr>
+            <p:cNvPr id="916" name="Shape 33"/>
+            <p:cNvSpPr/>
+            <p:nvPr/>
+          </p:nvSpPr>
+          <p:spPr>
+            <a:xfrm>
+              <a:off x="9800722" y="4031407"/>
+              <a:ext cx="-110094" cy="283098"/>
+            </a:xfrm>
+            <a:prstGeom prst="line">
+              <a:avLst>
+                <a:gd name="adj" fmla="val -83056"/>
+              </a:avLst>
+            </a:prstGeom>
+            <a:solidFill>
+              <a:srgbClr val="16243A"/>
+            </a:solidFill>
+            <a:ln w="38100">
+              <a:solidFill>
+                <a:srgbClr val="16243A"/>
+              </a:solidFill>
+              <a:prstDash val="solid"/>
+            </a:ln>
+          </p:spPr>
+        </p:sp>
+        <p:sp>
+          <p:nvSpPr>
+            <p:cNvPr id="917" name="Shape 34"/>
+            <p:cNvSpPr/>
+            <p:nvPr/>
+          </p:nvSpPr>
+          <p:spPr>
+            <a:xfrm>
+              <a:off x="10099548" y="4031407"/>
+              <a:ext cx="110094" cy="283098"/>
+            </a:xfrm>
+            <a:prstGeom prst="line">
+              <a:avLst>
+                <a:gd name="adj" fmla="val 83056"/>
+              </a:avLst>
+            </a:prstGeom>
+            <a:solidFill>
+              <a:srgbClr val="16243A"/>
+            </a:solidFill>
+            <a:ln w="38100">
+              <a:solidFill>
+                <a:srgbClr val="16243A"/>
+              </a:solidFill>
+              <a:prstDash val="solid"/>
+            </a:ln>
+          </p:spPr>
+        </p:sp>
+        <p:sp>
+          <p:nvSpPr>
+            <p:cNvPr id="918" name="Shape 35"/>
+            <p:cNvSpPr/>
+            <p:nvPr/>
+          </p:nvSpPr>
+          <p:spPr>
+            <a:xfrm>
+              <a:off x="9895088" y="3355116"/>
+              <a:ext cx="27523" cy="27523"/>
+            </a:xfrm>
+            <a:prstGeom prst="ellipse">
+              <a:avLst>
+                <a:gd name="adj" fmla="val 332231"/>
+              </a:avLst>
+            </a:prstGeom>
+            <a:solidFill>
+              <a:srgbClr val="16243A"/>
+            </a:solidFill>
+            <a:ln w="12700">
+              <a:solidFill>
+                <a:srgbClr val="16243A">
+                  <a:alpha val="0"/>
+                </a:srgbClr>
+              </a:solidFill>
+              <a:prstDash val="solid"/>
+            </a:ln>
+          </p:spPr>
+        </p:sp>
+        <p:sp>
+          <p:nvSpPr>
+            <p:cNvPr id="919" name="Shape 36"/>
+            <p:cNvSpPr/>
+            <p:nvPr/>
+          </p:nvSpPr>
+          <p:spPr>
+            <a:xfrm>
+              <a:off x="10028773" y="3355116"/>
+              <a:ext cx="27523" cy="27523"/>
+            </a:xfrm>
+            <a:prstGeom prst="ellipse">
+              <a:avLst>
+                <a:gd name="adj" fmla="val 332231"/>
+              </a:avLst>
+            </a:prstGeom>
+            <a:solidFill>
+              <a:srgbClr val="16243A"/>
+            </a:solidFill>
+            <a:ln w="12700">
+              <a:solidFill>
+                <a:srgbClr val="16243A">
+                  <a:alpha val="0"/>
+                </a:srgbClr>
+              </a:solidFill>
+              <a:prstDash val="solid"/>
+            </a:ln>
+          </p:spPr>
+        </p:sp>
+        <p:sp>
+          <p:nvSpPr>
+            <p:cNvPr id="920" name="Text 37"/>
+            <p:cNvSpPr/>
+            <p:nvPr/>
+          </p:nvSpPr>
+          <p:spPr>
+            <a:xfrm>
+              <a:off x="6784848" y="5276088"/>
+              <a:ext cx="1097280" cy="274320"/>
+            </a:xfrm>
+            <a:prstGeom prst="rect">
+              <a:avLst/>
+            </a:prstGeom>
+            <a:noFill/>
+            <a:ln/>
+          </p:spPr>
+          <p:txBody>
+            <a:bodyPr wrap="square" lIns="0" tIns="0" rIns="0" bIns="0" rtlCol="0" anchor="ctr">
+              <a:normAutofit/>
+            </a:bodyPr>
+            <a:lstStyle/>
+            <a:p>
+              <a:pPr algn="ctr" indent="0" marL="0">
+                <a:buNone/>
+              </a:pPr>
+              <a:r>
+                <a:rPr lang="en-US" sz="700" b="1" dirty="0">
+                  <a:solidFill>
+                    <a:srgbClr val="617287"/>
+                  </a:solidFill>
+                  <a:latin typeface="Malgun Gothic" pitchFamily="34" charset="0"/>
+                  <a:ea typeface="Malgun Gothic" pitchFamily="34" charset="-122"/>
+                  <a:cs typeface="Malgun Gothic" pitchFamily="34" charset="-120"/>
+                </a:rPr>
+                <a:t>SCAN</a:t>
+              </a:r>
+              <a:endParaRPr lang="en-US" sz="700" dirty="0"/>
+            </a:p>
+          </p:txBody>
+        </p:sp>
+        <p:sp>
+          <p:nvSpPr>
+            <p:cNvPr id="921" name="Text 38"/>
+            <p:cNvSpPr/>
+            <p:nvPr/>
+          </p:nvSpPr>
+          <p:spPr>
+            <a:xfrm>
+              <a:off x="8997696" y="5276088"/>
+              <a:ext cx="2103120" cy="274320"/>
+            </a:xfrm>
+            <a:prstGeom prst="rect">
+              <a:avLst/>
+            </a:prstGeom>
+            <a:noFill/>
+            <a:ln/>
+          </p:spPr>
+          <p:txBody>
+            <a:bodyPr wrap="square" lIns="0" tIns="0" rIns="0" bIns="0" rtlCol="0" anchor="ctr">
+              <a:normAutofit/>
+            </a:bodyPr>
+            <a:lstStyle/>
+            <a:p>
+              <a:pPr algn="ctr" indent="0" marL="0">
+                <a:buNone/>
+              </a:pPr>
+              <a:r>
+                <a:rPr lang="en-US" sz="700" b="1" dirty="0">
+                  <a:solidFill>
+                    <a:srgbClr val="617287"/>
+                  </a:solidFill>
+                  <a:latin typeface="Malgun Gothic" pitchFamily="34" charset="0"/>
+                  <a:ea typeface="Malgun Gothic" pitchFamily="34" charset="-122"/>
+                  <a:cs typeface="Malgun Gothic" pitchFamily="34" charset="-120"/>
+                </a:rPr>
+                <a:t>2D / 3D + α</a:t>
+              </a:r>
+              <a:endParaRPr lang="en-US" sz="700" dirty="0"/>
+            </a:p>
+          </p:txBody>
+        </p:sp>
+      </p:grpSp>
     </p:spTree>
   </p:cSld>
   <p:clrMapOvr>
@@ -8194,18 +9169,54 @@
       </p:sp>
       <p:sp>
         <p:nvSpPr>
-          <p:cNvPr id="5" name="original"/>
+          <p:cNvPr id="5" name="Text 3"/>
+          <p:cNvSpPr txBox="1"/>
+          <p:nvPr/>
+        </p:nvSpPr>
+        <p:spPr>
+          <a:xfrm>
+            <a:off x="548640" y="1965960"/>
+            <a:ext cx="1828800" cy="365760"/>
+          </a:xfrm>
+          <a:prstGeom prst="rect">
+            <a:avLst/>
+          </a:prstGeom>
+          <a:noFill/>
+          <a:ln/>
+        </p:spPr>
+        <p:txBody>
+          <a:bodyPr wrap="square" lIns="0" tIns="0" rIns="0" bIns="0" rtlCol="0" anchor="ctr"/>
+          <a:lstStyle/>
+          <a:p>
+            <a:pPr indent="0" marL="0">
+              <a:buNone/>
+            </a:pPr>
+            <a:r>
+              <a:rPr lang="en-US" sz="1700" b="1" dirty="0">
+                <a:solidFill>
+                  <a:srgbClr val="617287"/>
+                </a:solidFill>
+              </a:rPr>
+              <a:t>원안</a:t>
+            </a:r>
+            <a:endParaRPr lang="en-US" sz="1700" dirty="0"/>
+          </a:p>
+        </p:txBody>
+      </p:sp>
+      <p:sp>
+        <p:nvSpPr>
+          <p:cNvPr id="6" name="original"/>
           <p:cNvSpPr/>
           <p:nvPr/>
         </p:nvSpPr>
         <p:spPr>
           <a:xfrm>
-            <a:off x="548640" y="1965960"/>
-            <a:ext cx="4206240" cy="3794760"/>
+            <a:off x="548640" y="4645152"/>
+            <a:ext cx="4206240" cy="1115568"/>
           </a:xfrm>
           <a:prstGeom prst="roundRect">
             <a:avLst>
-              <a:gd name="adj" fmla="val 2892"/>
+              <a:gd name="adj" fmla="val 9836"/>
             </a:avLst>
           </a:prstGeom>
           <a:solidFill>
@@ -8221,50 +9232,14 @@
       </p:sp>
       <p:sp>
         <p:nvSpPr>
-          <p:cNvPr id="6" name="Text 4"/>
-          <p:cNvSpPr txBox="1"/>
-          <p:nvPr/>
-        </p:nvSpPr>
-        <p:spPr>
-          <a:xfrm>
-            <a:off x="822960" y="2121408"/>
-            <a:ext cx="1828800" cy="365760"/>
-          </a:xfrm>
-          <a:prstGeom prst="rect">
-            <a:avLst/>
-          </a:prstGeom>
-          <a:noFill/>
-          <a:ln/>
-        </p:spPr>
-        <p:txBody>
-          <a:bodyPr wrap="square" lIns="0" tIns="0" rIns="0" bIns="0" rtlCol="0" anchor="ctr"/>
-          <a:lstStyle/>
-          <a:p>
-            <a:pPr indent="0" marL="0">
-              <a:buNone/>
-            </a:pPr>
-            <a:r>
-              <a:rPr lang="en-US" sz="1700" b="1" dirty="0">
-                <a:solidFill>
-                  <a:srgbClr val="617287"/>
-                </a:solidFill>
-              </a:rPr>
-              <a:t>원안</a:t>
-            </a:r>
-            <a:endParaRPr lang="en-US" sz="1700" dirty="0"/>
-          </a:p>
-        </p:txBody>
-      </p:sp>
-      <p:sp>
-        <p:nvSpPr>
           <p:cNvPr id="7" name="chip-3-1"/>
           <p:cNvSpPr txBox="1"/>
           <p:nvPr/>
         </p:nvSpPr>
         <p:spPr>
           <a:xfrm>
-            <a:off x="822960" y="2651760"/>
-            <a:ext cx="566928" cy="292608"/>
+            <a:off x="685800" y="4773168"/>
+            <a:ext cx="502920" cy="292608"/>
           </a:xfrm>
           <a:prstGeom prst="roundRect">
             <a:avLst>
@@ -8303,8 +9278,8 @@
         </p:nvSpPr>
         <p:spPr>
           <a:xfrm>
-            <a:off x="1508760" y="2615184"/>
-            <a:ext cx="3108960" cy="365760"/>
+            <a:off x="1280160" y="4718304"/>
+            <a:ext cx="3383280" cy="457200"/>
           </a:xfrm>
           <a:prstGeom prst="rect">
             <a:avLst/>
@@ -8320,63 +9295,38 @@
               <a:buNone/>
             </a:pPr>
             <a:r>
-              <a:rPr lang="en-US" sz="1500" b="1" dirty="0">
+              <a:rPr lang="en-US" sz="1100" b="1" dirty="0">
                 <a:solidFill>
                   <a:srgbClr val="16243A"/>
                 </a:solidFill>
               </a:rPr>
-              <a:t>등장 이벤트</a:t>
-            </a:r>
-            <a:endParaRPr lang="en-US" sz="1500" dirty="0"/>
-          </a:p>
-        </p:txBody>
-      </p:sp>
-      <p:sp>
-        <p:nvSpPr>
-          <p:cNvPr id="9" name="Text 7"/>
-          <p:cNvSpPr txBox="1"/>
-          <p:nvPr/>
-        </p:nvSpPr>
-        <p:spPr>
-          <a:xfrm>
-            <a:off x="822960" y="3063240"/>
-            <a:ext cx="3703320" cy="960120"/>
-          </a:xfrm>
-          <a:prstGeom prst="rect">
-            <a:avLst/>
-          </a:prstGeom>
-          <a:noFill/>
-          <a:ln/>
-        </p:spPr>
-        <p:txBody>
-          <a:bodyPr wrap="square" lIns="0" tIns="0" rIns="0" bIns="0" rtlCol="0" anchor="t"/>
-          <a:lstStyle/>
-          <a:p>
+              <a:t>등장 이벤트  </a:t>
+            </a:r>
             <a:pPr indent="0" marL="0">
               <a:buNone/>
             </a:pPr>
             <a:r>
-              <a:rPr lang="en-US" sz="1300" dirty="0">
+              <a:rPr lang="en-US" sz="1100" dirty="0">
                 <a:solidFill>
                   <a:srgbClr val="617287"/>
                 </a:solidFill>
               </a:rPr>
-              <a:t>WELCOME! 스캔 완료 시 메인 월에 캐릭터가 크게 등장하여 춤추거나 인사</a:t>
-            </a:r>
-            <a:endParaRPr lang="en-US" sz="1300" dirty="0"/>
-          </a:p>
-        </p:txBody>
-      </p:sp>
-      <p:sp>
-        <p:nvSpPr>
-          <p:cNvPr id="10" name="chip-3-2"/>
-          <p:cNvSpPr txBox="1"/>
-          <p:nvPr/>
-        </p:nvSpPr>
-        <p:spPr>
-          <a:xfrm>
-            <a:off x="822960" y="4160520"/>
-            <a:ext cx="566928" cy="292608"/>
+              <a:t>스캔 완료 시 메인 월에 크게 등장해 춤 · 인사</a:t>
+            </a:r>
+            <a:endParaRPr lang="en-US" sz="1100" dirty="0"/>
+          </a:p>
+        </p:txBody>
+      </p:sp>
+      <p:sp>
+        <p:nvSpPr>
+          <p:cNvPr id="9" name="chip-3-2"/>
+          <p:cNvSpPr txBox="1"/>
+          <p:nvPr/>
+        </p:nvSpPr>
+        <p:spPr>
+          <a:xfrm>
+            <a:off x="685800" y="5276088"/>
+            <a:ext cx="502920" cy="292608"/>
           </a:xfrm>
           <a:prstGeom prst="roundRect">
             <a:avLst>
@@ -8409,79 +9359,54 @@
       </p:sp>
       <p:sp>
         <p:nvSpPr>
+          <p:cNvPr id="10" name="Text 8"/>
+          <p:cNvSpPr txBox="1"/>
+          <p:nvPr/>
+        </p:nvSpPr>
+        <p:spPr>
+          <a:xfrm>
+            <a:off x="1280160" y="5221224"/>
+            <a:ext cx="3383280" cy="457200"/>
+          </a:xfrm>
+          <a:prstGeom prst="rect">
+            <a:avLst/>
+          </a:prstGeom>
+          <a:noFill/>
+          <a:ln/>
+        </p:spPr>
+        <p:txBody>
+          <a:bodyPr wrap="square" lIns="0" tIns="0" rIns="0" bIns="0" rtlCol="0" anchor="ctr"/>
+          <a:lstStyle/>
+          <a:p>
+            <a:pPr indent="0" marL="0">
+              <a:buNone/>
+            </a:pPr>
+            <a:r>
+              <a:rPr lang="en-US" sz="1100" b="1" dirty="0">
+                <a:solidFill>
+                  <a:srgbClr val="16243A"/>
+                </a:solidFill>
+              </a:rPr>
+              <a:t>연못 / 가든 인터랙션  </a:t>
+            </a:r>
+            <a:pPr indent="0" marL="0">
+              <a:buNone/>
+            </a:pPr>
+            <a:r>
+              <a:rPr lang="en-US" sz="1100" dirty="0">
+                <a:solidFill>
+                  <a:srgbClr val="617287"/>
+                </a:solidFill>
+              </a:rPr>
+              <a:t>다른 캐릭터와 자유롭게 이동 · 터치 반응 검토</a:t>
+            </a:r>
+            <a:endParaRPr lang="en-US" sz="1100" dirty="0"/>
+          </a:p>
+        </p:txBody>
+      </p:sp>
+      <p:sp>
+        <p:nvSpPr>
           <p:cNvPr id="11" name="Text 9"/>
-          <p:cNvSpPr txBox="1"/>
-          <p:nvPr/>
-        </p:nvSpPr>
-        <p:spPr>
-          <a:xfrm>
-            <a:off x="1508760" y="4123944"/>
-            <a:ext cx="3108960" cy="365760"/>
-          </a:xfrm>
-          <a:prstGeom prst="rect">
-            <a:avLst/>
-          </a:prstGeom>
-          <a:noFill/>
-          <a:ln/>
-        </p:spPr>
-        <p:txBody>
-          <a:bodyPr wrap="square" lIns="0" tIns="0" rIns="0" bIns="0" rtlCol="0" anchor="ctr"/>
-          <a:lstStyle/>
-          <a:p>
-            <a:pPr indent="0" marL="0">
-              <a:buNone/>
-            </a:pPr>
-            <a:r>
-              <a:rPr lang="en-US" sz="1500" b="1" dirty="0">
-                <a:solidFill>
-                  <a:srgbClr val="16243A"/>
-                </a:solidFill>
-              </a:rPr>
-              <a:t>연못 / 가든 인터랙션</a:t>
-            </a:r>
-            <a:endParaRPr lang="en-US" sz="1500" dirty="0"/>
-          </a:p>
-        </p:txBody>
-      </p:sp>
-      <p:sp>
-        <p:nvSpPr>
-          <p:cNvPr id="12" name="Text 10"/>
-          <p:cNvSpPr txBox="1"/>
-          <p:nvPr/>
-        </p:nvSpPr>
-        <p:spPr>
-          <a:xfrm>
-            <a:off x="822960" y="4572000"/>
-            <a:ext cx="3703320" cy="960120"/>
-          </a:xfrm>
-          <a:prstGeom prst="rect">
-            <a:avLst/>
-          </a:prstGeom>
-          <a:noFill/>
-          <a:ln/>
-        </p:spPr>
-        <p:txBody>
-          <a:bodyPr wrap="square" lIns="0" tIns="0" rIns="0" bIns="0" rtlCol="0" anchor="t"/>
-          <a:lstStyle/>
-          <a:p>
-            <a:pPr indent="0" marL="0">
-              <a:buNone/>
-            </a:pPr>
-            <a:r>
-              <a:rPr lang="en-US" sz="1300" dirty="0">
-                <a:solidFill>
-                  <a:srgbClr val="617287"/>
-                </a:solidFill>
-              </a:rPr>
-              <a:t>다른 아이들의 캐릭터와 함께 자유롭게 이동 · 터치에 반응하는 방식 검토</a:t>
-            </a:r>
-            <a:endParaRPr lang="en-US" sz="1300" dirty="0"/>
-          </a:p>
-        </p:txBody>
-      </p:sp>
-      <p:sp>
-        <p:nvSpPr>
-          <p:cNvPr id="13" name="Text 11"/>
           <p:cNvSpPr txBox="1"/>
           <p:nvPr/>
         </p:nvSpPr>
@@ -8517,7 +9442,7 @@
       </p:sp>
       <p:sp>
         <p:nvSpPr>
-          <p:cNvPr id="14" name="prop-0"/>
+          <p:cNvPr id="12" name="prop-0"/>
           <p:cNvSpPr/>
           <p:nvPr/>
         </p:nvSpPr>
@@ -8544,7 +9469,7 @@
       </p:sp>
       <p:sp>
         <p:nvSpPr>
-          <p:cNvPr id="15" name="chip-연출"/>
+          <p:cNvPr id="13" name="chip-연출"/>
           <p:cNvSpPr txBox="1"/>
           <p:nvPr/>
         </p:nvSpPr>
@@ -8584,7 +9509,7 @@
       </p:sp>
       <p:sp>
         <p:nvSpPr>
-          <p:cNvPr id="16" name="Text 14"/>
+          <p:cNvPr id="14" name="Text 12"/>
           <p:cNvSpPr txBox="1"/>
           <p:nvPr/>
         </p:nvSpPr>
@@ -8620,7 +9545,7 @@
       </p:sp>
       <p:sp>
         <p:nvSpPr>
-          <p:cNvPr id="17" name="Text 15"/>
+          <p:cNvPr id="15" name="Text 13"/>
           <p:cNvSpPr txBox="1"/>
           <p:nvPr/>
         </p:nvSpPr>
@@ -8656,7 +9581,7 @@
       </p:sp>
       <p:sp>
         <p:nvSpPr>
-          <p:cNvPr id="18" name="prop-1"/>
+          <p:cNvPr id="16" name="prop-1"/>
           <p:cNvSpPr/>
           <p:nvPr/>
         </p:nvSpPr>
@@ -8683,7 +9608,7 @@
       </p:sp>
       <p:sp>
         <p:nvSpPr>
-          <p:cNvPr id="19" name="chip-체험"/>
+          <p:cNvPr id="17" name="chip-체험"/>
           <p:cNvSpPr txBox="1"/>
           <p:nvPr/>
         </p:nvSpPr>
@@ -8723,7 +9648,7 @@
       </p:sp>
       <p:sp>
         <p:nvSpPr>
-          <p:cNvPr id="20" name="Text 18"/>
+          <p:cNvPr id="18" name="Text 16"/>
           <p:cNvSpPr txBox="1"/>
           <p:nvPr/>
         </p:nvSpPr>
@@ -8759,7 +9684,7 @@
       </p:sp>
       <p:sp>
         <p:nvSpPr>
-          <p:cNvPr id="21" name="Text 19"/>
+          <p:cNvPr id="19" name="Text 17"/>
           <p:cNvSpPr txBox="1"/>
           <p:nvPr/>
         </p:nvSpPr>
@@ -8795,7 +9720,7 @@
       </p:sp>
       <p:sp>
         <p:nvSpPr>
-          <p:cNvPr id="22" name="prop-2"/>
+          <p:cNvPr id="20" name="prop-2"/>
           <p:cNvSpPr/>
           <p:nvPr/>
         </p:nvSpPr>
@@ -8822,7 +9747,7 @@
       </p:sp>
       <p:sp>
         <p:nvSpPr>
-          <p:cNvPr id="23" name="chip-체험"/>
+          <p:cNvPr id="21" name="chip-체험"/>
           <p:cNvSpPr txBox="1"/>
           <p:nvPr/>
         </p:nvSpPr>
@@ -8862,7 +9787,7 @@
       </p:sp>
       <p:sp>
         <p:nvSpPr>
-          <p:cNvPr id="24" name="Text 22"/>
+          <p:cNvPr id="22" name="Text 20"/>
           <p:cNvSpPr txBox="1"/>
           <p:nvPr/>
         </p:nvSpPr>
@@ -8898,7 +9823,7 @@
       </p:sp>
       <p:sp>
         <p:nvSpPr>
-          <p:cNvPr id="25" name="Text 23"/>
+          <p:cNvPr id="23" name="Text 21"/>
           <p:cNvSpPr txBox="1"/>
           <p:nvPr/>
         </p:nvSpPr>
@@ -8934,7 +9859,7 @@
       </p:sp>
       <p:sp>
         <p:nvSpPr>
-          <p:cNvPr id="26" name="prop-3"/>
+          <p:cNvPr id="24" name="prop-3"/>
           <p:cNvSpPr/>
           <p:nvPr/>
         </p:nvSpPr>
@@ -8961,7 +9886,7 @@
       </p:sp>
       <p:sp>
         <p:nvSpPr>
-          <p:cNvPr id="27" name="chip-운영"/>
+          <p:cNvPr id="25" name="chip-운영"/>
           <p:cNvSpPr txBox="1"/>
           <p:nvPr/>
         </p:nvSpPr>
@@ -9001,7 +9926,7 @@
       </p:sp>
       <p:sp>
         <p:nvSpPr>
-          <p:cNvPr id="28" name="Text 26"/>
+          <p:cNvPr id="26" name="Text 24"/>
           <p:cNvSpPr txBox="1"/>
           <p:nvPr/>
         </p:nvSpPr>
@@ -9037,7 +9962,7 @@
       </p:sp>
       <p:sp>
         <p:nvSpPr>
-          <p:cNvPr id="29" name="Text 27"/>
+          <p:cNvPr id="27" name="Text 25"/>
           <p:cNvSpPr txBox="1"/>
           <p:nvPr/>
         </p:nvSpPr>
@@ -9073,7 +9998,7 @@
       </p:sp>
       <p:sp>
         <p:nvSpPr>
-          <p:cNvPr id="30" name="Text 28"/>
+          <p:cNvPr id="28" name="Text 26"/>
           <p:cNvSpPr txBox="1"/>
           <p:nvPr/>
         </p:nvSpPr>
@@ -9163,6 +10088,626 @@
           </a:p>
         </p:txBody>
       </p:sp>
+      <p:grpSp>
+        <p:nvGrpSpPr>
+          <p:cNvPr id="900" name="원안 그림"/>
+          <p:cNvGrpSpPr/>
+          <p:nvPr/>
+        </p:nvGrpSpPr>
+        <p:grpSpPr>
+          <a:xfrm>
+            <a:off x="856040" y="2331720"/>
+            <a:ext cx="3591440" cy="2212848"/>
+            <a:chOff x="6135624" y="2331720"/>
+            <a:chExt cx="5550408" cy="3419856"/>
+          </a:xfrm>
+        </p:grpSpPr>
+        <p:sp>
+          <p:nvSpPr>
+            <p:cNvPr id="901" name="Shape 18"/>
+            <p:cNvSpPr/>
+            <p:nvPr/>
+          </p:nvSpPr>
+          <p:spPr>
+            <a:xfrm>
+              <a:off x="6135624" y="2331720"/>
+              <a:ext cx="5550408" cy="3419856"/>
+            </a:xfrm>
+            <a:prstGeom prst="roundRect">
+              <a:avLst>
+                <a:gd name="adj" fmla="val 2674"/>
+              </a:avLst>
+            </a:prstGeom>
+            <a:solidFill>
+              <a:srgbClr val="DBEEF0"/>
+            </a:solidFill>
+            <a:ln w="12700">
+              <a:solidFill>
+                <a:srgbClr val="DBEEF0">
+                  <a:alpha val="0"/>
+                </a:srgbClr>
+              </a:solidFill>
+              <a:prstDash val="solid"/>
+            </a:ln>
+          </p:spPr>
+        </p:sp>
+        <p:sp>
+          <p:nvSpPr>
+            <p:cNvPr id="902" name="Shape 19"/>
+            <p:cNvSpPr/>
+            <p:nvPr/>
+          </p:nvSpPr>
+          <p:spPr>
+            <a:xfrm>
+              <a:off x="6483096" y="3977640"/>
+              <a:ext cx="4846320" cy="1353312"/>
+            </a:xfrm>
+            <a:prstGeom prst="ellipse">
+              <a:avLst>
+                <a:gd name="adj" fmla="val 6757"/>
+              </a:avLst>
+            </a:prstGeom>
+            <a:solidFill>
+              <a:srgbClr val="9BCFDA"/>
+            </a:solidFill>
+            <a:ln w="12700">
+              <a:solidFill>
+                <a:srgbClr val="9BCFDA">
+                  <a:alpha val="0"/>
+                </a:srgbClr>
+              </a:solidFill>
+              <a:prstDash val="solid"/>
+            </a:ln>
+          </p:spPr>
+        </p:sp>
+        <p:sp>
+          <p:nvSpPr>
+            <p:cNvPr id="903" name="Shape 20"/>
+            <p:cNvSpPr/>
+            <p:nvPr/>
+          </p:nvSpPr>
+          <p:spPr>
+            <a:xfrm>
+              <a:off x="7589520" y="4178808"/>
+              <a:ext cx="1069848" cy="438912"/>
+            </a:xfrm>
+            <a:prstGeom prst="ellipse">
+              <a:avLst>
+                <a:gd name="adj" fmla="val 20833"/>
+              </a:avLst>
+            </a:prstGeom>
+            <a:solidFill>
+              <a:srgbClr val="7ABBA0"/>
+            </a:solidFill>
+            <a:ln w="12700">
+              <a:solidFill>
+                <a:srgbClr val="7ABBA0">
+                  <a:alpha val="0"/>
+                </a:srgbClr>
+              </a:solidFill>
+              <a:prstDash val="solid"/>
+            </a:ln>
+          </p:spPr>
+        </p:sp>
+        <p:sp>
+          <p:nvSpPr>
+            <p:cNvPr id="904" name="Shape 21"/>
+            <p:cNvSpPr/>
+            <p:nvPr/>
+          </p:nvSpPr>
+          <p:spPr>
+            <a:xfrm>
+              <a:off x="9729216" y="4462272"/>
+              <a:ext cx="1051560" cy="374904"/>
+            </a:xfrm>
+            <a:prstGeom prst="ellipse">
+              <a:avLst>
+                <a:gd name="adj" fmla="val 24390"/>
+              </a:avLst>
+            </a:prstGeom>
+            <a:solidFill>
+              <a:srgbClr val="7ABBA0"/>
+            </a:solidFill>
+            <a:ln w="12700">
+              <a:solidFill>
+                <a:srgbClr val="7ABBA0">
+                  <a:alpha val="0"/>
+                </a:srgbClr>
+              </a:solidFill>
+              <a:prstDash val="solid"/>
+            </a:ln>
+          </p:spPr>
+        </p:sp>
+        <p:sp>
+          <p:nvSpPr>
+            <p:cNvPr id="905" name="Shape 22"/>
+            <p:cNvSpPr/>
+            <p:nvPr/>
+          </p:nvSpPr>
+          <p:spPr>
+            <a:xfrm>
+              <a:off x="7777886" y="2971800"/>
+              <a:ext cx="502920" cy="502920"/>
+            </a:xfrm>
+            <a:prstGeom prst="ellipse">
+              <a:avLst>
+                <a:gd name="adj" fmla="val 18182"/>
+              </a:avLst>
+            </a:prstGeom>
+            <a:solidFill>
+              <a:srgbClr val="FDE6A5"/>
+            </a:solidFill>
+            <a:ln w="12700">
+              <a:solidFill>
+                <a:srgbClr val="FDE6A5">
+                  <a:alpha val="0"/>
+                </a:srgbClr>
+              </a:solidFill>
+              <a:prstDash val="solid"/>
+            </a:ln>
+          </p:spPr>
+        </p:sp>
+        <p:sp>
+          <p:nvSpPr>
+            <p:cNvPr id="906" name="Shape 23"/>
+            <p:cNvSpPr/>
+            <p:nvPr/>
+          </p:nvSpPr>
+          <p:spPr>
+            <a:xfrm rot="10800000">
+              <a:off x="7697419" y="3414370"/>
+              <a:ext cx="683971" cy="764438"/>
+            </a:xfrm>
+            <a:prstGeom prst="arc">
+              <a:avLst>
+                <a:gd name="adj" fmla="val 13369"/>
+              </a:avLst>
+            </a:prstGeom>
+            <a:solidFill>
+              <a:srgbClr val="F7DDE5"/>
+            </a:solidFill>
+            <a:ln w="12700">
+              <a:solidFill>
+                <a:srgbClr val="F7DDE5"/>
+              </a:solidFill>
+              <a:prstDash val="solid"/>
+            </a:ln>
+          </p:spPr>
+        </p:sp>
+        <p:sp>
+          <p:nvSpPr>
+            <p:cNvPr id="907" name="Shape 24"/>
+            <p:cNvSpPr/>
+            <p:nvPr/>
+          </p:nvSpPr>
+          <p:spPr>
+            <a:xfrm>
+              <a:off x="7727594" y="3635654"/>
+              <a:ext cx="553212" cy="100584"/>
+            </a:xfrm>
+            <a:prstGeom prst="line">
+              <a:avLst>
+                <a:gd name="adj" fmla="val 90909"/>
+              </a:avLst>
+            </a:prstGeom>
+            <a:solidFill>
+              <a:srgbClr val="16243A"/>
+            </a:solidFill>
+            <a:ln w="38100">
+              <a:solidFill>
+                <a:srgbClr val="16243A"/>
+              </a:solidFill>
+              <a:prstDash val="solid"/>
+            </a:ln>
+          </p:spPr>
+        </p:sp>
+        <p:sp>
+          <p:nvSpPr>
+            <p:cNvPr id="908" name="Shape 25"/>
+            <p:cNvSpPr/>
+            <p:nvPr/>
+          </p:nvSpPr>
+          <p:spPr>
+            <a:xfrm>
+              <a:off x="7787945" y="4058107"/>
+              <a:ext cx="-140818" cy="362102"/>
+            </a:xfrm>
+            <a:prstGeom prst="line">
+              <a:avLst>
+                <a:gd name="adj" fmla="val -64935"/>
+              </a:avLst>
+            </a:prstGeom>
+            <a:solidFill>
+              <a:srgbClr val="16243A"/>
+            </a:solidFill>
+            <a:ln w="38100">
+              <a:solidFill>
+                <a:srgbClr val="16243A"/>
+              </a:solidFill>
+              <a:prstDash val="solid"/>
+            </a:ln>
+          </p:spPr>
+        </p:sp>
+        <p:sp>
+          <p:nvSpPr>
+            <p:cNvPr id="909" name="Shape 26"/>
+            <p:cNvSpPr/>
+            <p:nvPr/>
+          </p:nvSpPr>
+          <p:spPr>
+            <a:xfrm>
+              <a:off x="8170164" y="4058107"/>
+              <a:ext cx="140818" cy="362102"/>
+            </a:xfrm>
+            <a:prstGeom prst="line">
+              <a:avLst>
+                <a:gd name="adj" fmla="val 64935"/>
+              </a:avLst>
+            </a:prstGeom>
+            <a:solidFill>
+              <a:srgbClr val="16243A"/>
+            </a:solidFill>
+            <a:ln w="38100">
+              <a:solidFill>
+                <a:srgbClr val="16243A"/>
+              </a:solidFill>
+              <a:prstDash val="solid"/>
+            </a:ln>
+          </p:spPr>
+        </p:sp>
+        <p:sp>
+          <p:nvSpPr>
+            <p:cNvPr id="910" name="Shape 27"/>
+            <p:cNvSpPr/>
+            <p:nvPr/>
+          </p:nvSpPr>
+          <p:spPr>
+            <a:xfrm>
+              <a:off x="7908646" y="3193085"/>
+              <a:ext cx="35204" cy="35204"/>
+            </a:xfrm>
+            <a:prstGeom prst="ellipse">
+              <a:avLst>
+                <a:gd name="adj" fmla="val 259743"/>
+              </a:avLst>
+            </a:prstGeom>
+            <a:solidFill>
+              <a:srgbClr val="16243A"/>
+            </a:solidFill>
+            <a:ln w="12700">
+              <a:solidFill>
+                <a:srgbClr val="16243A">
+                  <a:alpha val="0"/>
+                </a:srgbClr>
+              </a:solidFill>
+              <a:prstDash val="solid"/>
+            </a:ln>
+          </p:spPr>
+        </p:sp>
+        <p:sp>
+          <p:nvSpPr>
+            <p:cNvPr id="911" name="Shape 28"/>
+            <p:cNvSpPr/>
+            <p:nvPr/>
+          </p:nvSpPr>
+          <p:spPr>
+            <a:xfrm>
+              <a:off x="8079638" y="3193085"/>
+              <a:ext cx="35204" cy="35204"/>
+            </a:xfrm>
+            <a:prstGeom prst="ellipse">
+              <a:avLst>
+                <a:gd name="adj" fmla="val 259743"/>
+              </a:avLst>
+            </a:prstGeom>
+            <a:solidFill>
+              <a:srgbClr val="16243A"/>
+            </a:solidFill>
+            <a:ln w="12700">
+              <a:solidFill>
+                <a:srgbClr val="16243A">
+                  <a:alpha val="0"/>
+                </a:srgbClr>
+              </a:solidFill>
+              <a:prstDash val="solid"/>
+            </a:ln>
+          </p:spPr>
+        </p:sp>
+        <p:sp>
+          <p:nvSpPr>
+            <p:cNvPr id="912" name="Shape 29"/>
+            <p:cNvSpPr/>
+            <p:nvPr/>
+          </p:nvSpPr>
+          <p:spPr>
+            <a:xfrm>
+              <a:off x="9522927" y="3182112"/>
+              <a:ext cx="361188" cy="361188"/>
+            </a:xfrm>
+            <a:prstGeom prst="ellipse">
+              <a:avLst>
+                <a:gd name="adj" fmla="val 25316"/>
+              </a:avLst>
+            </a:prstGeom>
+            <a:solidFill>
+              <a:srgbClr val="FDE6A5"/>
+            </a:solidFill>
+            <a:ln w="12700">
+              <a:solidFill>
+                <a:srgbClr val="FDE6A5">
+                  <a:alpha val="0"/>
+                </a:srgbClr>
+              </a:solidFill>
+              <a:prstDash val="solid"/>
+            </a:ln>
+          </p:spPr>
+        </p:sp>
+        <p:sp>
+          <p:nvSpPr>
+            <p:cNvPr id="913" name="Shape 30"/>
+            <p:cNvSpPr/>
+            <p:nvPr/>
+          </p:nvSpPr>
+          <p:spPr>
+            <a:xfrm rot="10800000">
+              <a:off x="9465137" y="3499957"/>
+              <a:ext cx="491216" cy="549006"/>
+            </a:xfrm>
+            <a:prstGeom prst="arc">
+              <a:avLst>
+                <a:gd name="adj" fmla="val 18615"/>
+              </a:avLst>
+            </a:prstGeom>
+            <a:solidFill>
+              <a:srgbClr val="F7DDE5"/>
+            </a:solidFill>
+            <a:ln w="12700">
+              <a:solidFill>
+                <a:srgbClr val="F7DDE5"/>
+              </a:solidFill>
+              <a:prstDash val="solid"/>
+            </a:ln>
+          </p:spPr>
+        </p:sp>
+        <p:sp>
+          <p:nvSpPr>
+            <p:cNvPr id="914" name="Shape 31"/>
+            <p:cNvSpPr/>
+            <p:nvPr/>
+          </p:nvSpPr>
+          <p:spPr>
+            <a:xfrm>
+              <a:off x="9486809" y="3658880"/>
+              <a:ext cx="397307" cy="72238"/>
+            </a:xfrm>
+            <a:prstGeom prst="line">
+              <a:avLst>
+                <a:gd name="adj" fmla="val 126582"/>
+              </a:avLst>
+            </a:prstGeom>
+            <a:solidFill>
+              <a:srgbClr val="16243A"/>
+            </a:solidFill>
+            <a:ln w="38100">
+              <a:solidFill>
+                <a:srgbClr val="16243A"/>
+              </a:solidFill>
+              <a:prstDash val="solid"/>
+            </a:ln>
+          </p:spPr>
+        </p:sp>
+        <p:sp>
+          <p:nvSpPr>
+            <p:cNvPr id="915" name="Shape 32"/>
+            <p:cNvSpPr/>
+            <p:nvPr/>
+          </p:nvSpPr>
+          <p:spPr>
+            <a:xfrm>
+              <a:off x="9530151" y="3962278"/>
+              <a:ext cx="-101133" cy="260055"/>
+            </a:xfrm>
+            <a:prstGeom prst="line">
+              <a:avLst>
+                <a:gd name="adj" fmla="val -90416"/>
+              </a:avLst>
+            </a:prstGeom>
+            <a:solidFill>
+              <a:srgbClr val="16243A"/>
+            </a:solidFill>
+            <a:ln w="38100">
+              <a:solidFill>
+                <a:srgbClr val="16243A"/>
+              </a:solidFill>
+              <a:prstDash val="solid"/>
+            </a:ln>
+          </p:spPr>
+        </p:sp>
+        <p:sp>
+          <p:nvSpPr>
+            <p:cNvPr id="916" name="Shape 33"/>
+            <p:cNvSpPr/>
+            <p:nvPr/>
+          </p:nvSpPr>
+          <p:spPr>
+            <a:xfrm>
+              <a:off x="9804654" y="3962278"/>
+              <a:ext cx="101133" cy="260055"/>
+            </a:xfrm>
+            <a:prstGeom prst="line">
+              <a:avLst>
+                <a:gd name="adj" fmla="val 90416"/>
+              </a:avLst>
+            </a:prstGeom>
+            <a:solidFill>
+              <a:srgbClr val="16243A"/>
+            </a:solidFill>
+            <a:ln w="38100">
+              <a:solidFill>
+                <a:srgbClr val="16243A"/>
+              </a:solidFill>
+              <a:prstDash val="solid"/>
+            </a:ln>
+          </p:spPr>
+        </p:sp>
+        <p:sp>
+          <p:nvSpPr>
+            <p:cNvPr id="917" name="Shape 34"/>
+            <p:cNvSpPr/>
+            <p:nvPr/>
+          </p:nvSpPr>
+          <p:spPr>
+            <a:xfrm>
+              <a:off x="9616836" y="3341035"/>
+              <a:ext cx="25283" cy="25283"/>
+            </a:xfrm>
+            <a:prstGeom prst="ellipse">
+              <a:avLst>
+                <a:gd name="adj" fmla="val 361666"/>
+              </a:avLst>
+            </a:prstGeom>
+            <a:solidFill>
+              <a:srgbClr val="16243A"/>
+            </a:solidFill>
+            <a:ln w="12700">
+              <a:solidFill>
+                <a:srgbClr val="16243A">
+                  <a:alpha val="0"/>
+                </a:srgbClr>
+              </a:solidFill>
+              <a:prstDash val="solid"/>
+            </a:ln>
+          </p:spPr>
+        </p:sp>
+        <p:sp>
+          <p:nvSpPr>
+            <p:cNvPr id="918" name="Shape 35"/>
+            <p:cNvSpPr/>
+            <p:nvPr/>
+          </p:nvSpPr>
+          <p:spPr>
+            <a:xfrm>
+              <a:off x="9739640" y="3341035"/>
+              <a:ext cx="25283" cy="25283"/>
+            </a:xfrm>
+            <a:prstGeom prst="ellipse">
+              <a:avLst>
+                <a:gd name="adj" fmla="val 361666"/>
+              </a:avLst>
+            </a:prstGeom>
+            <a:solidFill>
+              <a:srgbClr val="16243A"/>
+            </a:solidFill>
+            <a:ln w="12700">
+              <a:solidFill>
+                <a:srgbClr val="16243A">
+                  <a:alpha val="0"/>
+                </a:srgbClr>
+              </a:solidFill>
+              <a:prstDash val="solid"/>
+            </a:ln>
+          </p:spPr>
+        </p:sp>
+        <p:sp>
+          <p:nvSpPr>
+            <p:cNvPr id="919" name="Shape 36"/>
+            <p:cNvSpPr/>
+            <p:nvPr/>
+          </p:nvSpPr>
+          <p:spPr>
+            <a:xfrm>
+              <a:off x="6720840" y="3136392"/>
+              <a:ext cx="411480" cy="420624"/>
+            </a:xfrm>
+            <a:prstGeom prst="ellipse">
+              <a:avLst>
+                <a:gd name="adj" fmla="val 22222"/>
+              </a:avLst>
+            </a:prstGeom>
+            <a:solidFill>
+              <a:srgbClr val="F3C9D8"/>
+            </a:solidFill>
+            <a:ln w="12700">
+              <a:solidFill>
+                <a:srgbClr val="F3C9D8">
+                  <a:alpha val="0"/>
+                </a:srgbClr>
+              </a:solidFill>
+              <a:prstDash val="solid"/>
+            </a:ln>
+          </p:spPr>
+        </p:sp>
+        <p:sp>
+          <p:nvSpPr>
+            <p:cNvPr id="920" name="Shape 37"/>
+            <p:cNvSpPr/>
+            <p:nvPr/>
+          </p:nvSpPr>
+          <p:spPr>
+            <a:xfrm>
+              <a:off x="10561320" y="2916936"/>
+              <a:ext cx="420624" cy="411480"/>
+            </a:xfrm>
+            <a:prstGeom prst="ellipse">
+              <a:avLst>
+                <a:gd name="adj" fmla="val 22222"/>
+              </a:avLst>
+            </a:prstGeom>
+            <a:solidFill>
+              <a:srgbClr val="F2DF9A"/>
+            </a:solidFill>
+            <a:ln w="12700">
+              <a:solidFill>
+                <a:srgbClr val="F2DF9A">
+                  <a:alpha val="0"/>
+                </a:srgbClr>
+              </a:solidFill>
+              <a:prstDash val="solid"/>
+            </a:ln>
+          </p:spPr>
+        </p:sp>
+        <p:sp>
+          <p:nvSpPr>
+            <p:cNvPr id="921" name="Text 38"/>
+            <p:cNvSpPr/>
+            <p:nvPr/>
+          </p:nvSpPr>
+          <p:spPr>
+            <a:xfrm>
+              <a:off x="8357616" y="2660904"/>
+              <a:ext cx="2240280" cy="292608"/>
+            </a:xfrm>
+            <a:prstGeom prst="rect">
+              <a:avLst/>
+            </a:prstGeom>
+            <a:noFill/>
+            <a:ln/>
+          </p:spPr>
+          <p:txBody>
+            <a:bodyPr wrap="square" lIns="0" tIns="0" rIns="0" bIns="0" rtlCol="0" anchor="ctr">
+              <a:normAutofit/>
+            </a:bodyPr>
+            <a:lstStyle/>
+            <a:p>
+              <a:pPr algn="ctr" indent="0" marL="0">
+                <a:buNone/>
+              </a:pPr>
+              <a:r>
+                <a:rPr lang="en-US" sz="900" b="1" dirty="0">
+                  <a:solidFill>
+                    <a:srgbClr val="16243A"/>
+                  </a:solidFill>
+                  <a:latin typeface="Malgun Gothic" pitchFamily="34" charset="0"/>
+                  <a:ea typeface="Malgun Gothic" pitchFamily="34" charset="-122"/>
+                  <a:cs typeface="Malgun Gothic" pitchFamily="34" charset="-120"/>
+                </a:rPr>
+                <a:t>WELCOME!</a:t>
+              </a:r>
+              <a:endParaRPr lang="en-US" sz="900" dirty="0"/>
+            </a:p>
+          </p:txBody>
+        </p:sp>
+      </p:grpSp>
     </p:spTree>
   </p:cSld>
   <p:clrMapOvr>
@@ -9302,18 +10847,54 @@
       </p:sp>
       <p:sp>
         <p:nvSpPr>
-          <p:cNvPr id="5" name="original"/>
+          <p:cNvPr id="5" name="Text 3"/>
+          <p:cNvSpPr txBox="1"/>
+          <p:nvPr/>
+        </p:nvSpPr>
+        <p:spPr>
+          <a:xfrm>
+            <a:off x="548640" y="1965960"/>
+            <a:ext cx="1828800" cy="365760"/>
+          </a:xfrm>
+          <a:prstGeom prst="rect">
+            <a:avLst/>
+          </a:prstGeom>
+          <a:noFill/>
+          <a:ln/>
+        </p:spPr>
+        <p:txBody>
+          <a:bodyPr wrap="square" lIns="0" tIns="0" rIns="0" bIns="0" rtlCol="0" anchor="ctr"/>
+          <a:lstStyle/>
+          <a:p>
+            <a:pPr indent="0" marL="0">
+              <a:buNone/>
+            </a:pPr>
+            <a:r>
+              <a:rPr lang="en-US" sz="1700" b="1" dirty="0">
+                <a:solidFill>
+                  <a:srgbClr val="617287"/>
+                </a:solidFill>
+              </a:rPr>
+              <a:t>원안</a:t>
+            </a:r>
+            <a:endParaRPr lang="en-US" sz="1700" dirty="0"/>
+          </a:p>
+        </p:txBody>
+      </p:sp>
+      <p:sp>
+        <p:nvSpPr>
+          <p:cNvPr id="6" name="original"/>
           <p:cNvSpPr/>
           <p:nvPr/>
         </p:nvSpPr>
         <p:spPr>
           <a:xfrm>
-            <a:off x="548640" y="1965960"/>
-            <a:ext cx="4206240" cy="3794760"/>
+            <a:off x="548640" y="4645152"/>
+            <a:ext cx="4206240" cy="1115568"/>
           </a:xfrm>
           <a:prstGeom prst="roundRect">
             <a:avLst>
-              <a:gd name="adj" fmla="val 2892"/>
+              <a:gd name="adj" fmla="val 9836"/>
             </a:avLst>
           </a:prstGeom>
           <a:solidFill>
@@ -9329,50 +10910,14 @@
       </p:sp>
       <p:sp>
         <p:nvSpPr>
-          <p:cNvPr id="6" name="Text 4"/>
-          <p:cNvSpPr txBox="1"/>
-          <p:nvPr/>
-        </p:nvSpPr>
-        <p:spPr>
-          <a:xfrm>
-            <a:off x="822960" y="2121408"/>
-            <a:ext cx="1828800" cy="365760"/>
-          </a:xfrm>
-          <a:prstGeom prst="rect">
-            <a:avLst/>
-          </a:prstGeom>
-          <a:noFill/>
-          <a:ln/>
-        </p:spPr>
-        <p:txBody>
-          <a:bodyPr wrap="square" lIns="0" tIns="0" rIns="0" bIns="0" rtlCol="0" anchor="ctr"/>
-          <a:lstStyle/>
-          <a:p>
-            <a:pPr indent="0" marL="0">
-              <a:buNone/>
-            </a:pPr>
-            <a:r>
-              <a:rPr lang="en-US" sz="1700" b="1" dirty="0">
-                <a:solidFill>
-                  <a:srgbClr val="617287"/>
-                </a:solidFill>
-              </a:rPr>
-              <a:t>원안</a:t>
-            </a:r>
-            <a:endParaRPr lang="en-US" sz="1700" dirty="0"/>
-          </a:p>
-        </p:txBody>
-      </p:sp>
-      <p:sp>
-        <p:nvSpPr>
           <p:cNvPr id="7" name="chip-4-1"/>
           <p:cNvSpPr txBox="1"/>
           <p:nvPr/>
         </p:nvSpPr>
         <p:spPr>
           <a:xfrm>
-            <a:off x="822960" y="2651760"/>
-            <a:ext cx="566928" cy="292608"/>
+            <a:off x="685800" y="4773168"/>
+            <a:ext cx="502920" cy="292608"/>
           </a:xfrm>
           <a:prstGeom prst="roundRect">
             <a:avLst>
@@ -9411,8 +10956,8 @@
         </p:nvSpPr>
         <p:spPr>
           <a:xfrm>
-            <a:off x="1508760" y="2615184"/>
-            <a:ext cx="3108960" cy="365760"/>
+            <a:off x="1280160" y="4718304"/>
+            <a:ext cx="3383280" cy="457200"/>
           </a:xfrm>
           <a:prstGeom prst="rect">
             <a:avLst/>
@@ -9428,63 +10973,38 @@
               <a:buNone/>
             </a:pPr>
             <a:r>
-              <a:rPr lang="en-US" sz="1500" b="1" dirty="0">
+              <a:rPr lang="en-US" sz="1100" b="1" dirty="0">
                 <a:solidFill>
                   <a:srgbClr val="16243A"/>
                 </a:solidFill>
               </a:rPr>
-              <a:t>퍼레이드 이벤트</a:t>
-            </a:r>
-            <a:endParaRPr lang="en-US" sz="1500" dirty="0"/>
-          </a:p>
-        </p:txBody>
-      </p:sp>
-      <p:sp>
-        <p:nvSpPr>
-          <p:cNvPr id="9" name="Text 7"/>
-          <p:cNvSpPr txBox="1"/>
-          <p:nvPr/>
-        </p:nvSpPr>
-        <p:spPr>
-          <a:xfrm>
-            <a:off x="822960" y="3063240"/>
-            <a:ext cx="3703320" cy="960120"/>
-          </a:xfrm>
-          <a:prstGeom prst="rect">
-            <a:avLst/>
-          </a:prstGeom>
-          <a:noFill/>
-          <a:ln/>
-        </p:spPr>
-        <p:txBody>
-          <a:bodyPr wrap="square" lIns="0" tIns="0" rIns="0" bIns="0" rtlCol="0" anchor="t"/>
-          <a:lstStyle/>
-          <a:p>
+              <a:t>퍼레이드 이벤트  </a:t>
+            </a:r>
             <a:pPr indent="0" marL="0">
               <a:buNone/>
             </a:pPr>
             <a:r>
-              <a:rPr lang="en-US" sz="1300" dirty="0">
+              <a:rPr lang="en-US" sz="1100" dirty="0">
                 <a:solidFill>
                   <a:srgbClr val="617287"/>
                 </a:solidFill>
               </a:rPr>
               <a:t>아이들이 만든 캐릭터들이 광장을 둘러 행진</a:t>
             </a:r>
-            <a:endParaRPr lang="en-US" sz="1300" dirty="0"/>
-          </a:p>
-        </p:txBody>
-      </p:sp>
-      <p:sp>
-        <p:nvSpPr>
-          <p:cNvPr id="10" name="chip-4-2"/>
-          <p:cNvSpPr txBox="1"/>
-          <p:nvPr/>
-        </p:nvSpPr>
-        <p:spPr>
-          <a:xfrm>
-            <a:off x="822960" y="4160520"/>
-            <a:ext cx="566928" cy="292608"/>
+            <a:endParaRPr lang="en-US" sz="1100" dirty="0"/>
+          </a:p>
+        </p:txBody>
+      </p:sp>
+      <p:sp>
+        <p:nvSpPr>
+          <p:cNvPr id="9" name="chip-4-2"/>
+          <p:cNvSpPr txBox="1"/>
+          <p:nvPr/>
+        </p:nvSpPr>
+        <p:spPr>
+          <a:xfrm>
+            <a:off x="685800" y="5276088"/>
+            <a:ext cx="502920" cy="292608"/>
           </a:xfrm>
           <a:prstGeom prst="roundRect">
             <a:avLst>
@@ -9517,79 +11037,54 @@
       </p:sp>
       <p:sp>
         <p:nvSpPr>
+          <p:cNvPr id="10" name="Text 8"/>
+          <p:cNvSpPr txBox="1"/>
+          <p:nvPr/>
+        </p:nvSpPr>
+        <p:spPr>
+          <a:xfrm>
+            <a:off x="1280160" y="5221224"/>
+            <a:ext cx="3383280" cy="457200"/>
+          </a:xfrm>
+          <a:prstGeom prst="rect">
+            <a:avLst/>
+          </a:prstGeom>
+          <a:noFill/>
+          <a:ln/>
+        </p:spPr>
+        <p:txBody>
+          <a:bodyPr wrap="square" lIns="0" tIns="0" rIns="0" bIns="0" rtlCol="0" anchor="ctr"/>
+          <a:lstStyle/>
+          <a:p>
+            <a:pPr indent="0" marL="0">
+              <a:buNone/>
+            </a:pPr>
+            <a:r>
+              <a:rPr lang="en-US" sz="1100" b="1" dirty="0">
+                <a:solidFill>
+                  <a:srgbClr val="16243A"/>
+                </a:solidFill>
+              </a:rPr>
+              <a:t>기존 콘텐츠 연계  </a:t>
+            </a:r>
+            <a:pPr indent="0" marL="0">
+              <a:buNone/>
+            </a:pPr>
+            <a:r>
+              <a:rPr lang="en-US" sz="1100" dirty="0">
+                <a:solidFill>
+                  <a:srgbClr val="617287"/>
+                </a:solidFill>
+              </a:rPr>
+              <a:t>Art: 배경 앞을 지나며 합류 / Logo: 도형 위 · 사이 이동</a:t>
+            </a:r>
+            <a:endParaRPr lang="en-US" sz="1100" dirty="0"/>
+          </a:p>
+        </p:txBody>
+      </p:sp>
+      <p:sp>
+        <p:nvSpPr>
           <p:cNvPr id="11" name="Text 9"/>
-          <p:cNvSpPr txBox="1"/>
-          <p:nvPr/>
-        </p:nvSpPr>
-        <p:spPr>
-          <a:xfrm>
-            <a:off x="1508760" y="4123944"/>
-            <a:ext cx="3108960" cy="365760"/>
-          </a:xfrm>
-          <a:prstGeom prst="rect">
-            <a:avLst/>
-          </a:prstGeom>
-          <a:noFill/>
-          <a:ln/>
-        </p:spPr>
-        <p:txBody>
-          <a:bodyPr wrap="square" lIns="0" tIns="0" rIns="0" bIns="0" rtlCol="0" anchor="ctr"/>
-          <a:lstStyle/>
-          <a:p>
-            <a:pPr indent="0" marL="0">
-              <a:buNone/>
-            </a:pPr>
-            <a:r>
-              <a:rPr lang="en-US" sz="1500" b="1" dirty="0">
-                <a:solidFill>
-                  <a:srgbClr val="16243A"/>
-                </a:solidFill>
-              </a:rPr>
-              <a:t>기존 콘텐츠 연계</a:t>
-            </a:r>
-            <a:endParaRPr lang="en-US" sz="1500" dirty="0"/>
-          </a:p>
-        </p:txBody>
-      </p:sp>
-      <p:sp>
-        <p:nvSpPr>
-          <p:cNvPr id="12" name="Text 10"/>
-          <p:cNvSpPr txBox="1"/>
-          <p:nvPr/>
-        </p:nvSpPr>
-        <p:spPr>
-          <a:xfrm>
-            <a:off x="822960" y="4572000"/>
-            <a:ext cx="3703320" cy="960120"/>
-          </a:xfrm>
-          <a:prstGeom prst="rect">
-            <a:avLst/>
-          </a:prstGeom>
-          <a:noFill/>
-          <a:ln/>
-        </p:spPr>
-        <p:txBody>
-          <a:bodyPr wrap="square" lIns="0" tIns="0" rIns="0" bIns="0" rtlCol="0" anchor="t"/>
-          <a:lstStyle/>
-          <a:p>
-            <a:pPr indent="0" marL="0">
-              <a:buNone/>
-            </a:pPr>
-            <a:r>
-              <a:rPr lang="en-US" sz="1300" dirty="0">
-                <a:solidFill>
-                  <a:srgbClr val="617287"/>
-                </a:solidFill>
-              </a:rPr>
-              <a:t>Art Mode: 미디어아트 배경 앞을 지나가며 합류 · Logo Mode: 도형 위에 올라타거나 도형 사이를 이동</a:t>
-            </a:r>
-            <a:endParaRPr lang="en-US" sz="1300" dirty="0"/>
-          </a:p>
-        </p:txBody>
-      </p:sp>
-      <p:sp>
-        <p:nvSpPr>
-          <p:cNvPr id="13" name="Text 11"/>
           <p:cNvSpPr txBox="1"/>
           <p:nvPr/>
         </p:nvSpPr>
@@ -9625,7 +11120,7 @@
       </p:sp>
       <p:sp>
         <p:nvSpPr>
-          <p:cNvPr id="14" name="prop-0"/>
+          <p:cNvPr id="12" name="prop-0"/>
           <p:cNvSpPr/>
           <p:nvPr/>
         </p:nvSpPr>
@@ -9652,7 +11147,7 @@
       </p:sp>
       <p:sp>
         <p:nvSpPr>
-          <p:cNvPr id="15" name="chip-연출"/>
+          <p:cNvPr id="13" name="chip-연출"/>
           <p:cNvSpPr txBox="1"/>
           <p:nvPr/>
         </p:nvSpPr>
@@ -9692,7 +11187,7 @@
       </p:sp>
       <p:sp>
         <p:nvSpPr>
-          <p:cNvPr id="16" name="Text 14"/>
+          <p:cNvPr id="14" name="Text 12"/>
           <p:cNvSpPr txBox="1"/>
           <p:nvPr/>
         </p:nvSpPr>
@@ -9728,7 +11223,7 @@
       </p:sp>
       <p:sp>
         <p:nvSpPr>
-          <p:cNvPr id="17" name="Text 15"/>
+          <p:cNvPr id="15" name="Text 13"/>
           <p:cNvSpPr txBox="1"/>
           <p:nvPr/>
         </p:nvSpPr>
@@ -9764,7 +11259,7 @@
       </p:sp>
       <p:sp>
         <p:nvSpPr>
-          <p:cNvPr id="18" name="prop-1"/>
+          <p:cNvPr id="16" name="prop-1"/>
           <p:cNvSpPr/>
           <p:nvPr/>
         </p:nvSpPr>
@@ -9791,7 +11286,7 @@
       </p:sp>
       <p:sp>
         <p:nvSpPr>
-          <p:cNvPr id="19" name="chip-연출"/>
+          <p:cNvPr id="17" name="chip-연출"/>
           <p:cNvSpPr txBox="1"/>
           <p:nvPr/>
         </p:nvSpPr>
@@ -9831,7 +11326,7 @@
       </p:sp>
       <p:sp>
         <p:nvSpPr>
-          <p:cNvPr id="20" name="Text 18"/>
+          <p:cNvPr id="18" name="Text 16"/>
           <p:cNvSpPr txBox="1"/>
           <p:nvPr/>
         </p:nvSpPr>
@@ -9867,7 +11362,7 @@
       </p:sp>
       <p:sp>
         <p:nvSpPr>
-          <p:cNvPr id="21" name="Text 19"/>
+          <p:cNvPr id="19" name="Text 17"/>
           <p:cNvSpPr txBox="1"/>
           <p:nvPr/>
         </p:nvSpPr>
@@ -9903,7 +11398,7 @@
       </p:sp>
       <p:sp>
         <p:nvSpPr>
-          <p:cNvPr id="22" name="prop-2"/>
+          <p:cNvPr id="20" name="prop-2"/>
           <p:cNvSpPr/>
           <p:nvPr/>
         </p:nvSpPr>
@@ -9930,7 +11425,7 @@
       </p:sp>
       <p:sp>
         <p:nvSpPr>
-          <p:cNvPr id="23" name="chip-연출"/>
+          <p:cNvPr id="21" name="chip-연출"/>
           <p:cNvSpPr txBox="1"/>
           <p:nvPr/>
         </p:nvSpPr>
@@ -9970,7 +11465,7 @@
       </p:sp>
       <p:sp>
         <p:nvSpPr>
-          <p:cNvPr id="24" name="Text 22"/>
+          <p:cNvPr id="22" name="Text 20"/>
           <p:cNvSpPr txBox="1"/>
           <p:nvPr/>
         </p:nvSpPr>
@@ -10006,7 +11501,7 @@
       </p:sp>
       <p:sp>
         <p:nvSpPr>
-          <p:cNvPr id="25" name="Text 23"/>
+          <p:cNvPr id="23" name="Text 21"/>
           <p:cNvSpPr txBox="1"/>
           <p:nvPr/>
         </p:nvSpPr>
@@ -10042,7 +11537,7 @@
       </p:sp>
       <p:sp>
         <p:nvSpPr>
-          <p:cNvPr id="26" name="prop-3"/>
+          <p:cNvPr id="24" name="prop-3"/>
           <p:cNvSpPr/>
           <p:nvPr/>
         </p:nvSpPr>
@@ -10069,7 +11564,7 @@
       </p:sp>
       <p:sp>
         <p:nvSpPr>
-          <p:cNvPr id="27" name="chip-운영"/>
+          <p:cNvPr id="25" name="chip-운영"/>
           <p:cNvSpPr txBox="1"/>
           <p:nvPr/>
         </p:nvSpPr>
@@ -10109,7 +11604,7 @@
       </p:sp>
       <p:sp>
         <p:nvSpPr>
-          <p:cNvPr id="28" name="Text 26"/>
+          <p:cNvPr id="26" name="Text 24"/>
           <p:cNvSpPr txBox="1"/>
           <p:nvPr/>
         </p:nvSpPr>
@@ -10145,7 +11640,7 @@
       </p:sp>
       <p:sp>
         <p:nvSpPr>
-          <p:cNvPr id="29" name="Text 27"/>
+          <p:cNvPr id="27" name="Text 25"/>
           <p:cNvSpPr txBox="1"/>
           <p:nvPr/>
         </p:nvSpPr>
@@ -10181,7 +11676,7 @@
       </p:sp>
       <p:sp>
         <p:nvSpPr>
-          <p:cNvPr id="30" name="Text 28"/>
+          <p:cNvPr id="28" name="Text 26"/>
           <p:cNvSpPr txBox="1"/>
           <p:nvPr/>
         </p:nvSpPr>
@@ -10271,6 +11766,920 @@
           </a:p>
         </p:txBody>
       </p:sp>
+      <p:grpSp>
+        <p:nvGrpSpPr>
+          <p:cNvPr id="900" name="원안 그림"/>
+          <p:cNvGrpSpPr/>
+          <p:nvPr/>
+        </p:nvGrpSpPr>
+        <p:grpSpPr>
+          <a:xfrm>
+            <a:off x="867395" y="2331720"/>
+            <a:ext cx="3568730" cy="2212848"/>
+            <a:chOff x="6135624" y="2304288"/>
+            <a:chExt cx="5559552" cy="3447288"/>
+          </a:xfrm>
+        </p:grpSpPr>
+        <p:sp>
+          <p:nvSpPr>
+            <p:cNvPr id="901" name="Shape 18"/>
+            <p:cNvSpPr/>
+            <p:nvPr/>
+          </p:nvSpPr>
+          <p:spPr>
+            <a:xfrm>
+              <a:off x="6135624" y="2304288"/>
+              <a:ext cx="5559552" cy="3447288"/>
+            </a:xfrm>
+            <a:prstGeom prst="roundRect">
+              <a:avLst>
+                <a:gd name="adj" fmla="val 2653"/>
+              </a:avLst>
+            </a:prstGeom>
+            <a:solidFill>
+              <a:srgbClr val="16243A"/>
+            </a:solidFill>
+            <a:ln w="12700">
+              <a:solidFill>
+                <a:srgbClr val="16243A">
+                  <a:alpha val="0"/>
+                </a:srgbClr>
+              </a:solidFill>
+              <a:prstDash val="solid"/>
+            </a:ln>
+          </p:spPr>
+        </p:sp>
+        <p:sp>
+          <p:nvSpPr>
+            <p:cNvPr id="902" name="Shape 19"/>
+            <p:cNvSpPr/>
+            <p:nvPr/>
+          </p:nvSpPr>
+          <p:spPr>
+            <a:xfrm>
+              <a:off x="6355080" y="2624328"/>
+              <a:ext cx="621792" cy="2258568"/>
+            </a:xfrm>
+            <a:prstGeom prst="rect">
+              <a:avLst>
+                <a:gd name="adj" fmla="val 14706"/>
+              </a:avLst>
+            </a:prstGeom>
+            <a:solidFill>
+              <a:srgbClr val="2A455B"/>
+            </a:solidFill>
+            <a:ln w="12700">
+              <a:solidFill>
+                <a:srgbClr val="2A455B">
+                  <a:alpha val="0"/>
+                </a:srgbClr>
+              </a:solidFill>
+              <a:prstDash val="solid"/>
+            </a:ln>
+          </p:spPr>
+        </p:sp>
+        <p:sp>
+          <p:nvSpPr>
+            <p:cNvPr id="903" name="Shape 20"/>
+            <p:cNvSpPr/>
+            <p:nvPr/>
+          </p:nvSpPr>
+          <p:spPr>
+            <a:xfrm>
+              <a:off x="7196328" y="2624328"/>
+              <a:ext cx="621792" cy="2258568"/>
+            </a:xfrm>
+            <a:prstGeom prst="rect">
+              <a:avLst>
+                <a:gd name="adj" fmla="val 14706"/>
+              </a:avLst>
+            </a:prstGeom>
+            <a:solidFill>
+              <a:srgbClr val="38526B"/>
+            </a:solidFill>
+            <a:ln w="12700">
+              <a:solidFill>
+                <a:srgbClr val="38526B">
+                  <a:alpha val="0"/>
+                </a:srgbClr>
+              </a:solidFill>
+              <a:prstDash val="solid"/>
+            </a:ln>
+          </p:spPr>
+        </p:sp>
+        <p:sp>
+          <p:nvSpPr>
+            <p:cNvPr id="904" name="Shape 21"/>
+            <p:cNvSpPr/>
+            <p:nvPr/>
+          </p:nvSpPr>
+          <p:spPr>
+            <a:xfrm>
+              <a:off x="8037576" y="2624328"/>
+              <a:ext cx="621792" cy="2258568"/>
+            </a:xfrm>
+            <a:prstGeom prst="rect">
+              <a:avLst>
+                <a:gd name="adj" fmla="val 14706"/>
+              </a:avLst>
+            </a:prstGeom>
+            <a:solidFill>
+              <a:srgbClr val="2A455B"/>
+            </a:solidFill>
+            <a:ln w="12700">
+              <a:solidFill>
+                <a:srgbClr val="2A455B">
+                  <a:alpha val="0"/>
+                </a:srgbClr>
+              </a:solidFill>
+              <a:prstDash val="solid"/>
+            </a:ln>
+          </p:spPr>
+        </p:sp>
+        <p:sp>
+          <p:nvSpPr>
+            <p:cNvPr id="905" name="Shape 22"/>
+            <p:cNvSpPr/>
+            <p:nvPr/>
+          </p:nvSpPr>
+          <p:spPr>
+            <a:xfrm>
+              <a:off x="8878824" y="2624328"/>
+              <a:ext cx="621792" cy="2258568"/>
+            </a:xfrm>
+            <a:prstGeom prst="rect">
+              <a:avLst>
+                <a:gd name="adj" fmla="val 14706"/>
+              </a:avLst>
+            </a:prstGeom>
+            <a:solidFill>
+              <a:srgbClr val="38526B"/>
+            </a:solidFill>
+            <a:ln w="12700">
+              <a:solidFill>
+                <a:srgbClr val="38526B">
+                  <a:alpha val="0"/>
+                </a:srgbClr>
+              </a:solidFill>
+              <a:prstDash val="solid"/>
+            </a:ln>
+          </p:spPr>
+        </p:sp>
+        <p:sp>
+          <p:nvSpPr>
+            <p:cNvPr id="906" name="Shape 23"/>
+            <p:cNvSpPr/>
+            <p:nvPr/>
+          </p:nvSpPr>
+          <p:spPr>
+            <a:xfrm>
+              <a:off x="9720072" y="2624328"/>
+              <a:ext cx="621792" cy="2258568"/>
+            </a:xfrm>
+            <a:prstGeom prst="rect">
+              <a:avLst>
+                <a:gd name="adj" fmla="val 14706"/>
+              </a:avLst>
+            </a:prstGeom>
+            <a:solidFill>
+              <a:srgbClr val="2A455B"/>
+            </a:solidFill>
+            <a:ln w="12700">
+              <a:solidFill>
+                <a:srgbClr val="2A455B">
+                  <a:alpha val="0"/>
+                </a:srgbClr>
+              </a:solidFill>
+              <a:prstDash val="solid"/>
+            </a:ln>
+          </p:spPr>
+        </p:sp>
+        <p:sp>
+          <p:nvSpPr>
+            <p:cNvPr id="907" name="Shape 24"/>
+            <p:cNvSpPr/>
+            <p:nvPr/>
+          </p:nvSpPr>
+          <p:spPr>
+            <a:xfrm>
+              <a:off x="10561320" y="2624328"/>
+              <a:ext cx="621792" cy="2258568"/>
+            </a:xfrm>
+            <a:prstGeom prst="rect">
+              <a:avLst>
+                <a:gd name="adj" fmla="val 14706"/>
+              </a:avLst>
+            </a:prstGeom>
+            <a:solidFill>
+              <a:srgbClr val="38526B"/>
+            </a:solidFill>
+            <a:ln w="12700">
+              <a:solidFill>
+                <a:srgbClr val="38526B">
+                  <a:alpha val="0"/>
+                </a:srgbClr>
+              </a:solidFill>
+              <a:prstDash val="solid"/>
+            </a:ln>
+          </p:spPr>
+        </p:sp>
+        <p:sp>
+          <p:nvSpPr>
+            <p:cNvPr id="908" name="Shape 25"/>
+            <p:cNvSpPr/>
+            <p:nvPr/>
+          </p:nvSpPr>
+          <p:spPr>
+            <a:xfrm>
+              <a:off x="6565392" y="4690872"/>
+              <a:ext cx="4709160" cy="512064"/>
+            </a:xfrm>
+            <a:prstGeom prst="ellipse">
+              <a:avLst>
+                <a:gd name="adj" fmla="val 17857"/>
+              </a:avLst>
+            </a:prstGeom>
+            <a:solidFill>
+              <a:srgbClr val="60778A"/>
+            </a:solidFill>
+            <a:ln w="12700">
+              <a:solidFill>
+                <a:srgbClr val="60778A">
+                  <a:alpha val="0"/>
+                </a:srgbClr>
+              </a:solidFill>
+              <a:prstDash val="solid"/>
+            </a:ln>
+          </p:spPr>
+        </p:sp>
+        <p:sp>
+          <p:nvSpPr>
+            <p:cNvPr id="909" name="Shape 26"/>
+            <p:cNvSpPr/>
+            <p:nvPr/>
+          </p:nvSpPr>
+          <p:spPr>
+            <a:xfrm>
+              <a:off x="7037588" y="3858768"/>
+              <a:ext cx="338328" cy="338328"/>
+            </a:xfrm>
+            <a:prstGeom prst="ellipse">
+              <a:avLst>
+                <a:gd name="adj" fmla="val 27027"/>
+              </a:avLst>
+            </a:prstGeom>
+            <a:solidFill>
+              <a:srgbClr val="FDE6A5"/>
+            </a:solidFill>
+            <a:ln w="12700">
+              <a:solidFill>
+                <a:srgbClr val="FDE6A5">
+                  <a:alpha val="0"/>
+                </a:srgbClr>
+              </a:solidFill>
+              <a:prstDash val="solid"/>
+            </a:ln>
+          </p:spPr>
+        </p:sp>
+        <p:sp>
+          <p:nvSpPr>
+            <p:cNvPr id="910" name="Shape 27"/>
+            <p:cNvSpPr/>
+            <p:nvPr/>
+          </p:nvSpPr>
+          <p:spPr>
+            <a:xfrm rot="10800000">
+              <a:off x="6983456" y="4156497"/>
+              <a:ext cx="460126" cy="514259"/>
+            </a:xfrm>
+            <a:prstGeom prst="arc">
+              <a:avLst>
+                <a:gd name="adj" fmla="val 19873"/>
+              </a:avLst>
+            </a:prstGeom>
+            <a:solidFill>
+              <a:srgbClr val="F7DDE5"/>
+            </a:solidFill>
+            <a:ln w="12700">
+              <a:solidFill>
+                <a:srgbClr val="F7DDE5"/>
+              </a:solidFill>
+              <a:prstDash val="solid"/>
+            </a:ln>
+          </p:spPr>
+        </p:sp>
+        <p:sp>
+          <p:nvSpPr>
+            <p:cNvPr id="911" name="Shape 28"/>
+            <p:cNvSpPr/>
+            <p:nvPr/>
+          </p:nvSpPr>
+          <p:spPr>
+            <a:xfrm>
+              <a:off x="7003755" y="4305361"/>
+              <a:ext cx="372161" cy="67666"/>
+            </a:xfrm>
+            <a:prstGeom prst="line">
+              <a:avLst>
+                <a:gd name="adj" fmla="val 135134"/>
+              </a:avLst>
+            </a:prstGeom>
+            <a:solidFill>
+              <a:srgbClr val="16243A"/>
+            </a:solidFill>
+            <a:ln w="38100">
+              <a:solidFill>
+                <a:srgbClr val="16243A"/>
+              </a:solidFill>
+              <a:prstDash val="solid"/>
+            </a:ln>
+          </p:spPr>
+        </p:sp>
+        <p:sp>
+          <p:nvSpPr>
+            <p:cNvPr id="912" name="Shape 29"/>
+            <p:cNvSpPr/>
+            <p:nvPr/>
+          </p:nvSpPr>
+          <p:spPr>
+            <a:xfrm>
+              <a:off x="7044355" y="4589556"/>
+              <a:ext cx="-94732" cy="243596"/>
+            </a:xfrm>
+            <a:prstGeom prst="line">
+              <a:avLst>
+                <a:gd name="adj" fmla="val -96525"/>
+              </a:avLst>
+            </a:prstGeom>
+            <a:solidFill>
+              <a:srgbClr val="16243A"/>
+            </a:solidFill>
+            <a:ln w="38100">
+              <a:solidFill>
+                <a:srgbClr val="16243A"/>
+              </a:solidFill>
+              <a:prstDash val="solid"/>
+            </a:ln>
+          </p:spPr>
+        </p:sp>
+        <p:sp>
+          <p:nvSpPr>
+            <p:cNvPr id="913" name="Shape 30"/>
+            <p:cNvSpPr/>
+            <p:nvPr/>
+          </p:nvSpPr>
+          <p:spPr>
+            <a:xfrm>
+              <a:off x="7301484" y="4589556"/>
+              <a:ext cx="94732" cy="243596"/>
+            </a:xfrm>
+            <a:prstGeom prst="line">
+              <a:avLst>
+                <a:gd name="adj" fmla="val 96525"/>
+              </a:avLst>
+            </a:prstGeom>
+            <a:solidFill>
+              <a:srgbClr val="16243A"/>
+            </a:solidFill>
+            <a:ln w="38100">
+              <a:solidFill>
+                <a:srgbClr val="16243A"/>
+              </a:solidFill>
+              <a:prstDash val="solid"/>
+            </a:ln>
+          </p:spPr>
+        </p:sp>
+        <p:sp>
+          <p:nvSpPr>
+            <p:cNvPr id="914" name="Shape 31"/>
+            <p:cNvSpPr/>
+            <p:nvPr/>
+          </p:nvSpPr>
+          <p:spPr>
+            <a:xfrm>
+              <a:off x="7125553" y="4007632"/>
+              <a:ext cx="23683" cy="23683"/>
+            </a:xfrm>
+            <a:prstGeom prst="ellipse">
+              <a:avLst>
+                <a:gd name="adj" fmla="val 386100"/>
+              </a:avLst>
+            </a:prstGeom>
+            <a:solidFill>
+              <a:srgbClr val="16243A"/>
+            </a:solidFill>
+            <a:ln w="12700">
+              <a:solidFill>
+                <a:srgbClr val="16243A">
+                  <a:alpha val="0"/>
+                </a:srgbClr>
+              </a:solidFill>
+              <a:prstDash val="solid"/>
+            </a:ln>
+          </p:spPr>
+        </p:sp>
+        <p:sp>
+          <p:nvSpPr>
+            <p:cNvPr id="915" name="Shape 32"/>
+            <p:cNvSpPr/>
+            <p:nvPr/>
+          </p:nvSpPr>
+          <p:spPr>
+            <a:xfrm>
+              <a:off x="7240585" y="4007632"/>
+              <a:ext cx="23683" cy="23683"/>
+            </a:xfrm>
+            <a:prstGeom prst="ellipse">
+              <a:avLst>
+                <a:gd name="adj" fmla="val 386100"/>
+              </a:avLst>
+            </a:prstGeom>
+            <a:solidFill>
+              <a:srgbClr val="16243A"/>
+            </a:solidFill>
+            <a:ln w="12700">
+              <a:solidFill>
+                <a:srgbClr val="16243A">
+                  <a:alpha val="0"/>
+                </a:srgbClr>
+              </a:solidFill>
+              <a:prstDash val="solid"/>
+            </a:ln>
+          </p:spPr>
+        </p:sp>
+        <p:sp>
+          <p:nvSpPr>
+            <p:cNvPr id="916" name="Shape 33"/>
+            <p:cNvSpPr/>
+            <p:nvPr/>
+          </p:nvSpPr>
+          <p:spPr>
+            <a:xfrm>
+              <a:off x="8524403" y="3685032"/>
+              <a:ext cx="384048" cy="384048"/>
+            </a:xfrm>
+            <a:prstGeom prst="ellipse">
+              <a:avLst>
+                <a:gd name="adj" fmla="val 23810"/>
+              </a:avLst>
+            </a:prstGeom>
+            <a:solidFill>
+              <a:srgbClr val="FDE6A5"/>
+            </a:solidFill>
+            <a:ln w="12700">
+              <a:solidFill>
+                <a:srgbClr val="FDE6A5">
+                  <a:alpha val="0"/>
+                </a:srgbClr>
+              </a:solidFill>
+              <a:prstDash val="solid"/>
+            </a:ln>
+          </p:spPr>
+        </p:sp>
+        <p:sp>
+          <p:nvSpPr>
+            <p:cNvPr id="917" name="Shape 34"/>
+            <p:cNvSpPr/>
+            <p:nvPr/>
+          </p:nvSpPr>
+          <p:spPr>
+            <a:xfrm rot="10800000">
+              <a:off x="8462955" y="4022994"/>
+              <a:ext cx="522305" cy="583753"/>
+            </a:xfrm>
+            <a:prstGeom prst="arc">
+              <a:avLst>
+                <a:gd name="adj" fmla="val 17507"/>
+              </a:avLst>
+            </a:prstGeom>
+            <a:solidFill>
+              <a:srgbClr val="F7DDE5"/>
+            </a:solidFill>
+            <a:ln w="12700">
+              <a:solidFill>
+                <a:srgbClr val="F7DDE5"/>
+              </a:solidFill>
+              <a:prstDash val="solid"/>
+            </a:ln>
+          </p:spPr>
+        </p:sp>
+        <p:sp>
+          <p:nvSpPr>
+            <p:cNvPr id="918" name="Shape 35"/>
+            <p:cNvSpPr/>
+            <p:nvPr/>
+          </p:nvSpPr>
+          <p:spPr>
+            <a:xfrm>
+              <a:off x="8485998" y="4191975"/>
+              <a:ext cx="422453" cy="76810"/>
+            </a:xfrm>
+            <a:prstGeom prst="line">
+              <a:avLst>
+                <a:gd name="adj" fmla="val 119047"/>
+              </a:avLst>
+            </a:prstGeom>
+            <a:solidFill>
+              <a:srgbClr val="16243A"/>
+            </a:solidFill>
+            <a:ln w="38100">
+              <a:solidFill>
+                <a:srgbClr val="16243A"/>
+              </a:solidFill>
+              <a:prstDash val="solid"/>
+            </a:ln>
+          </p:spPr>
+        </p:sp>
+        <p:sp>
+          <p:nvSpPr>
+            <p:cNvPr id="919" name="Shape 36"/>
+            <p:cNvSpPr/>
+            <p:nvPr/>
+          </p:nvSpPr>
+          <p:spPr>
+            <a:xfrm>
+              <a:off x="8532084" y="4514576"/>
+              <a:ext cx="-107533" cy="276515"/>
+            </a:xfrm>
+            <a:prstGeom prst="line">
+              <a:avLst>
+                <a:gd name="adj" fmla="val -85034"/>
+              </a:avLst>
+            </a:prstGeom>
+            <a:solidFill>
+              <a:srgbClr val="16243A"/>
+            </a:solidFill>
+            <a:ln w="38100">
+              <a:solidFill>
+                <a:srgbClr val="16243A"/>
+              </a:solidFill>
+              <a:prstDash val="solid"/>
+            </a:ln>
+          </p:spPr>
+        </p:sp>
+        <p:sp>
+          <p:nvSpPr>
+            <p:cNvPr id="920" name="Shape 37"/>
+            <p:cNvSpPr/>
+            <p:nvPr/>
+          </p:nvSpPr>
+          <p:spPr>
+            <a:xfrm>
+              <a:off x="8823960" y="4514576"/>
+              <a:ext cx="107533" cy="276515"/>
+            </a:xfrm>
+            <a:prstGeom prst="line">
+              <a:avLst>
+                <a:gd name="adj" fmla="val 85034"/>
+              </a:avLst>
+            </a:prstGeom>
+            <a:solidFill>
+              <a:srgbClr val="16243A"/>
+            </a:solidFill>
+            <a:ln w="38100">
+              <a:solidFill>
+                <a:srgbClr val="16243A"/>
+              </a:solidFill>
+              <a:prstDash val="solid"/>
+            </a:ln>
+          </p:spPr>
+        </p:sp>
+        <p:sp>
+          <p:nvSpPr>
+            <p:cNvPr id="921" name="Shape 38"/>
+            <p:cNvSpPr/>
+            <p:nvPr/>
+          </p:nvSpPr>
+          <p:spPr>
+            <a:xfrm>
+              <a:off x="8624255" y="3854013"/>
+              <a:ext cx="26883" cy="26883"/>
+            </a:xfrm>
+            <a:prstGeom prst="ellipse">
+              <a:avLst>
+                <a:gd name="adj" fmla="val 340141"/>
+              </a:avLst>
+            </a:prstGeom>
+            <a:solidFill>
+              <a:srgbClr val="16243A"/>
+            </a:solidFill>
+            <a:ln w="12700">
+              <a:solidFill>
+                <a:srgbClr val="16243A">
+                  <a:alpha val="0"/>
+                </a:srgbClr>
+              </a:solidFill>
+              <a:prstDash val="solid"/>
+            </a:ln>
+          </p:spPr>
+        </p:sp>
+        <p:sp>
+          <p:nvSpPr>
+            <p:cNvPr id="922" name="Shape 39"/>
+            <p:cNvSpPr/>
+            <p:nvPr/>
+          </p:nvSpPr>
+          <p:spPr>
+            <a:xfrm>
+              <a:off x="8754831" y="3854013"/>
+              <a:ext cx="26883" cy="26883"/>
+            </a:xfrm>
+            <a:prstGeom prst="ellipse">
+              <a:avLst>
+                <a:gd name="adj" fmla="val 340141"/>
+              </a:avLst>
+            </a:prstGeom>
+            <a:solidFill>
+              <a:srgbClr val="16243A"/>
+            </a:solidFill>
+            <a:ln w="12700">
+              <a:solidFill>
+                <a:srgbClr val="16243A">
+                  <a:alpha val="0"/>
+                </a:srgbClr>
+              </a:solidFill>
+              <a:prstDash val="solid"/>
+            </a:ln>
+          </p:spPr>
+        </p:sp>
+        <p:sp>
+          <p:nvSpPr>
+            <p:cNvPr id="923" name="Shape 40"/>
+            <p:cNvSpPr/>
+            <p:nvPr/>
+          </p:nvSpPr>
+          <p:spPr>
+            <a:xfrm>
+              <a:off x="10134112" y="3840480"/>
+              <a:ext cx="333756" cy="333756"/>
+            </a:xfrm>
+            <a:prstGeom prst="ellipse">
+              <a:avLst>
+                <a:gd name="adj" fmla="val 27397"/>
+              </a:avLst>
+            </a:prstGeom>
+            <a:solidFill>
+              <a:srgbClr val="FDE6A5"/>
+            </a:solidFill>
+            <a:ln w="12700">
+              <a:solidFill>
+                <a:srgbClr val="FDE6A5">
+                  <a:alpha val="0"/>
+                </a:srgbClr>
+              </a:solidFill>
+              <a:prstDash val="solid"/>
+            </a:ln>
+          </p:spPr>
+        </p:sp>
+        <p:sp>
+          <p:nvSpPr>
+            <p:cNvPr id="924" name="Shape 41"/>
+            <p:cNvSpPr/>
+            <p:nvPr/>
+          </p:nvSpPr>
+          <p:spPr>
+            <a:xfrm rot="10800000">
+              <a:off x="10080711" y="4134185"/>
+              <a:ext cx="453908" cy="507309"/>
+            </a:xfrm>
+            <a:prstGeom prst="arc">
+              <a:avLst>
+                <a:gd name="adj" fmla="val 20145"/>
+              </a:avLst>
+            </a:prstGeom>
+            <a:solidFill>
+              <a:srgbClr val="F7DDE5"/>
+            </a:solidFill>
+            <a:ln w="12700">
+              <a:solidFill>
+                <a:srgbClr val="F7DDE5"/>
+              </a:solidFill>
+              <a:prstDash val="solid"/>
+            </a:ln>
+          </p:spPr>
+        </p:sp>
+        <p:sp>
+          <p:nvSpPr>
+            <p:cNvPr id="925" name="Shape 42"/>
+            <p:cNvSpPr/>
+            <p:nvPr/>
+          </p:nvSpPr>
+          <p:spPr>
+            <a:xfrm>
+              <a:off x="10100737" y="4281038"/>
+              <a:ext cx="367132" cy="66751"/>
+            </a:xfrm>
+            <a:prstGeom prst="line">
+              <a:avLst>
+                <a:gd name="adj" fmla="val 136987"/>
+              </a:avLst>
+            </a:prstGeom>
+            <a:solidFill>
+              <a:srgbClr val="16243A"/>
+            </a:solidFill>
+            <a:ln w="38100">
+              <a:solidFill>
+                <a:srgbClr val="16243A"/>
+              </a:solidFill>
+              <a:prstDash val="solid"/>
+            </a:ln>
+          </p:spPr>
+        </p:sp>
+        <p:sp>
+          <p:nvSpPr>
+            <p:cNvPr id="926" name="Shape 43"/>
+            <p:cNvSpPr/>
+            <p:nvPr/>
+          </p:nvSpPr>
+          <p:spPr>
+            <a:xfrm>
+              <a:off x="10140787" y="4561393"/>
+              <a:ext cx="-93452" cy="240304"/>
+            </a:xfrm>
+            <a:prstGeom prst="line">
+              <a:avLst>
+                <a:gd name="adj" fmla="val -97847"/>
+              </a:avLst>
+            </a:prstGeom>
+            <a:solidFill>
+              <a:srgbClr val="16243A"/>
+            </a:solidFill>
+            <a:ln w="38100">
+              <a:solidFill>
+                <a:srgbClr val="16243A"/>
+              </a:solidFill>
+              <a:prstDash val="solid"/>
+            </a:ln>
+          </p:spPr>
+        </p:sp>
+        <p:sp>
+          <p:nvSpPr>
+            <p:cNvPr id="927" name="Shape 44"/>
+            <p:cNvSpPr/>
+            <p:nvPr/>
+          </p:nvSpPr>
+          <p:spPr>
+            <a:xfrm>
+              <a:off x="10394442" y="4561393"/>
+              <a:ext cx="93452" cy="240304"/>
+            </a:xfrm>
+            <a:prstGeom prst="line">
+              <a:avLst>
+                <a:gd name="adj" fmla="val 97847"/>
+              </a:avLst>
+            </a:prstGeom>
+            <a:solidFill>
+              <a:srgbClr val="16243A"/>
+            </a:solidFill>
+            <a:ln w="38100">
+              <a:solidFill>
+                <a:srgbClr val="16243A"/>
+              </a:solidFill>
+              <a:prstDash val="solid"/>
+            </a:ln>
+          </p:spPr>
+        </p:sp>
+        <p:sp>
+          <p:nvSpPr>
+            <p:cNvPr id="928" name="Shape 45"/>
+            <p:cNvSpPr/>
+            <p:nvPr/>
+          </p:nvSpPr>
+          <p:spPr>
+            <a:xfrm>
+              <a:off x="10220889" y="3987333"/>
+              <a:ext cx="23363" cy="23363"/>
+            </a:xfrm>
+            <a:prstGeom prst="ellipse">
+              <a:avLst>
+                <a:gd name="adj" fmla="val 391388"/>
+              </a:avLst>
+            </a:prstGeom>
+            <a:solidFill>
+              <a:srgbClr val="16243A"/>
+            </a:solidFill>
+            <a:ln w="12700">
+              <a:solidFill>
+                <a:srgbClr val="16243A">
+                  <a:alpha val="0"/>
+                </a:srgbClr>
+              </a:solidFill>
+              <a:prstDash val="solid"/>
+            </a:ln>
+          </p:spPr>
+        </p:sp>
+        <p:sp>
+          <p:nvSpPr>
+            <p:cNvPr id="929" name="Shape 46"/>
+            <p:cNvSpPr/>
+            <p:nvPr/>
+          </p:nvSpPr>
+          <p:spPr>
+            <a:xfrm>
+              <a:off x="10334366" y="3987333"/>
+              <a:ext cx="23363" cy="23363"/>
+            </a:xfrm>
+            <a:prstGeom prst="ellipse">
+              <a:avLst>
+                <a:gd name="adj" fmla="val 391388"/>
+              </a:avLst>
+            </a:prstGeom>
+            <a:solidFill>
+              <a:srgbClr val="16243A"/>
+            </a:solidFill>
+            <a:ln w="12700">
+              <a:solidFill>
+                <a:srgbClr val="16243A">
+                  <a:alpha val="0"/>
+                </a:srgbClr>
+              </a:solidFill>
+              <a:prstDash val="solid"/>
+            </a:ln>
+          </p:spPr>
+        </p:sp>
+        <p:sp>
+          <p:nvSpPr>
+            <p:cNvPr id="930" name="Text 47"/>
+            <p:cNvSpPr/>
+            <p:nvPr/>
+          </p:nvSpPr>
+          <p:spPr>
+            <a:xfrm>
+              <a:off x="6885432" y="2779776"/>
+              <a:ext cx="4078224" cy="310896"/>
+            </a:xfrm>
+            <a:prstGeom prst="rect">
+              <a:avLst/>
+            </a:prstGeom>
+            <a:noFill/>
+            <a:ln/>
+          </p:spPr>
+          <p:txBody>
+            <a:bodyPr wrap="square" lIns="0" tIns="0" rIns="0" bIns="0" rtlCol="0" anchor="ctr">
+              <a:normAutofit/>
+            </a:bodyPr>
+            <a:lstStyle/>
+            <a:p>
+              <a:pPr algn="ctr" indent="0" marL="0">
+                <a:buNone/>
+              </a:pPr>
+              <a:r>
+                <a:rPr lang="en-US" sz="800" b="1" dirty="0">
+                  <a:solidFill>
+                    <a:srgbClr val="FFFFFF"/>
+                  </a:solidFill>
+                  <a:latin typeface="Malgun Gothic" pitchFamily="34" charset="0"/>
+                  <a:ea typeface="Malgun Gothic" pitchFamily="34" charset="-122"/>
+                  <a:cs typeface="Malgun Gothic" pitchFamily="34" charset="-120"/>
+                </a:rPr>
+                <a:t>ART MODE  /  LOGO MODE</a:t>
+              </a:r>
+              <a:endParaRPr lang="en-US" sz="800" dirty="0"/>
+            </a:p>
+          </p:txBody>
+        </p:sp>
+        <p:sp>
+          <p:nvSpPr>
+            <p:cNvPr id="931" name="Text 48"/>
+            <p:cNvSpPr/>
+            <p:nvPr/>
+          </p:nvSpPr>
+          <p:spPr>
+            <a:xfrm>
+              <a:off x="7333488" y="5394960"/>
+              <a:ext cx="3108960" cy="228600"/>
+            </a:xfrm>
+            <a:prstGeom prst="rect">
+              <a:avLst/>
+            </a:prstGeom>
+            <a:noFill/>
+            <a:ln/>
+          </p:spPr>
+          <p:txBody>
+            <a:bodyPr wrap="square" lIns="0" tIns="0" rIns="0" bIns="0" rtlCol="0" anchor="ctr">
+              <a:normAutofit/>
+            </a:bodyPr>
+            <a:lstStyle/>
+            <a:p>
+              <a:pPr algn="ctr" indent="0" marL="0">
+                <a:buNone/>
+              </a:pPr>
+              <a:r>
+                <a:rPr lang="en-US" sz="700" dirty="0">
+                  <a:solidFill>
+                    <a:srgbClr val="617287"/>
+                  </a:solidFill>
+                  <a:latin typeface="Malgun Gothic" pitchFamily="34" charset="0"/>
+                  <a:ea typeface="Malgun Gothic" pitchFamily="34" charset="-122"/>
+                  <a:cs typeface="Malgun Gothic" pitchFamily="34" charset="-120"/>
+                </a:rPr>
+                <a:t>CHARACTER PARADE</a:t>
+              </a:r>
+              <a:endParaRPr lang="en-US" sz="700" dirty="0"/>
+            </a:p>
+          </p:txBody>
+        </p:sp>
+      </p:grpSp>
     </p:spTree>
   </p:cSld>
   <p:clrMapOvr>

</xml_diff>

<commit_message>
Fix Live Sketchbook v2 deck file error and make decision options explicit
Co-Authored-By: Claude Opus 5.5 <noreply@anthropic.com>
Claude-Session: https://claude.ai/code/session_011BBjM7b8Q7Xhvjdp6vDPPC
</commit_message>
<xml_diff>
--- a/live-sketchbook/Live_Sketchbook_Experience_Flow_v2.pptx
+++ b/live-sketchbook/Live_Sketchbook_Experience_Flow_v2.pptx
@@ -116,52 +116,52 @@
   <p:extLst>
     <p:ext uri="{521415D9-36F7-43E2-AB2F-B90AF26B5E84}">
       <p14:sectionLst xmlns:p14="http://schemas.microsoft.com/office/powerpoint/2010/main">
-        <p14:section name="표지" id="{7e547541-a37b-c20d-5f74-c902a74868b9}">
+        <p14:section name="표지" id="{a446278a-8485-0b06-32d7-12ce4bdce0cf}">
           <p14:sldIdLst>
             <p14:sldId id="256"/>
           </p14:sldIdLst>
         </p14:section>
-        <p14:section name="요약" id="{26a0530c-a904-bf1d-eba8-2f3eae0d01f0}">
+        <p14:section name="요약" id="{f1d5b4ff-21f7-fcef-ebd6-d698f4ab79fd}">
           <p14:sldIdLst>
             <p14:sldId id="257"/>
           </p14:sldIdLst>
         </p14:section>
-        <p14:section name="검토" id="{cfdc8497-4f98-08fd-fe2d-7ed90ab3c945}">
+        <p14:section name="검토" id="{dea93831-f194-9b7f-7994-2a39f242a98b}">
           <p14:sldIdLst>
             <p14:sldId id="258"/>
           </p14:sldIdLst>
         </p14:section>
-        <p14:section name="01 Drawing" id="{97a6d495-6632-7c3a-c116-834f0a93b5be}">
+        <p14:section name="01 Drawing" id="{510cf7c5-949b-eabe-0845-16408d3bc569}">
           <p14:sldIdLst>
             <p14:sldId id="259"/>
           </p14:sldIdLst>
         </p14:section>
-        <p14:section name="02 Scan" id="{d4f38992-d195-a9fa-d9ec-ec79c5d4523c}">
+        <p14:section name="02 Scan" id="{4b07b914-19f4-2e9e-c34f-4a62a11db927}">
           <p14:sldIdLst>
             <p14:sldId id="260"/>
           </p14:sldIdLst>
         </p14:section>
-        <p14:section name="03 Wall" id="{07eb5e86-e202-bae4-8591-3beba775cf3f}">
+        <p14:section name="03 Wall" id="{e6b20892-cff1-c2f6-6a82-33019b78b3a7}">
           <p14:sldIdLst>
             <p14:sldId id="261"/>
           </p14:sldIdLst>
         </p14:section>
-        <p14:section name="04 Facade" id="{8895220a-406d-f621-078d-45895cda1b3d}">
+        <p14:section name="04 Facade" id="{502f27c5-58c0-2737-201b-3941d4457fe3}">
           <p14:sldIdLst>
             <p14:sldId id="262"/>
           </p14:sldIdLst>
         </p14:section>
-        <p14:section name="05 Archive" id="{14d488d4-7994-9646-f4c5-542902296132}">
+        <p14:section name="05 Archive" id="{7164ae49-243f-3290-4f2c-60c38b3e4556}">
           <p14:sldIdLst>
             <p14:sldId id="263"/>
           </p14:sldIdLst>
         </p14:section>
-        <p14:section name="운영" id="{f895c41b-770a-097c-f945-0036cafa1622}">
+        <p14:section name="운영" id="{0a07e603-bbc1-dd85-78a9-f630f5977a34}">
           <p14:sldIdLst>
             <p14:sldId id="264"/>
           </p14:sldIdLst>
         </p14:section>
-        <p14:section name="다음 단계" id="{8744fe38-25a4-2f70-d746-6aed07e01bcb}">
+        <p14:section name="다음 단계" id="{12a61eed-f4fb-76ab-c4a5-0b0f880f7878}">
           <p14:sldIdLst>
             <p14:sldId id="265"/>
           </p14:sldIdLst>
@@ -658,7 +658,7 @@
           <a:p>
             <a:r>
               <a:rPr lang="en-US" dirty="0"/>
-              <a:t/>
+              <a:t>제안안 근거: ① 처음 요청(도안 없이 자유롭게) ② 처리 시간과 제작 범위 ③ 배경 아이데이션 추천 조합 ④ 광장 이동 동기 + 평소 볼거리 ⑤ 하루 기록이 파사드 마감 쇼와 연결됨. 참고: 배경 아이데이션 https://claude.ai/artifact/D1egd98wfpfk7UxL8675ko · 기존 콘텐츠 연계 https://claude.ai/artifact/8Ly23dXVmzK4ApvdEsQWh9 · 쌓이는 그림 아카이브 https://claude.ai/artifact/V1VBgNDnCrYZTeZJq4ga5x</a:t>
             </a:r>
             <a:endParaRPr lang="en-US" dirty="0"/>
           </a:p>
@@ -2322,7 +2322,7 @@
                   <a:srgbClr val="16243A"/>
                 </a:solidFill>
               </a:rPr>
-              <a:t>결정이 필요한 것 5가지</a:t>
+              <a:t>결정이 필요한 것 | 5가지 중 하나씩 선택</a:t>
             </a:r>
             <a:endParaRPr lang="en-US" sz="3000" dirty="0"/>
           </a:p>
@@ -2360,7 +2360,7 @@
                   <a:srgbClr val="617287"/>
                 </a:solidFill>
               </a:rPr>
-              <a:t>결정 순서대로 정리. 앞의 결정이 뒤의 하드웨어 · 콘텐츠 범위를 정함</a:t>
+              <a:t>초록 테두리는 이 문서의 제안안 · 회의에서 □에 체크해 결정</a:t>
             </a:r>
             <a:endParaRPr lang="en-US" sz="1500" dirty="0"/>
           </a:p>
@@ -2368,18 +2368,92 @@
       </p:sp>
       <p:sp>
         <p:nvSpPr>
-          <p:cNvPr id="4" name="decision-0"/>
+          <p:cNvPr id="4" name="decision-no"/>
+          <p:cNvSpPr txBox="1"/>
+          <p:nvPr/>
+        </p:nvSpPr>
+        <p:spPr>
+          <a:xfrm>
+            <a:off x="548640" y="2029968"/>
+            <a:ext cx="457200" cy="457200"/>
+          </a:xfrm>
+          <a:prstGeom prst="ellipse">
+            <a:avLst/>
+          </a:prstGeom>
+          <a:solidFill>
+            <a:srgbClr val="E8614D"/>
+          </a:solidFill>
+          <a:ln/>
+        </p:spPr>
+        <p:txBody>
+          <a:bodyPr wrap="square" lIns="0" tIns="0" rIns="0" bIns="0" rtlCol="0" anchor="ctr"/>
+          <a:lstStyle/>
+          <a:p>
+            <a:pPr algn="ctr" indent="0" marL="0">
+              <a:buNone/>
+            </a:pPr>
+            <a:r>
+              <a:rPr lang="en-US" sz="1800" b="1" dirty="0">
+                <a:solidFill>
+                  <a:srgbClr val="FFFFFF"/>
+                </a:solidFill>
+              </a:rPr>
+              <a:t>①</a:t>
+            </a:r>
+            <a:endParaRPr lang="en-US" sz="1800" dirty="0"/>
+          </a:p>
+        </p:txBody>
+      </p:sp>
+      <p:sp>
+        <p:nvSpPr>
+          <p:cNvPr id="5" name="Text 3"/>
+          <p:cNvSpPr txBox="1"/>
+          <p:nvPr/>
+        </p:nvSpPr>
+        <p:spPr>
+          <a:xfrm>
+            <a:off x="1143000" y="1984248"/>
+            <a:ext cx="1737360" cy="548640"/>
+          </a:xfrm>
+          <a:prstGeom prst="rect">
+            <a:avLst/>
+          </a:prstGeom>
+          <a:noFill/>
+          <a:ln/>
+        </p:spPr>
+        <p:txBody>
+          <a:bodyPr wrap="square" lIns="0" tIns="0" rIns="0" bIns="0" rtlCol="0" anchor="ctr"/>
+          <a:lstStyle/>
+          <a:p>
+            <a:pPr indent="0" marL="0">
+              <a:buNone/>
+            </a:pPr>
+            <a:r>
+              <a:rPr lang="en-US" sz="1700" b="1" dirty="0">
+                <a:solidFill>
+                  <a:srgbClr val="16243A"/>
+                </a:solidFill>
+              </a:rPr>
+              <a:t>기본 도안</a:t>
+            </a:r>
+            <a:endParaRPr lang="en-US" sz="1700" dirty="0"/>
+          </a:p>
+        </p:txBody>
+      </p:sp>
+      <p:sp>
+        <p:nvSpPr>
+          <p:cNvPr id="6" name="option-0-0"/>
           <p:cNvSpPr/>
           <p:nvPr/>
         </p:nvSpPr>
         <p:spPr>
           <a:xfrm>
-            <a:off x="548640" y="1965960"/>
-            <a:ext cx="3520440" cy="1828800"/>
+            <a:off x="2971800" y="1874520"/>
+            <a:ext cx="2788920" cy="768096"/>
           </a:xfrm>
           <a:prstGeom prst="roundRect">
             <a:avLst>
-              <a:gd name="adj" fmla="val 6000"/>
+              <a:gd name="adj" fmla="val 11905"/>
             </a:avLst>
           </a:prstGeom>
           <a:solidFill>
@@ -2395,52 +2469,75 @@
       </p:sp>
       <p:sp>
         <p:nvSpPr>
-          <p:cNvPr id="5" name="Text 3"/>
-          <p:cNvSpPr txBox="1"/>
-          <p:nvPr/>
-        </p:nvSpPr>
-        <p:spPr>
-          <a:xfrm>
-            <a:off x="777240" y="2194560"/>
-            <a:ext cx="457200" cy="457200"/>
-          </a:xfrm>
-          <a:prstGeom prst="ellipse">
+          <p:cNvPr id="7" name="checkbox"/>
+          <p:cNvSpPr/>
+          <p:nvPr/>
+        </p:nvSpPr>
+        <p:spPr>
+          <a:xfrm>
+            <a:off x="3108960" y="2121408"/>
+            <a:ext cx="237744" cy="237744"/>
+          </a:xfrm>
+          <a:prstGeom prst="rect">
             <a:avLst/>
           </a:prstGeom>
           <a:solidFill>
-            <a:srgbClr val="5DCDC1"/>
+            <a:srgbClr val="FFFFFF"/>
           </a:solidFill>
-          <a:ln/>
-        </p:spPr>
-        <p:txBody>
-          <a:bodyPr wrap="square" lIns="0" tIns="0" rIns="0" bIns="0" rtlCol="0" anchor="ctr"/>
-          <a:lstStyle/>
-          <a:p>
-            <a:pPr algn="ctr" indent="0" marL="0">
-              <a:buNone/>
-            </a:pPr>
-            <a:r>
-              <a:rPr lang="en-US" sz="1700" b="1" dirty="0">
+          <a:ln w="15875">
+            <a:solidFill>
+              <a:srgbClr val="617287"/>
+            </a:solidFill>
+            <a:prstDash val="solid"/>
+          </a:ln>
+        </p:spPr>
+      </p:sp>
+      <p:sp>
+        <p:nvSpPr>
+          <p:cNvPr id="8" name="Text 6"/>
+          <p:cNvSpPr txBox="1"/>
+          <p:nvPr/>
+        </p:nvSpPr>
+        <p:spPr>
+          <a:xfrm>
+            <a:off x="3447288" y="1947672"/>
+            <a:ext cx="2194560" cy="347472"/>
+          </a:xfrm>
+          <a:prstGeom prst="rect">
+            <a:avLst/>
+          </a:prstGeom>
+          <a:noFill/>
+          <a:ln/>
+        </p:spPr>
+        <p:txBody>
+          <a:bodyPr wrap="square" lIns="0" tIns="0" rIns="0" bIns="0" rtlCol="0" anchor="ctr"/>
+          <a:lstStyle/>
+          <a:p>
+            <a:pPr indent="0" marL="0">
+              <a:buNone/>
+            </a:pPr>
+            <a:r>
+              <a:rPr lang="en-US" sz="1300" b="1" dirty="0">
                 <a:solidFill>
                   <a:srgbClr val="16243A"/>
                 </a:solidFill>
               </a:rPr>
-              <a:t>1</a:t>
-            </a:r>
-            <a:endParaRPr lang="en-US" sz="1700" dirty="0"/>
-          </a:p>
-        </p:txBody>
-      </p:sp>
-      <p:sp>
-        <p:nvSpPr>
-          <p:cNvPr id="6" name="Text 4"/>
-          <p:cNvSpPr txBox="1"/>
-          <p:nvPr/>
-        </p:nvSpPr>
-        <p:spPr>
-          <a:xfrm>
-            <a:off x="1417320" y="2194560"/>
-            <a:ext cx="2468880" cy="457200"/>
+              <a:t>A안 전신 가이드</a:t>
+            </a:r>
+            <a:endParaRPr lang="en-US" sz="1300" dirty="0"/>
+          </a:p>
+        </p:txBody>
+      </p:sp>
+      <p:sp>
+        <p:nvSpPr>
+          <p:cNvPr id="9" name="Text 7"/>
+          <p:cNvSpPr txBox="1"/>
+          <p:nvPr/>
+        </p:nvSpPr>
+        <p:spPr>
+          <a:xfrm>
+            <a:off x="3447288" y="2276856"/>
+            <a:ext cx="2194560" cy="292608"/>
           </a:xfrm>
           <a:prstGeom prst="rect">
             <a:avLst/>
@@ -2456,67 +2553,31 @@
               <a:buNone/>
             </a:pPr>
             <a:r>
-              <a:rPr lang="en-US" sz="1700" b="1" dirty="0">
-                <a:solidFill>
-                  <a:srgbClr val="16243A"/>
-                </a:solidFill>
-              </a:rPr>
-              <a:t>기본 도안</a:t>
-            </a:r>
-            <a:endParaRPr lang="en-US" sz="1700" dirty="0"/>
-          </a:p>
-        </p:txBody>
-      </p:sp>
-      <p:sp>
-        <p:nvSpPr>
-          <p:cNvPr id="7" name="Text 5"/>
-          <p:cNvSpPr txBox="1"/>
-          <p:nvPr/>
-        </p:nvSpPr>
-        <p:spPr>
-          <a:xfrm>
-            <a:off x="777240" y="2834640"/>
-            <a:ext cx="3063240" cy="822960"/>
-          </a:xfrm>
-          <a:prstGeom prst="rect">
-            <a:avLst/>
-          </a:prstGeom>
-          <a:noFill/>
-          <a:ln/>
-        </p:spPr>
-        <p:txBody>
-          <a:bodyPr wrap="square" lIns="0" tIns="0" rIns="0" bIns="0" rtlCol="0" anchor="t"/>
-          <a:lstStyle/>
-          <a:p>
-            <a:pPr indent="0" marL="0">
-              <a:buNone/>
-            </a:pPr>
-            <a:r>
-              <a:rPr lang="en-US" sz="1400" dirty="0">
+              <a:rPr lang="en-US" sz="1100" dirty="0">
                 <a:solidFill>
                   <a:srgbClr val="617287"/>
                 </a:solidFill>
               </a:rPr>
-              <a:t>A · B · 자유 그리기 C 중 무엇을 기본으로</a:t>
-            </a:r>
-            <a:endParaRPr lang="en-US" sz="1400" dirty="0"/>
-          </a:p>
-        </p:txBody>
-      </p:sp>
-      <p:sp>
-        <p:nvSpPr>
-          <p:cNvPr id="8" name="decision-1"/>
+              <a:t>얼굴 · 몸통 · 팔 · 다리</a:t>
+            </a:r>
+            <a:endParaRPr lang="en-US" sz="1100" dirty="0"/>
+          </a:p>
+        </p:txBody>
+      </p:sp>
+      <p:sp>
+        <p:nvSpPr>
+          <p:cNvPr id="10" name="option-0-1"/>
           <p:cNvSpPr/>
           <p:nvPr/>
         </p:nvSpPr>
         <p:spPr>
           <a:xfrm>
-            <a:off x="4297680" y="1965960"/>
-            <a:ext cx="3520440" cy="1828800"/>
+            <a:off x="5897880" y="1874520"/>
+            <a:ext cx="2788920" cy="768096"/>
           </a:xfrm>
           <a:prstGeom prst="roundRect">
             <a:avLst>
-              <a:gd name="adj" fmla="val 6000"/>
+              <a:gd name="adj" fmla="val 11905"/>
             </a:avLst>
           </a:prstGeom>
           <a:solidFill>
@@ -2532,17 +2593,240 @@
       </p:sp>
       <p:sp>
         <p:nvSpPr>
-          <p:cNvPr id="9" name="Text 7"/>
-          <p:cNvSpPr txBox="1"/>
-          <p:nvPr/>
-        </p:nvSpPr>
-        <p:spPr>
-          <a:xfrm>
-            <a:off x="4526280" y="2194560"/>
-            <a:ext cx="457200" cy="457200"/>
-          </a:xfrm>
-          <a:prstGeom prst="ellipse">
-            <a:avLst/>
+          <p:cNvPr id="11" name="checkbox"/>
+          <p:cNvSpPr/>
+          <p:nvPr/>
+        </p:nvSpPr>
+        <p:spPr>
+          <a:xfrm>
+            <a:off x="6035040" y="2121408"/>
+            <a:ext cx="237744" cy="237744"/>
+          </a:xfrm>
+          <a:prstGeom prst="rect">
+            <a:avLst/>
+          </a:prstGeom>
+          <a:solidFill>
+            <a:srgbClr val="FFFFFF"/>
+          </a:solidFill>
+          <a:ln w="15875">
+            <a:solidFill>
+              <a:srgbClr val="617287"/>
+            </a:solidFill>
+            <a:prstDash val="solid"/>
+          </a:ln>
+        </p:spPr>
+      </p:sp>
+      <p:sp>
+        <p:nvSpPr>
+          <p:cNvPr id="12" name="Text 10"/>
+          <p:cNvSpPr txBox="1"/>
+          <p:nvPr/>
+        </p:nvSpPr>
+        <p:spPr>
+          <a:xfrm>
+            <a:off x="6373368" y="1947672"/>
+            <a:ext cx="2194560" cy="347472"/>
+          </a:xfrm>
+          <a:prstGeom prst="rect">
+            <a:avLst/>
+          </a:prstGeom>
+          <a:noFill/>
+          <a:ln/>
+        </p:spPr>
+        <p:txBody>
+          <a:bodyPr wrap="square" lIns="0" tIns="0" rIns="0" bIns="0" rtlCol="0" anchor="ctr"/>
+          <a:lstStyle/>
+          <a:p>
+            <a:pPr indent="0" marL="0">
+              <a:buNone/>
+            </a:pPr>
+            <a:r>
+              <a:rPr lang="en-US" sz="1300" b="1" dirty="0">
+                <a:solidFill>
+                  <a:srgbClr val="16243A"/>
+                </a:solidFill>
+              </a:rPr>
+              <a:t>B안 얼굴만</a:t>
+            </a:r>
+            <a:endParaRPr lang="en-US" sz="1300" dirty="0"/>
+          </a:p>
+        </p:txBody>
+      </p:sp>
+      <p:sp>
+        <p:nvSpPr>
+          <p:cNvPr id="13" name="Text 11"/>
+          <p:cNvSpPr txBox="1"/>
+          <p:nvPr/>
+        </p:nvSpPr>
+        <p:spPr>
+          <a:xfrm>
+            <a:off x="6373368" y="2276856"/>
+            <a:ext cx="2194560" cy="292608"/>
+          </a:xfrm>
+          <a:prstGeom prst="rect">
+            <a:avLst/>
+          </a:prstGeom>
+          <a:noFill/>
+          <a:ln/>
+        </p:spPr>
+        <p:txBody>
+          <a:bodyPr wrap="square" lIns="0" tIns="0" rIns="0" bIns="0" rtlCol="0" anchor="ctr"/>
+          <a:lstStyle/>
+          <a:p>
+            <a:pPr indent="0" marL="0">
+              <a:buNone/>
+            </a:pPr>
+            <a:r>
+              <a:rPr lang="en-US" sz="1100" dirty="0">
+                <a:solidFill>
+                  <a:srgbClr val="617287"/>
+                </a:solidFill>
+              </a:rPr>
+              <a:t>심플 가이드</a:t>
+            </a:r>
+            <a:endParaRPr lang="en-US" sz="1100" dirty="0"/>
+          </a:p>
+        </p:txBody>
+      </p:sp>
+      <p:sp>
+        <p:nvSpPr>
+          <p:cNvPr id="14" name="option-0-2"/>
+          <p:cNvSpPr/>
+          <p:nvPr/>
+        </p:nvSpPr>
+        <p:spPr>
+          <a:xfrm>
+            <a:off x="8823960" y="1874520"/>
+            <a:ext cx="2788920" cy="768096"/>
+          </a:xfrm>
+          <a:prstGeom prst="roundRect">
+            <a:avLst>
+              <a:gd name="adj" fmla="val 11905"/>
+            </a:avLst>
+          </a:prstGeom>
+          <a:solidFill>
+            <a:srgbClr val="EAF5F1"/>
+          </a:solidFill>
+          <a:ln w="25400">
+            <a:solidFill>
+              <a:srgbClr val="2B8C83"/>
+            </a:solidFill>
+            <a:prstDash val="solid"/>
+          </a:ln>
+        </p:spPr>
+      </p:sp>
+      <p:sp>
+        <p:nvSpPr>
+          <p:cNvPr id="15" name="checkbox"/>
+          <p:cNvSpPr/>
+          <p:nvPr/>
+        </p:nvSpPr>
+        <p:spPr>
+          <a:xfrm>
+            <a:off x="8961120" y="2121408"/>
+            <a:ext cx="237744" cy="237744"/>
+          </a:xfrm>
+          <a:prstGeom prst="rect">
+            <a:avLst/>
+          </a:prstGeom>
+          <a:solidFill>
+            <a:srgbClr val="FFFFFF"/>
+          </a:solidFill>
+          <a:ln w="15875">
+            <a:solidFill>
+              <a:srgbClr val="2B8C83"/>
+            </a:solidFill>
+            <a:prstDash val="solid"/>
+          </a:ln>
+        </p:spPr>
+      </p:sp>
+      <p:sp>
+        <p:nvSpPr>
+          <p:cNvPr id="16" name="Text 14"/>
+          <p:cNvSpPr txBox="1"/>
+          <p:nvPr/>
+        </p:nvSpPr>
+        <p:spPr>
+          <a:xfrm>
+            <a:off x="9299448" y="1947672"/>
+            <a:ext cx="1600200" cy="347472"/>
+          </a:xfrm>
+          <a:prstGeom prst="rect">
+            <a:avLst/>
+          </a:prstGeom>
+          <a:noFill/>
+          <a:ln/>
+        </p:spPr>
+        <p:txBody>
+          <a:bodyPr wrap="square" lIns="0" tIns="0" rIns="0" bIns="0" rtlCol="0" anchor="ctr"/>
+          <a:lstStyle/>
+          <a:p>
+            <a:pPr indent="0" marL="0">
+              <a:buNone/>
+            </a:pPr>
+            <a:r>
+              <a:rPr lang="en-US" sz="1300" b="1" dirty="0">
+                <a:solidFill>
+                  <a:srgbClr val="16243A"/>
+                </a:solidFill>
+              </a:rPr>
+              <a:t>C안 자유 그리기</a:t>
+            </a:r>
+            <a:endParaRPr lang="en-US" sz="1300" dirty="0"/>
+          </a:p>
+        </p:txBody>
+      </p:sp>
+      <p:sp>
+        <p:nvSpPr>
+          <p:cNvPr id="17" name="Text 15"/>
+          <p:cNvSpPr txBox="1"/>
+          <p:nvPr/>
+        </p:nvSpPr>
+        <p:spPr>
+          <a:xfrm>
+            <a:off x="9299448" y="2276856"/>
+            <a:ext cx="2194560" cy="292608"/>
+          </a:xfrm>
+          <a:prstGeom prst="rect">
+            <a:avLst/>
+          </a:prstGeom>
+          <a:noFill/>
+          <a:ln/>
+        </p:spPr>
+        <p:txBody>
+          <a:bodyPr wrap="square" lIns="0" tIns="0" rIns="0" bIns="0" rtlCol="0" anchor="ctr"/>
+          <a:lstStyle/>
+          <a:p>
+            <a:pPr indent="0" marL="0">
+              <a:buNone/>
+            </a:pPr>
+            <a:r>
+              <a:rPr lang="en-US" sz="1100" dirty="0">
+                <a:solidFill>
+                  <a:srgbClr val="617287"/>
+                </a:solidFill>
+              </a:rPr>
+              <a:t>“도안 없이” 처음 방향</a:t>
+            </a:r>
+            <a:endParaRPr lang="en-US" sz="1100" dirty="0"/>
+          </a:p>
+        </p:txBody>
+      </p:sp>
+      <p:sp>
+        <p:nvSpPr>
+          <p:cNvPr id="18" name="chip-제안"/>
+          <p:cNvSpPr txBox="1"/>
+          <p:nvPr/>
+        </p:nvSpPr>
+        <p:spPr>
+          <a:xfrm>
+            <a:off x="10954512" y="1965960"/>
+            <a:ext cx="548640" cy="292608"/>
+          </a:xfrm>
+          <a:prstGeom prst="roundRect">
+            <a:avLst>
+              <a:gd name="adj" fmla="val 25000"/>
+            </a:avLst>
           </a:prstGeom>
           <a:solidFill>
             <a:srgbClr val="5DCDC1"/>
@@ -2557,12 +2841,86 @@
               <a:buNone/>
             </a:pPr>
             <a:r>
+              <a:rPr lang="en-US" sz="1100" b="1" dirty="0">
+                <a:solidFill>
+                  <a:srgbClr val="16243A"/>
+                </a:solidFill>
+              </a:rPr>
+              <a:t>제안</a:t>
+            </a:r>
+            <a:endParaRPr lang="en-US" sz="1100" dirty="0"/>
+          </a:p>
+        </p:txBody>
+      </p:sp>
+      <p:sp>
+        <p:nvSpPr>
+          <p:cNvPr id="19" name="decision-no"/>
+          <p:cNvSpPr txBox="1"/>
+          <p:nvPr/>
+        </p:nvSpPr>
+        <p:spPr>
+          <a:xfrm>
+            <a:off x="548640" y="2898648"/>
+            <a:ext cx="457200" cy="457200"/>
+          </a:xfrm>
+          <a:prstGeom prst="ellipse">
+            <a:avLst/>
+          </a:prstGeom>
+          <a:solidFill>
+            <a:srgbClr val="E8614D"/>
+          </a:solidFill>
+          <a:ln/>
+        </p:spPr>
+        <p:txBody>
+          <a:bodyPr wrap="square" lIns="0" tIns="0" rIns="0" bIns="0" rtlCol="0" anchor="ctr"/>
+          <a:lstStyle/>
+          <a:p>
+            <a:pPr algn="ctr" indent="0" marL="0">
+              <a:buNone/>
+            </a:pPr>
+            <a:r>
+              <a:rPr lang="en-US" sz="1800" b="1" dirty="0">
+                <a:solidFill>
+                  <a:srgbClr val="FFFFFF"/>
+                </a:solidFill>
+              </a:rPr>
+              <a:t>②</a:t>
+            </a:r>
+            <a:endParaRPr lang="en-US" sz="1800" dirty="0"/>
+          </a:p>
+        </p:txBody>
+      </p:sp>
+      <p:sp>
+        <p:nvSpPr>
+          <p:cNvPr id="20" name="Text 18"/>
+          <p:cNvSpPr txBox="1"/>
+          <p:nvPr/>
+        </p:nvSpPr>
+        <p:spPr>
+          <a:xfrm>
+            <a:off x="1143000" y="2852928"/>
+            <a:ext cx="1737360" cy="548640"/>
+          </a:xfrm>
+          <a:prstGeom prst="rect">
+            <a:avLst/>
+          </a:prstGeom>
+          <a:noFill/>
+          <a:ln/>
+        </p:spPr>
+        <p:txBody>
+          <a:bodyPr wrap="square" lIns="0" tIns="0" rIns="0" bIns="0" rtlCol="0" anchor="ctr"/>
+          <a:lstStyle/>
+          <a:p>
+            <a:pPr indent="0" marL="0">
+              <a:buNone/>
+            </a:pPr>
+            <a:r>
               <a:rPr lang="en-US" sz="1700" b="1" dirty="0">
                 <a:solidFill>
                   <a:srgbClr val="16243A"/>
                 </a:solidFill>
               </a:rPr>
-              <a:t>2</a:t>
+              <a:t>캐릭터 방식</a:t>
             </a:r>
             <a:endParaRPr lang="en-US" sz="1700" dirty="0"/>
           </a:p>
@@ -2570,90 +2928,182 @@
       </p:sp>
       <p:sp>
         <p:nvSpPr>
-          <p:cNvPr id="10" name="Text 8"/>
-          <p:cNvSpPr txBox="1"/>
-          <p:nvPr/>
-        </p:nvSpPr>
-        <p:spPr>
-          <a:xfrm>
-            <a:off x="5166360" y="2194560"/>
-            <a:ext cx="2468880" cy="457200"/>
-          </a:xfrm>
-          <a:prstGeom prst="rect">
-            <a:avLst/>
-          </a:prstGeom>
-          <a:noFill/>
-          <a:ln/>
-        </p:spPr>
-        <p:txBody>
-          <a:bodyPr wrap="square" lIns="0" tIns="0" rIns="0" bIns="0" rtlCol="0" anchor="ctr"/>
-          <a:lstStyle/>
-          <a:p>
-            <a:pPr indent="0" marL="0">
-              <a:buNone/>
-            </a:pPr>
-            <a:r>
-              <a:rPr lang="en-US" sz="1700" b="1" dirty="0">
-                <a:solidFill>
-                  <a:srgbClr val="16243A"/>
-                </a:solidFill>
-              </a:rPr>
-              <a:t>캐릭터 방식</a:t>
-            </a:r>
-            <a:endParaRPr lang="en-US" sz="1700" dirty="0"/>
-          </a:p>
-        </p:txBody>
-      </p:sp>
-      <p:sp>
-        <p:nvSpPr>
-          <p:cNvPr id="11" name="Text 9"/>
-          <p:cNvSpPr txBox="1"/>
-          <p:nvPr/>
-        </p:nvSpPr>
-        <p:spPr>
-          <a:xfrm>
-            <a:off x="4526280" y="2834640"/>
-            <a:ext cx="3063240" cy="822960"/>
-          </a:xfrm>
-          <a:prstGeom prst="rect">
-            <a:avLst/>
-          </a:prstGeom>
-          <a:noFill/>
-          <a:ln/>
-        </p:spPr>
-        <p:txBody>
-          <a:bodyPr wrap="square" lIns="0" tIns="0" rIns="0" bIns="0" rtlCol="0" anchor="t"/>
-          <a:lstStyle/>
-          <a:p>
-            <a:pPr indent="0" marL="0">
-              <a:buNone/>
-            </a:pPr>
-            <a:r>
-              <a:rPr lang="en-US" sz="1400" dirty="0">
-                <a:solidFill>
-                  <a:srgbClr val="617287"/>
-                </a:solidFill>
-              </a:rPr>
-              <a:t>2D 휘기 vs 3D 변환</a:t>
-            </a:r>
-            <a:endParaRPr lang="en-US" sz="1400" dirty="0"/>
-          </a:p>
-        </p:txBody>
-      </p:sp>
-      <p:sp>
-        <p:nvSpPr>
-          <p:cNvPr id="12" name="decision-2"/>
+          <p:cNvPr id="21" name="option-1-0"/>
           <p:cNvSpPr/>
           <p:nvPr/>
         </p:nvSpPr>
         <p:spPr>
           <a:xfrm>
-            <a:off x="8046720" y="1965960"/>
-            <a:ext cx="3520440" cy="1828800"/>
+            <a:off x="2971800" y="2743200"/>
+            <a:ext cx="2788920" cy="768096"/>
           </a:xfrm>
           <a:prstGeom prst="roundRect">
             <a:avLst>
-              <a:gd name="adj" fmla="val 6000"/>
+              <a:gd name="adj" fmla="val 11905"/>
+            </a:avLst>
+          </a:prstGeom>
+          <a:solidFill>
+            <a:srgbClr val="EAF5F1"/>
+          </a:solidFill>
+          <a:ln w="25400">
+            <a:solidFill>
+              <a:srgbClr val="2B8C83"/>
+            </a:solidFill>
+            <a:prstDash val="solid"/>
+          </a:ln>
+        </p:spPr>
+      </p:sp>
+      <p:sp>
+        <p:nvSpPr>
+          <p:cNvPr id="22" name="checkbox"/>
+          <p:cNvSpPr/>
+          <p:nvPr/>
+        </p:nvSpPr>
+        <p:spPr>
+          <a:xfrm>
+            <a:off x="3108960" y="2990088"/>
+            <a:ext cx="237744" cy="237744"/>
+          </a:xfrm>
+          <a:prstGeom prst="rect">
+            <a:avLst/>
+          </a:prstGeom>
+          <a:solidFill>
+            <a:srgbClr val="FFFFFF"/>
+          </a:solidFill>
+          <a:ln w="15875">
+            <a:solidFill>
+              <a:srgbClr val="2B8C83"/>
+            </a:solidFill>
+            <a:prstDash val="solid"/>
+          </a:ln>
+        </p:spPr>
+      </p:sp>
+      <p:sp>
+        <p:nvSpPr>
+          <p:cNvPr id="23" name="Text 21"/>
+          <p:cNvSpPr txBox="1"/>
+          <p:nvPr/>
+        </p:nvSpPr>
+        <p:spPr>
+          <a:xfrm>
+            <a:off x="3447288" y="2816352"/>
+            <a:ext cx="1600200" cy="347472"/>
+          </a:xfrm>
+          <a:prstGeom prst="rect">
+            <a:avLst/>
+          </a:prstGeom>
+          <a:noFill/>
+          <a:ln/>
+        </p:spPr>
+        <p:txBody>
+          <a:bodyPr wrap="square" lIns="0" tIns="0" rIns="0" bIns="0" rtlCol="0" anchor="ctr"/>
+          <a:lstStyle/>
+          <a:p>
+            <a:pPr indent="0" marL="0">
+              <a:buNone/>
+            </a:pPr>
+            <a:r>
+              <a:rPr lang="en-US" sz="1300" b="1" dirty="0">
+                <a:solidFill>
+                  <a:srgbClr val="16243A"/>
+                </a:solidFill>
+              </a:rPr>
+              <a:t>2D 휘기</a:t>
+            </a:r>
+            <a:endParaRPr lang="en-US" sz="1300" dirty="0"/>
+          </a:p>
+        </p:txBody>
+      </p:sp>
+      <p:sp>
+        <p:nvSpPr>
+          <p:cNvPr id="24" name="Text 22"/>
+          <p:cNvSpPr txBox="1"/>
+          <p:nvPr/>
+        </p:nvSpPr>
+        <p:spPr>
+          <a:xfrm>
+            <a:off x="3447288" y="3145536"/>
+            <a:ext cx="2194560" cy="292608"/>
+          </a:xfrm>
+          <a:prstGeom prst="rect">
+            <a:avLst/>
+          </a:prstGeom>
+          <a:noFill/>
+          <a:ln/>
+        </p:spPr>
+        <p:txBody>
+          <a:bodyPr wrap="square" lIns="0" tIns="0" rIns="0" bIns="0" rtlCol="0" anchor="ctr"/>
+          <a:lstStyle/>
+          <a:p>
+            <a:pPr indent="0" marL="0">
+              <a:buNone/>
+            </a:pPr>
+            <a:r>
+              <a:rPr lang="en-US" sz="1100" dirty="0">
+                <a:solidFill>
+                  <a:srgbClr val="617287"/>
+                </a:solidFill>
+              </a:rPr>
+              <a:t>그림 모양 그대로 움직임</a:t>
+            </a:r>
+            <a:endParaRPr lang="en-US" sz="1100" dirty="0"/>
+          </a:p>
+        </p:txBody>
+      </p:sp>
+      <p:sp>
+        <p:nvSpPr>
+          <p:cNvPr id="25" name="chip-제안"/>
+          <p:cNvSpPr txBox="1"/>
+          <p:nvPr/>
+        </p:nvSpPr>
+        <p:spPr>
+          <a:xfrm>
+            <a:off x="5102352" y="2834640"/>
+            <a:ext cx="548640" cy="292608"/>
+          </a:xfrm>
+          <a:prstGeom prst="roundRect">
+            <a:avLst>
+              <a:gd name="adj" fmla="val 25000"/>
+            </a:avLst>
+          </a:prstGeom>
+          <a:solidFill>
+            <a:srgbClr val="5DCDC1"/>
+          </a:solidFill>
+          <a:ln/>
+        </p:spPr>
+        <p:txBody>
+          <a:bodyPr wrap="square" lIns="0" tIns="0" rIns="0" bIns="0" rtlCol="0" anchor="ctr"/>
+          <a:lstStyle/>
+          <a:p>
+            <a:pPr algn="ctr" indent="0" marL="0">
+              <a:buNone/>
+            </a:pPr>
+            <a:r>
+              <a:rPr lang="en-US" sz="1100" b="1" dirty="0">
+                <a:solidFill>
+                  <a:srgbClr val="16243A"/>
+                </a:solidFill>
+              </a:rPr>
+              <a:t>제안</a:t>
+            </a:r>
+            <a:endParaRPr lang="en-US" sz="1100" dirty="0"/>
+          </a:p>
+        </p:txBody>
+      </p:sp>
+      <p:sp>
+        <p:nvSpPr>
+          <p:cNvPr id="26" name="option-1-1"/>
+          <p:cNvSpPr/>
+          <p:nvPr/>
+        </p:nvSpPr>
+        <p:spPr>
+          <a:xfrm>
+            <a:off x="5897880" y="2743200"/>
+            <a:ext cx="2788920" cy="768096"/>
+          </a:xfrm>
+          <a:prstGeom prst="roundRect">
+            <a:avLst>
+              <a:gd name="adj" fmla="val 11905"/>
             </a:avLst>
           </a:prstGeom>
           <a:solidFill>
@@ -2669,52 +3119,75 @@
       </p:sp>
       <p:sp>
         <p:nvSpPr>
-          <p:cNvPr id="13" name="Text 11"/>
-          <p:cNvSpPr txBox="1"/>
-          <p:nvPr/>
-        </p:nvSpPr>
-        <p:spPr>
-          <a:xfrm>
-            <a:off x="8275320" y="2194560"/>
-            <a:ext cx="457200" cy="457200"/>
-          </a:xfrm>
-          <a:prstGeom prst="ellipse">
+          <p:cNvPr id="27" name="checkbox"/>
+          <p:cNvSpPr/>
+          <p:nvPr/>
+        </p:nvSpPr>
+        <p:spPr>
+          <a:xfrm>
+            <a:off x="6035040" y="2990088"/>
+            <a:ext cx="237744" cy="237744"/>
+          </a:xfrm>
+          <a:prstGeom prst="rect">
             <a:avLst/>
           </a:prstGeom>
           <a:solidFill>
-            <a:srgbClr val="5DCDC1"/>
+            <a:srgbClr val="FFFFFF"/>
           </a:solidFill>
-          <a:ln/>
-        </p:spPr>
-        <p:txBody>
-          <a:bodyPr wrap="square" lIns="0" tIns="0" rIns="0" bIns="0" rtlCol="0" anchor="ctr"/>
-          <a:lstStyle/>
-          <a:p>
-            <a:pPr algn="ctr" indent="0" marL="0">
-              <a:buNone/>
-            </a:pPr>
-            <a:r>
-              <a:rPr lang="en-US" sz="1700" b="1" dirty="0">
+          <a:ln w="15875">
+            <a:solidFill>
+              <a:srgbClr val="617287"/>
+            </a:solidFill>
+            <a:prstDash val="solid"/>
+          </a:ln>
+        </p:spPr>
+      </p:sp>
+      <p:sp>
+        <p:nvSpPr>
+          <p:cNvPr id="28" name="Text 26"/>
+          <p:cNvSpPr txBox="1"/>
+          <p:nvPr/>
+        </p:nvSpPr>
+        <p:spPr>
+          <a:xfrm>
+            <a:off x="6373368" y="2816352"/>
+            <a:ext cx="2194560" cy="347472"/>
+          </a:xfrm>
+          <a:prstGeom prst="rect">
+            <a:avLst/>
+          </a:prstGeom>
+          <a:noFill/>
+          <a:ln/>
+        </p:spPr>
+        <p:txBody>
+          <a:bodyPr wrap="square" lIns="0" tIns="0" rIns="0" bIns="0" rtlCol="0" anchor="ctr"/>
+          <a:lstStyle/>
+          <a:p>
+            <a:pPr indent="0" marL="0">
+              <a:buNone/>
+            </a:pPr>
+            <a:r>
+              <a:rPr lang="en-US" sz="1300" b="1" dirty="0">
                 <a:solidFill>
                   <a:srgbClr val="16243A"/>
                 </a:solidFill>
               </a:rPr>
-              <a:t>3</a:t>
-            </a:r>
-            <a:endParaRPr lang="en-US" sz="1700" dirty="0"/>
-          </a:p>
-        </p:txBody>
-      </p:sp>
-      <p:sp>
-        <p:nvSpPr>
-          <p:cNvPr id="14" name="Text 12"/>
-          <p:cNvSpPr txBox="1"/>
-          <p:nvPr/>
-        </p:nvSpPr>
-        <p:spPr>
-          <a:xfrm>
-            <a:off x="8915400" y="2194560"/>
-            <a:ext cx="2468880" cy="457200"/>
+              <a:t>3D 변환</a:t>
+            </a:r>
+            <a:endParaRPr lang="en-US" sz="1300" dirty="0"/>
+          </a:p>
+        </p:txBody>
+      </p:sp>
+      <p:sp>
+        <p:nvSpPr>
+          <p:cNvPr id="29" name="Text 27"/>
+          <p:cNvSpPr txBox="1"/>
+          <p:nvPr/>
+        </p:nvSpPr>
+        <p:spPr>
+          <a:xfrm>
+            <a:off x="6373368" y="3145536"/>
+            <a:ext cx="2194560" cy="292608"/>
           </a:xfrm>
           <a:prstGeom prst="rect">
             <a:avLst/>
@@ -2730,67 +3203,31 @@
               <a:buNone/>
             </a:pPr>
             <a:r>
-              <a:rPr lang="en-US" sz="1700" b="1" dirty="0">
-                <a:solidFill>
-                  <a:srgbClr val="16243A"/>
-                </a:solidFill>
-              </a:rPr>
-              <a:t>배경 방식</a:t>
-            </a:r>
-            <a:endParaRPr lang="en-US" sz="1700" dirty="0"/>
-          </a:p>
-        </p:txBody>
-      </p:sp>
-      <p:sp>
-        <p:nvSpPr>
-          <p:cNvPr id="15" name="Text 13"/>
-          <p:cNvSpPr txBox="1"/>
-          <p:nvPr/>
-        </p:nvSpPr>
-        <p:spPr>
-          <a:xfrm>
-            <a:off x="8275320" y="2834640"/>
-            <a:ext cx="3063240" cy="822960"/>
-          </a:xfrm>
-          <a:prstGeom prst="rect">
-            <a:avLst/>
-          </a:prstGeom>
-          <a:noFill/>
-          <a:ln/>
-        </p:spPr>
-        <p:txBody>
-          <a:bodyPr wrap="square" lIns="0" tIns="0" rIns="0" bIns="0" rtlCol="0" anchor="t"/>
-          <a:lstStyle/>
-          <a:p>
-            <a:pPr indent="0" marL="0">
-              <a:buNone/>
-            </a:pPr>
-            <a:r>
-              <a:rPr lang="en-US" sz="1400" dirty="0">
+              <a:rPr lang="en-US" sz="1100" dirty="0">
                 <a:solidFill>
                   <a:srgbClr val="617287"/>
                 </a:solidFill>
               </a:rPr>
-              <a:t>벽에서 그림이 배경에 붙는 방식(B1–B6 중)</a:t>
-            </a:r>
-            <a:endParaRPr lang="en-US" sz="1400" dirty="0"/>
-          </a:p>
-        </p:txBody>
-      </p:sp>
-      <p:sp>
-        <p:nvSpPr>
-          <p:cNvPr id="16" name="decision-3"/>
+              <a:t>품질 · 시간 검증 필요</a:t>
+            </a:r>
+            <a:endParaRPr lang="en-US" sz="1100" dirty="0"/>
+          </a:p>
+        </p:txBody>
+      </p:sp>
+      <p:sp>
+        <p:nvSpPr>
+          <p:cNvPr id="30" name="option-1-2"/>
           <p:cNvSpPr/>
           <p:nvPr/>
         </p:nvSpPr>
         <p:spPr>
           <a:xfrm>
-            <a:off x="548640" y="4023360"/>
-            <a:ext cx="3520440" cy="1828800"/>
+            <a:off x="8823960" y="2743200"/>
+            <a:ext cx="2788920" cy="768096"/>
           </a:xfrm>
           <a:prstGeom prst="roundRect">
             <a:avLst>
-              <a:gd name="adj" fmla="val 6000"/>
+              <a:gd name="adj" fmla="val 11905"/>
             </a:avLst>
           </a:prstGeom>
           <a:solidFill>
@@ -2806,17 +3243,314 @@
       </p:sp>
       <p:sp>
         <p:nvSpPr>
-          <p:cNvPr id="17" name="Text 15"/>
-          <p:cNvSpPr txBox="1"/>
-          <p:nvPr/>
-        </p:nvSpPr>
-        <p:spPr>
-          <a:xfrm>
-            <a:off x="777240" y="4251960"/>
+          <p:cNvPr id="31" name="checkbox"/>
+          <p:cNvSpPr/>
+          <p:nvPr/>
+        </p:nvSpPr>
+        <p:spPr>
+          <a:xfrm>
+            <a:off x="8961120" y="2990088"/>
+            <a:ext cx="237744" cy="237744"/>
+          </a:xfrm>
+          <a:prstGeom prst="rect">
+            <a:avLst/>
+          </a:prstGeom>
+          <a:solidFill>
+            <a:srgbClr val="FFFFFF"/>
+          </a:solidFill>
+          <a:ln w="15875">
+            <a:solidFill>
+              <a:srgbClr val="617287"/>
+            </a:solidFill>
+            <a:prstDash val="solid"/>
+          </a:ln>
+        </p:spPr>
+      </p:sp>
+      <p:sp>
+        <p:nvSpPr>
+          <p:cNvPr id="32" name="Text 30"/>
+          <p:cNvSpPr txBox="1"/>
+          <p:nvPr/>
+        </p:nvSpPr>
+        <p:spPr>
+          <a:xfrm>
+            <a:off x="9299448" y="2816352"/>
+            <a:ext cx="2194560" cy="347472"/>
+          </a:xfrm>
+          <a:prstGeom prst="rect">
+            <a:avLst/>
+          </a:prstGeom>
+          <a:noFill/>
+          <a:ln/>
+        </p:spPr>
+        <p:txBody>
+          <a:bodyPr wrap="square" lIns="0" tIns="0" rIns="0" bIns="0" rtlCol="0" anchor="ctr"/>
+          <a:lstStyle/>
+          <a:p>
+            <a:pPr indent="0" marL="0">
+              <a:buNone/>
+            </a:pPr>
+            <a:r>
+              <a:rPr lang="en-US" sz="1300" b="1" dirty="0">
+                <a:solidFill>
+                  <a:srgbClr val="16243A"/>
+                </a:solidFill>
+              </a:rPr>
+              <a:t>2D 시작 → 3D 추가</a:t>
+            </a:r>
+            <a:endParaRPr lang="en-US" sz="1300" dirty="0"/>
+          </a:p>
+        </p:txBody>
+      </p:sp>
+      <p:sp>
+        <p:nvSpPr>
+          <p:cNvPr id="33" name="Text 31"/>
+          <p:cNvSpPr txBox="1"/>
+          <p:nvPr/>
+        </p:nvSpPr>
+        <p:spPr>
+          <a:xfrm>
+            <a:off x="9299448" y="3145536"/>
+            <a:ext cx="2194560" cy="292608"/>
+          </a:xfrm>
+          <a:prstGeom prst="rect">
+            <a:avLst/>
+          </a:prstGeom>
+          <a:noFill/>
+          <a:ln/>
+        </p:spPr>
+        <p:txBody>
+          <a:bodyPr wrap="square" lIns="0" tIns="0" rIns="0" bIns="0" rtlCol="0" anchor="ctr"/>
+          <a:lstStyle/>
+          <a:p>
+            <a:pPr indent="0" marL="0">
+              <a:buNone/>
+            </a:pPr>
+            <a:r>
+              <a:rPr lang="en-US" sz="1100" dirty="0">
+                <a:solidFill>
+                  <a:srgbClr val="617287"/>
+                </a:solidFill>
+              </a:rPr>
+              <a:t>단계적 도입</a:t>
+            </a:r>
+            <a:endParaRPr lang="en-US" sz="1100" dirty="0"/>
+          </a:p>
+        </p:txBody>
+      </p:sp>
+      <p:sp>
+        <p:nvSpPr>
+          <p:cNvPr id="34" name="decision-no"/>
+          <p:cNvSpPr txBox="1"/>
+          <p:nvPr/>
+        </p:nvSpPr>
+        <p:spPr>
+          <a:xfrm>
+            <a:off x="548640" y="3767328"/>
             <a:ext cx="457200" cy="457200"/>
           </a:xfrm>
           <a:prstGeom prst="ellipse">
             <a:avLst/>
+          </a:prstGeom>
+          <a:solidFill>
+            <a:srgbClr val="E8614D"/>
+          </a:solidFill>
+          <a:ln/>
+        </p:spPr>
+        <p:txBody>
+          <a:bodyPr wrap="square" lIns="0" tIns="0" rIns="0" bIns="0" rtlCol="0" anchor="ctr"/>
+          <a:lstStyle/>
+          <a:p>
+            <a:pPr algn="ctr" indent="0" marL="0">
+              <a:buNone/>
+            </a:pPr>
+            <a:r>
+              <a:rPr lang="en-US" sz="1800" b="1" dirty="0">
+                <a:solidFill>
+                  <a:srgbClr val="FFFFFF"/>
+                </a:solidFill>
+              </a:rPr>
+              <a:t>③</a:t>
+            </a:r>
+            <a:endParaRPr lang="en-US" sz="1800" dirty="0"/>
+          </a:p>
+        </p:txBody>
+      </p:sp>
+      <p:sp>
+        <p:nvSpPr>
+          <p:cNvPr id="35" name="Text 33"/>
+          <p:cNvSpPr txBox="1"/>
+          <p:nvPr/>
+        </p:nvSpPr>
+        <p:spPr>
+          <a:xfrm>
+            <a:off x="1143000" y="3721608"/>
+            <a:ext cx="1737360" cy="548640"/>
+          </a:xfrm>
+          <a:prstGeom prst="rect">
+            <a:avLst/>
+          </a:prstGeom>
+          <a:noFill/>
+          <a:ln/>
+        </p:spPr>
+        <p:txBody>
+          <a:bodyPr wrap="square" lIns="0" tIns="0" rIns="0" bIns="0" rtlCol="0" anchor="ctr"/>
+          <a:lstStyle/>
+          <a:p>
+            <a:pPr indent="0" marL="0">
+              <a:buNone/>
+            </a:pPr>
+            <a:r>
+              <a:rPr lang="en-US" sz="1700" b="1" dirty="0">
+                <a:solidFill>
+                  <a:srgbClr val="16243A"/>
+                </a:solidFill>
+              </a:rPr>
+              <a:t>배경 방식</a:t>
+            </a:r>
+            <a:endParaRPr lang="en-US" sz="1700" dirty="0"/>
+          </a:p>
+        </p:txBody>
+      </p:sp>
+      <p:sp>
+        <p:nvSpPr>
+          <p:cNvPr id="36" name="option-2-0"/>
+          <p:cNvSpPr/>
+          <p:nvPr/>
+        </p:nvSpPr>
+        <p:spPr>
+          <a:xfrm>
+            <a:off x="2971800" y="3611880"/>
+            <a:ext cx="2788920" cy="768096"/>
+          </a:xfrm>
+          <a:prstGeom prst="roundRect">
+            <a:avLst>
+              <a:gd name="adj" fmla="val 11905"/>
+            </a:avLst>
+          </a:prstGeom>
+          <a:solidFill>
+            <a:srgbClr val="EAF5F1"/>
+          </a:solidFill>
+          <a:ln w="25400">
+            <a:solidFill>
+              <a:srgbClr val="2B8C83"/>
+            </a:solidFill>
+            <a:prstDash val="solid"/>
+          </a:ln>
+        </p:spPr>
+      </p:sp>
+      <p:sp>
+        <p:nvSpPr>
+          <p:cNvPr id="37" name="checkbox"/>
+          <p:cNvSpPr/>
+          <p:nvPr/>
+        </p:nvSpPr>
+        <p:spPr>
+          <a:xfrm>
+            <a:off x="3108960" y="3858768"/>
+            <a:ext cx="237744" cy="237744"/>
+          </a:xfrm>
+          <a:prstGeom prst="rect">
+            <a:avLst/>
+          </a:prstGeom>
+          <a:solidFill>
+            <a:srgbClr val="FFFFFF"/>
+          </a:solidFill>
+          <a:ln w="15875">
+            <a:solidFill>
+              <a:srgbClr val="2B8C83"/>
+            </a:solidFill>
+            <a:prstDash val="solid"/>
+          </a:ln>
+        </p:spPr>
+      </p:sp>
+      <p:sp>
+        <p:nvSpPr>
+          <p:cNvPr id="38" name="Text 36"/>
+          <p:cNvSpPr txBox="1"/>
+          <p:nvPr/>
+        </p:nvSpPr>
+        <p:spPr>
+          <a:xfrm>
+            <a:off x="3447288" y="3685032"/>
+            <a:ext cx="1600200" cy="347472"/>
+          </a:xfrm>
+          <a:prstGeom prst="rect">
+            <a:avLst/>
+          </a:prstGeom>
+          <a:noFill/>
+          <a:ln/>
+        </p:spPr>
+        <p:txBody>
+          <a:bodyPr wrap="square" lIns="0" tIns="0" rIns="0" bIns="0" rtlCol="0" anchor="ctr"/>
+          <a:lstStyle/>
+          <a:p>
+            <a:pPr indent="0" marL="0">
+              <a:buNone/>
+            </a:pPr>
+            <a:r>
+              <a:rPr lang="en-US" sz="1300" b="1" dirty="0">
+                <a:solidFill>
+                  <a:srgbClr val="16243A"/>
+                </a:solidFill>
+              </a:rPr>
+              <a:t>톤 통일 + 빈칸</a:t>
+            </a:r>
+            <a:endParaRPr lang="en-US" sz="1300" dirty="0"/>
+          </a:p>
+        </p:txBody>
+      </p:sp>
+      <p:sp>
+        <p:nvSpPr>
+          <p:cNvPr id="39" name="Text 37"/>
+          <p:cNvSpPr txBox="1"/>
+          <p:nvPr/>
+        </p:nvSpPr>
+        <p:spPr>
+          <a:xfrm>
+            <a:off x="3447288" y="4014216"/>
+            <a:ext cx="2194560" cy="292608"/>
+          </a:xfrm>
+          <a:prstGeom prst="rect">
+            <a:avLst/>
+          </a:prstGeom>
+          <a:noFill/>
+          <a:ln/>
+        </p:spPr>
+        <p:txBody>
+          <a:bodyPr wrap="square" lIns="0" tIns="0" rIns="0" bIns="0" rtlCol="0" anchor="ctr"/>
+          <a:lstStyle/>
+          <a:p>
+            <a:pPr indent="0" marL="0">
+              <a:buNone/>
+            </a:pPr>
+            <a:r>
+              <a:rPr lang="en-US" sz="1100" dirty="0">
+                <a:solidFill>
+                  <a:srgbClr val="617287"/>
+                </a:solidFill>
+              </a:rPr>
+              <a:t>B4 + B1 (배경 아이데이션)</a:t>
+            </a:r>
+            <a:endParaRPr lang="en-US" sz="1100" dirty="0"/>
+          </a:p>
+        </p:txBody>
+      </p:sp>
+      <p:sp>
+        <p:nvSpPr>
+          <p:cNvPr id="40" name="chip-제안"/>
+          <p:cNvSpPr txBox="1"/>
+          <p:nvPr/>
+        </p:nvSpPr>
+        <p:spPr>
+          <a:xfrm>
+            <a:off x="5102352" y="3703320"/>
+            <a:ext cx="548640" cy="292608"/>
+          </a:xfrm>
+          <a:prstGeom prst="roundRect">
+            <a:avLst>
+              <a:gd name="adj" fmla="val 25000"/>
+            </a:avLst>
           </a:prstGeom>
           <a:solidFill>
             <a:srgbClr val="5DCDC1"/>
@@ -2831,103 +3565,31 @@
               <a:buNone/>
             </a:pPr>
             <a:r>
-              <a:rPr lang="en-US" sz="1700" b="1" dirty="0">
+              <a:rPr lang="en-US" sz="1100" b="1" dirty="0">
                 <a:solidFill>
                   <a:srgbClr val="16243A"/>
                 </a:solidFill>
               </a:rPr>
-              <a:t>4</a:t>
-            </a:r>
-            <a:endParaRPr lang="en-US" sz="1700" dirty="0"/>
-          </a:p>
-        </p:txBody>
-      </p:sp>
-      <p:sp>
-        <p:nvSpPr>
-          <p:cNvPr id="18" name="Text 16"/>
-          <p:cNvSpPr txBox="1"/>
-          <p:nvPr/>
-        </p:nvSpPr>
-        <p:spPr>
-          <a:xfrm>
-            <a:off x="1417320" y="4251960"/>
-            <a:ext cx="2468880" cy="457200"/>
-          </a:xfrm>
-          <a:prstGeom prst="rect">
-            <a:avLst/>
-          </a:prstGeom>
-          <a:noFill/>
-          <a:ln/>
-        </p:spPr>
-        <p:txBody>
-          <a:bodyPr wrap="square" lIns="0" tIns="0" rIns="0" bIns="0" rtlCol="0" anchor="ctr"/>
-          <a:lstStyle/>
-          <a:p>
-            <a:pPr indent="0" marL="0">
-              <a:buNone/>
-            </a:pPr>
-            <a:r>
-              <a:rPr lang="en-US" sz="1700" b="1" dirty="0">
-                <a:solidFill>
-                  <a:srgbClr val="16243A"/>
-                </a:solidFill>
-              </a:rPr>
-              <a:t>퍼레이드 운영</a:t>
-            </a:r>
-            <a:endParaRPr lang="en-US" sz="1700" dirty="0"/>
-          </a:p>
-        </p:txBody>
-      </p:sp>
-      <p:sp>
-        <p:nvSpPr>
-          <p:cNvPr id="19" name="Text 17"/>
-          <p:cNvSpPr txBox="1"/>
-          <p:nvPr/>
-        </p:nvSpPr>
-        <p:spPr>
-          <a:xfrm>
-            <a:off x="777240" y="4892040"/>
-            <a:ext cx="3063240" cy="822960"/>
-          </a:xfrm>
-          <a:prstGeom prst="rect">
-            <a:avLst/>
-          </a:prstGeom>
-          <a:noFill/>
-          <a:ln/>
-        </p:spPr>
-        <p:txBody>
-          <a:bodyPr wrap="square" lIns="0" tIns="0" rIns="0" bIns="0" rtlCol="0" anchor="t"/>
-          <a:lstStyle/>
-          <a:p>
-            <a:pPr indent="0" marL="0">
-              <a:buNone/>
-            </a:pPr>
-            <a:r>
-              <a:rPr lang="en-US" sz="1400" dirty="0">
-                <a:solidFill>
-                  <a:srgbClr val="617287"/>
-                </a:solidFill>
-              </a:rPr>
-              <a:t>정시 주기와 길이, Art/Logo 모드 비율</a:t>
-            </a:r>
-            <a:endParaRPr lang="en-US" sz="1400" dirty="0"/>
-          </a:p>
-        </p:txBody>
-      </p:sp>
-      <p:sp>
-        <p:nvSpPr>
-          <p:cNvPr id="20" name="decision-4"/>
+              <a:t>제안</a:t>
+            </a:r>
+            <a:endParaRPr lang="en-US" sz="1100" dirty="0"/>
+          </a:p>
+        </p:txBody>
+      </p:sp>
+      <p:sp>
+        <p:nvSpPr>
+          <p:cNvPr id="41" name="option-2-1"/>
           <p:cNvSpPr/>
           <p:nvPr/>
         </p:nvSpPr>
         <p:spPr>
           <a:xfrm>
-            <a:off x="4297680" y="4023360"/>
-            <a:ext cx="3520440" cy="1828800"/>
+            <a:off x="5897880" y="3611880"/>
+            <a:ext cx="2788920" cy="768096"/>
           </a:xfrm>
           <a:prstGeom prst="roundRect">
             <a:avLst>
-              <a:gd name="adj" fmla="val 6000"/>
+              <a:gd name="adj" fmla="val 11905"/>
             </a:avLst>
           </a:prstGeom>
           <a:solidFill>
@@ -2943,52 +3605,75 @@
       </p:sp>
       <p:sp>
         <p:nvSpPr>
-          <p:cNvPr id="21" name="Text 19"/>
-          <p:cNvSpPr txBox="1"/>
-          <p:nvPr/>
-        </p:nvSpPr>
-        <p:spPr>
-          <a:xfrm>
-            <a:off x="4526280" y="4251960"/>
-            <a:ext cx="457200" cy="457200"/>
-          </a:xfrm>
-          <a:prstGeom prst="ellipse">
+          <p:cNvPr id="42" name="checkbox"/>
+          <p:cNvSpPr/>
+          <p:nvPr/>
+        </p:nvSpPr>
+        <p:spPr>
+          <a:xfrm>
+            <a:off x="6035040" y="3858768"/>
+            <a:ext cx="237744" cy="237744"/>
+          </a:xfrm>
+          <a:prstGeom prst="rect">
             <a:avLst/>
           </a:prstGeom>
           <a:solidFill>
-            <a:srgbClr val="5DCDC1"/>
+            <a:srgbClr val="FFFFFF"/>
           </a:solidFill>
-          <a:ln/>
-        </p:spPr>
-        <p:txBody>
-          <a:bodyPr wrap="square" lIns="0" tIns="0" rIns="0" bIns="0" rtlCol="0" anchor="ctr"/>
-          <a:lstStyle/>
-          <a:p>
-            <a:pPr algn="ctr" indent="0" marL="0">
-              <a:buNone/>
-            </a:pPr>
-            <a:r>
-              <a:rPr lang="en-US" sz="1700" b="1" dirty="0">
+          <a:ln w="15875">
+            <a:solidFill>
+              <a:srgbClr val="617287"/>
+            </a:solidFill>
+            <a:prstDash val="solid"/>
+          </a:ln>
+        </p:spPr>
+      </p:sp>
+      <p:sp>
+        <p:nvSpPr>
+          <p:cNvPr id="43" name="Text 41"/>
+          <p:cNvSpPr txBox="1"/>
+          <p:nvPr/>
+        </p:nvSpPr>
+        <p:spPr>
+          <a:xfrm>
+            <a:off x="6373368" y="3685032"/>
+            <a:ext cx="2194560" cy="347472"/>
+          </a:xfrm>
+          <a:prstGeom prst="rect">
+            <a:avLst/>
+          </a:prstGeom>
+          <a:noFill/>
+          <a:ln/>
+        </p:spPr>
+        <p:txBody>
+          <a:bodyPr wrap="square" lIns="0" tIns="0" rIns="0" bIns="0" rtlCol="0" anchor="ctr"/>
+          <a:lstStyle/>
+          <a:p>
+            <a:pPr indent="0" marL="0">
+              <a:buNone/>
+            </a:pPr>
+            <a:r>
+              <a:rPr lang="en-US" sz="1300" b="1" dirty="0">
                 <a:solidFill>
                   <a:srgbClr val="16243A"/>
                 </a:solidFill>
               </a:rPr>
-              <a:t>5</a:t>
-            </a:r>
-            <a:endParaRPr lang="en-US" sz="1700" dirty="0"/>
-          </a:p>
-        </p:txBody>
-      </p:sp>
-      <p:sp>
-        <p:nvSpPr>
-          <p:cNvPr id="22" name="Text 20"/>
-          <p:cNvSpPr txBox="1"/>
-          <p:nvPr/>
-        </p:nvSpPr>
-        <p:spPr>
-          <a:xfrm>
-            <a:off x="5166360" y="4251960"/>
-            <a:ext cx="2468880" cy="457200"/>
+              <a:t>Scribble + 자라는 배경</a:t>
+            </a:r>
+            <a:endParaRPr lang="en-US" sz="1300" dirty="0"/>
+          </a:p>
+        </p:txBody>
+      </p:sp>
+      <p:sp>
+        <p:nvSpPr>
+          <p:cNvPr id="44" name="Text 42"/>
+          <p:cNvSpPr txBox="1"/>
+          <p:nvPr/>
+        </p:nvSpPr>
+        <p:spPr>
+          <a:xfrm>
+            <a:off x="6373368" y="4014216"/>
+            <a:ext cx="2194560" cy="292608"/>
           </a:xfrm>
           <a:prstGeom prst="rect">
             <a:avLst/>
@@ -3004,71 +3689,35 @@
               <a:buNone/>
             </a:pPr>
             <a:r>
-              <a:rPr lang="en-US" sz="1700" b="1" dirty="0">
-                <a:solidFill>
-                  <a:srgbClr val="16243A"/>
-                </a:solidFill>
-              </a:rPr>
-              <a:t>보관 방식</a:t>
-            </a:r>
-            <a:endParaRPr lang="en-US" sz="1700" dirty="0"/>
-          </a:p>
-        </p:txBody>
-      </p:sp>
-      <p:sp>
-        <p:nvSpPr>
-          <p:cNvPr id="23" name="Text 21"/>
-          <p:cNvSpPr txBox="1"/>
-          <p:nvPr/>
-        </p:nvSpPr>
-        <p:spPr>
-          <a:xfrm>
-            <a:off x="4526280" y="4892040"/>
-            <a:ext cx="3063240" cy="822960"/>
-          </a:xfrm>
-          <a:prstGeom prst="rect">
-            <a:avLst/>
-          </a:prstGeom>
-          <a:noFill/>
-          <a:ln/>
-        </p:spPr>
-        <p:txBody>
-          <a:bodyPr wrap="square" lIns="0" tIns="0" rIns="0" bIns="0" rtlCol="0" anchor="t"/>
-          <a:lstStyle/>
-          <a:p>
-            <a:pPr indent="0" marL="0">
-              <a:buNone/>
-            </a:pPr>
-            <a:r>
-              <a:rPr lang="en-US" sz="1400" dirty="0">
+              <a:rPr lang="en-US" sz="1100" dirty="0">
                 <a:solidFill>
                   <a:srgbClr val="617287"/>
                 </a:solidFill>
               </a:rPr>
-              <a:t>QR 보관함 · 하루 한 장 · 굿즈 범위</a:t>
-            </a:r>
-            <a:endParaRPr lang="en-US" sz="1400" dirty="0"/>
-          </a:p>
-        </p:txBody>
-      </p:sp>
-      <p:sp>
-        <p:nvSpPr>
-          <p:cNvPr id="24" name="refs"/>
+              <a:t>A0 + B5</a:t>
+            </a:r>
+            <a:endParaRPr lang="en-US" sz="1100" dirty="0"/>
+          </a:p>
+        </p:txBody>
+      </p:sp>
+      <p:sp>
+        <p:nvSpPr>
+          <p:cNvPr id="45" name="option-2-2"/>
           <p:cNvSpPr/>
           <p:nvPr/>
         </p:nvSpPr>
         <p:spPr>
           <a:xfrm>
-            <a:off x="8046720" y="4023360"/>
-            <a:ext cx="3520440" cy="1828800"/>
+            <a:off x="8823960" y="3611880"/>
+            <a:ext cx="2788920" cy="768096"/>
           </a:xfrm>
           <a:prstGeom prst="roundRect">
             <a:avLst>
-              <a:gd name="adj" fmla="val 6000"/>
+              <a:gd name="adj" fmla="val 11905"/>
             </a:avLst>
           </a:prstGeom>
           <a:solidFill>
-            <a:srgbClr val="EAF5F1"/>
+            <a:srgbClr val="FFFFFF"/>
           </a:solidFill>
           <a:ln w="12700">
             <a:solidFill>
@@ -3080,14 +3729,39 @@
       </p:sp>
       <p:sp>
         <p:nvSpPr>
-          <p:cNvPr id="25" name="Text 23"/>
-          <p:cNvSpPr txBox="1"/>
-          <p:nvPr/>
-        </p:nvSpPr>
-        <p:spPr>
-          <a:xfrm>
-            <a:off x="8183880" y="4206240"/>
-            <a:ext cx="3108960" cy="365760"/>
+          <p:cNvPr id="46" name="checkbox"/>
+          <p:cNvSpPr/>
+          <p:nvPr/>
+        </p:nvSpPr>
+        <p:spPr>
+          <a:xfrm>
+            <a:off x="8961120" y="3858768"/>
+            <a:ext cx="237744" cy="237744"/>
+          </a:xfrm>
+          <a:prstGeom prst="rect">
+            <a:avLst/>
+          </a:prstGeom>
+          <a:solidFill>
+            <a:srgbClr val="FFFFFF"/>
+          </a:solidFill>
+          <a:ln w="15875">
+            <a:solidFill>
+              <a:srgbClr val="617287"/>
+            </a:solidFill>
+            <a:prstDash val="solid"/>
+          </a:ln>
+        </p:spPr>
+      </p:sp>
+      <p:sp>
+        <p:nvSpPr>
+          <p:cNvPr id="47" name="Text 45"/>
+          <p:cNvSpPr txBox="1"/>
+          <p:nvPr/>
+        </p:nvSpPr>
+        <p:spPr>
+          <a:xfrm>
+            <a:off x="9299448" y="3685032"/>
+            <a:ext cx="2194560" cy="347472"/>
           </a:xfrm>
           <a:prstGeom prst="rect">
             <a:avLst/>
@@ -3103,106 +3777,458 @@
               <a:buNone/>
             </a:pPr>
             <a:r>
-              <a:rPr lang="en-US" sz="1500" b="1" dirty="0">
+              <a:rPr lang="en-US" sz="1300" b="1" dirty="0">
                 <a:solidFill>
                   <a:srgbClr val="16243A"/>
                 </a:solidFill>
               </a:rPr>
-              <a:t>참고 프로토타입</a:t>
-            </a:r>
-            <a:endParaRPr lang="en-US" sz="1500" dirty="0"/>
-          </a:p>
-        </p:txBody>
-      </p:sp>
-      <p:sp>
-        <p:nvSpPr>
-          <p:cNvPr id="26" name="Text 24"/>
-          <p:cNvSpPr txBox="1"/>
-          <p:nvPr/>
-        </p:nvSpPr>
-        <p:spPr>
-          <a:xfrm>
-            <a:off x="8183880" y="4617720"/>
-            <a:ext cx="3108960" cy="1143000"/>
-          </a:xfrm>
-          <a:prstGeom prst="rect">
-            <a:avLst/>
-          </a:prstGeom>
-          <a:noFill/>
-          <a:ln/>
-        </p:spPr>
-        <p:txBody>
-          <a:bodyPr wrap="square" lIns="0" tIns="0" rIns="0" bIns="0" rtlCol="0" anchor="t"/>
+              <a:t>덩굴 + 모자이크</a:t>
+            </a:r>
+            <a:endParaRPr lang="en-US" sz="1300" dirty="0"/>
+          </a:p>
+        </p:txBody>
+      </p:sp>
+      <p:sp>
+        <p:nvSpPr>
+          <p:cNvPr id="48" name="Text 46"/>
+          <p:cNvSpPr txBox="1"/>
+          <p:nvPr/>
+        </p:nvSpPr>
+        <p:spPr>
+          <a:xfrm>
+            <a:off x="9299448" y="4014216"/>
+            <a:ext cx="2194560" cy="292608"/>
+          </a:xfrm>
+          <a:prstGeom prst="rect">
+            <a:avLst/>
+          </a:prstGeom>
+          <a:noFill/>
+          <a:ln/>
+        </p:spPr>
+        <p:txBody>
+          <a:bodyPr wrap="square" lIns="0" tIns="0" rIns="0" bIns="0" rtlCol="0" anchor="ctr"/>
           <a:lstStyle/>
           <a:p>
             <a:pPr indent="0" marL="0">
-              <a:spcAft>
-                <a:spcPts val="400"/>
-              </a:spcAft>
-              <a:buNone/>
-            </a:pPr>
-            <a:r>
-              <a:rPr lang="en-US" sz="1300" u="sng" dirty="0">
-                <a:solidFill>
-                  <a:srgbClr val="2B8C83"/>
-                </a:solidFill>
-                <a:hlinkClick r:id="rId1" invalidUrl="" action="" tgtFrame="" tooltip="" history="1" highlightClick="0" endSnd="0">
-                  <a:extLst>
-                    <a:ext uri="{A12FA001-AC4F-418D-AE19-62706E023703}">
-                      <ahyp:hlinkClr xmlns:ahyp="http://schemas.microsoft.com/office/drawing/2018/hyperlinkcolor" val="tx"/>
-                    </a:ext>
-                  </a:extLst>
-                </a:hlinkClick>
-              </a:rPr>
-              <a:t>배경 아이데이션 B1–B6</a:t>
+              <a:buNone/>
+            </a:pPr>
+            <a:r>
+              <a:rPr lang="en-US" sz="1100" dirty="0">
+                <a:solidFill>
+                  <a:srgbClr val="617287"/>
+                </a:solidFill>
+              </a:rPr>
+              <a:t>B2 + B6</a:t>
+            </a:r>
+            <a:endParaRPr lang="en-US" sz="1100" dirty="0"/>
+          </a:p>
+        </p:txBody>
+      </p:sp>
+      <p:sp>
+        <p:nvSpPr>
+          <p:cNvPr id="49" name="decision-no"/>
+          <p:cNvSpPr txBox="1"/>
+          <p:nvPr/>
+        </p:nvSpPr>
+        <p:spPr>
+          <a:xfrm>
+            <a:off x="548640" y="4636008"/>
+            <a:ext cx="457200" cy="457200"/>
+          </a:xfrm>
+          <a:prstGeom prst="ellipse">
+            <a:avLst/>
+          </a:prstGeom>
+          <a:solidFill>
+            <a:srgbClr val="E8614D"/>
+          </a:solidFill>
+          <a:ln/>
+        </p:spPr>
+        <p:txBody>
+          <a:bodyPr wrap="square" lIns="0" tIns="0" rIns="0" bIns="0" rtlCol="0" anchor="ctr"/>
+          <a:lstStyle/>
+          <a:p>
+            <a:pPr algn="ctr" indent="0" marL="0">
+              <a:buNone/>
+            </a:pPr>
+            <a:r>
+              <a:rPr lang="en-US" sz="1800" b="1" dirty="0">
+                <a:solidFill>
+                  <a:srgbClr val="FFFFFF"/>
+                </a:solidFill>
+              </a:rPr>
+              <a:t>④</a:t>
+            </a:r>
+            <a:endParaRPr lang="en-US" sz="1800" dirty="0"/>
+          </a:p>
+        </p:txBody>
+      </p:sp>
+      <p:sp>
+        <p:nvSpPr>
+          <p:cNvPr id="50" name="Text 48"/>
+          <p:cNvSpPr txBox="1"/>
+          <p:nvPr/>
+        </p:nvSpPr>
+        <p:spPr>
+          <a:xfrm>
+            <a:off x="1143000" y="4590288"/>
+            <a:ext cx="1737360" cy="548640"/>
+          </a:xfrm>
+          <a:prstGeom prst="rect">
+            <a:avLst/>
+          </a:prstGeom>
+          <a:noFill/>
+          <a:ln/>
+        </p:spPr>
+        <p:txBody>
+          <a:bodyPr wrap="square" lIns="0" tIns="0" rIns="0" bIns="0" rtlCol="0" anchor="ctr"/>
+          <a:lstStyle/>
+          <a:p>
+            <a:pPr indent="0" marL="0">
+              <a:buNone/>
+            </a:pPr>
+            <a:r>
+              <a:rPr lang="en-US" sz="1700" b="1" dirty="0">
+                <a:solidFill>
+                  <a:srgbClr val="16243A"/>
+                </a:solidFill>
+              </a:rPr>
+              <a:t>퍼레이드 운영</a:t>
+            </a:r>
+            <a:endParaRPr lang="en-US" sz="1700" dirty="0"/>
+          </a:p>
+        </p:txBody>
+      </p:sp>
+      <p:sp>
+        <p:nvSpPr>
+          <p:cNvPr id="51" name="option-3-0"/>
+          <p:cNvSpPr/>
+          <p:nvPr/>
+        </p:nvSpPr>
+        <p:spPr>
+          <a:xfrm>
+            <a:off x="2971800" y="4480560"/>
+            <a:ext cx="2788920" cy="768096"/>
+          </a:xfrm>
+          <a:prstGeom prst="roundRect">
+            <a:avLst>
+              <a:gd name="adj" fmla="val 11905"/>
+            </a:avLst>
+          </a:prstGeom>
+          <a:solidFill>
+            <a:srgbClr val="FFFFFF"/>
+          </a:solidFill>
+          <a:ln w="12700">
+            <a:solidFill>
+              <a:srgbClr val="DFE6EB"/>
+            </a:solidFill>
+            <a:prstDash val="solid"/>
+          </a:ln>
+        </p:spPr>
+      </p:sp>
+      <p:sp>
+        <p:nvSpPr>
+          <p:cNvPr id="52" name="checkbox"/>
+          <p:cNvSpPr/>
+          <p:nvPr/>
+        </p:nvSpPr>
+        <p:spPr>
+          <a:xfrm>
+            <a:off x="3108960" y="4727448"/>
+            <a:ext cx="237744" cy="237744"/>
+          </a:xfrm>
+          <a:prstGeom prst="rect">
+            <a:avLst/>
+          </a:prstGeom>
+          <a:solidFill>
+            <a:srgbClr val="FFFFFF"/>
+          </a:solidFill>
+          <a:ln w="15875">
+            <a:solidFill>
+              <a:srgbClr val="617287"/>
+            </a:solidFill>
+            <a:prstDash val="solid"/>
+          </a:ln>
+        </p:spPr>
+      </p:sp>
+      <p:sp>
+        <p:nvSpPr>
+          <p:cNvPr id="53" name="Text 51"/>
+          <p:cNvSpPr txBox="1"/>
+          <p:nvPr/>
+        </p:nvSpPr>
+        <p:spPr>
+          <a:xfrm>
+            <a:off x="3447288" y="4553712"/>
+            <a:ext cx="2194560" cy="347472"/>
+          </a:xfrm>
+          <a:prstGeom prst="rect">
+            <a:avLst/>
+          </a:prstGeom>
+          <a:noFill/>
+          <a:ln/>
+        </p:spPr>
+        <p:txBody>
+          <a:bodyPr wrap="square" lIns="0" tIns="0" rIns="0" bIns="0" rtlCol="0" anchor="ctr"/>
+          <a:lstStyle/>
+          <a:p>
+            <a:pPr indent="0" marL="0">
+              <a:buNone/>
+            </a:pPr>
+            <a:r>
+              <a:rPr lang="en-US" sz="1300" b="1" dirty="0">
+                <a:solidFill>
+                  <a:srgbClr val="16243A"/>
+                </a:solidFill>
+              </a:rPr>
+              <a:t>상시 합류만</a:t>
             </a:r>
             <a:endParaRPr lang="en-US" sz="1300" dirty="0"/>
           </a:p>
+        </p:txBody>
+      </p:sp>
+      <p:sp>
+        <p:nvSpPr>
+          <p:cNvPr id="54" name="Text 52"/>
+          <p:cNvSpPr txBox="1"/>
+          <p:nvPr/>
+        </p:nvSpPr>
+        <p:spPr>
+          <a:xfrm>
+            <a:off x="3447288" y="4882896"/>
+            <a:ext cx="2194560" cy="292608"/>
+          </a:xfrm>
+          <a:prstGeom prst="rect">
+            <a:avLst/>
+          </a:prstGeom>
+          <a:noFill/>
+          <a:ln/>
+        </p:spPr>
+        <p:txBody>
+          <a:bodyPr wrap="square" lIns="0" tIns="0" rIns="0" bIns="0" rtlCol="0" anchor="ctr"/>
+          <a:lstStyle/>
           <a:p>
             <a:pPr indent="0" marL="0">
-              <a:spcAft>
-                <a:spcPts val="400"/>
-              </a:spcAft>
-              <a:buNone/>
-            </a:pPr>
-            <a:r>
-              <a:rPr lang="en-US" sz="1300" u="sng" dirty="0">
-                <a:solidFill>
-                  <a:srgbClr val="2B8C83"/>
-                </a:solidFill>
-                <a:hlinkClick r:id="rId2" invalidUrl="" action="" tgtFrame="" tooltip="" history="1" highlightClick="0" endSnd="0">
-                  <a:extLst>
-                    <a:ext uri="{A12FA001-AC4F-418D-AE19-62706E023703}">
-                      <ahyp:hlinkClr xmlns:ahyp="http://schemas.microsoft.com/office/drawing/2018/hyperlinkcolor" val="tx"/>
-                    </a:ext>
-                  </a:extLst>
-                </a:hlinkClick>
-              </a:rPr>
-              <a:t>기존 콘텐츠 연계(Art · Logo)</a:t>
+              <a:buNone/>
+            </a:pPr>
+            <a:r>
+              <a:rPr lang="en-US" sz="1100" dirty="0">
+                <a:solidFill>
+                  <a:srgbClr val="617287"/>
+                </a:solidFill>
+              </a:rPr>
+              <a:t>늘 몇 명씩 등장</a:t>
+            </a:r>
+            <a:endParaRPr lang="en-US" sz="1100" dirty="0"/>
+          </a:p>
+        </p:txBody>
+      </p:sp>
+      <p:sp>
+        <p:nvSpPr>
+          <p:cNvPr id="55" name="option-3-1"/>
+          <p:cNvSpPr/>
+          <p:nvPr/>
+        </p:nvSpPr>
+        <p:spPr>
+          <a:xfrm>
+            <a:off x="5897880" y="4480560"/>
+            <a:ext cx="2788920" cy="768096"/>
+          </a:xfrm>
+          <a:prstGeom prst="roundRect">
+            <a:avLst>
+              <a:gd name="adj" fmla="val 11905"/>
+            </a:avLst>
+          </a:prstGeom>
+          <a:solidFill>
+            <a:srgbClr val="FFFFFF"/>
+          </a:solidFill>
+          <a:ln w="12700">
+            <a:solidFill>
+              <a:srgbClr val="DFE6EB"/>
+            </a:solidFill>
+            <a:prstDash val="solid"/>
+          </a:ln>
+        </p:spPr>
+      </p:sp>
+      <p:sp>
+        <p:nvSpPr>
+          <p:cNvPr id="56" name="checkbox"/>
+          <p:cNvSpPr/>
+          <p:nvPr/>
+        </p:nvSpPr>
+        <p:spPr>
+          <a:xfrm>
+            <a:off x="6035040" y="4727448"/>
+            <a:ext cx="237744" cy="237744"/>
+          </a:xfrm>
+          <a:prstGeom prst="rect">
+            <a:avLst/>
+          </a:prstGeom>
+          <a:solidFill>
+            <a:srgbClr val="FFFFFF"/>
+          </a:solidFill>
+          <a:ln w="15875">
+            <a:solidFill>
+              <a:srgbClr val="617287"/>
+            </a:solidFill>
+            <a:prstDash val="solid"/>
+          </a:ln>
+        </p:spPr>
+      </p:sp>
+      <p:sp>
+        <p:nvSpPr>
+          <p:cNvPr id="57" name="Text 55"/>
+          <p:cNvSpPr txBox="1"/>
+          <p:nvPr/>
+        </p:nvSpPr>
+        <p:spPr>
+          <a:xfrm>
+            <a:off x="6373368" y="4553712"/>
+            <a:ext cx="2194560" cy="347472"/>
+          </a:xfrm>
+          <a:prstGeom prst="rect">
+            <a:avLst/>
+          </a:prstGeom>
+          <a:noFill/>
+          <a:ln/>
+        </p:spPr>
+        <p:txBody>
+          <a:bodyPr wrap="square" lIns="0" tIns="0" rIns="0" bIns="0" rtlCol="0" anchor="ctr"/>
+          <a:lstStyle/>
+          <a:p>
+            <a:pPr indent="0" marL="0">
+              <a:buNone/>
+            </a:pPr>
+            <a:r>
+              <a:rPr lang="en-US" sz="1300" b="1" dirty="0">
+                <a:solidFill>
+                  <a:srgbClr val="16243A"/>
+                </a:solidFill>
+              </a:rPr>
+              <a:t>정시 퍼레이드만</a:t>
             </a:r>
             <a:endParaRPr lang="en-US" sz="1300" dirty="0"/>
           </a:p>
+        </p:txBody>
+      </p:sp>
+      <p:sp>
+        <p:nvSpPr>
+          <p:cNvPr id="58" name="Text 56"/>
+          <p:cNvSpPr txBox="1"/>
+          <p:nvPr/>
+        </p:nvSpPr>
+        <p:spPr>
+          <a:xfrm>
+            <a:off x="6373368" y="4882896"/>
+            <a:ext cx="2194560" cy="292608"/>
+          </a:xfrm>
+          <a:prstGeom prst="rect">
+            <a:avLst/>
+          </a:prstGeom>
+          <a:noFill/>
+          <a:ln/>
+        </p:spPr>
+        <p:txBody>
+          <a:bodyPr wrap="square" lIns="0" tIns="0" rIns="0" bIns="0" rtlCol="0" anchor="ctr"/>
+          <a:lstStyle/>
           <a:p>
             <a:pPr indent="0" marL="0">
-              <a:spcAft>
-                <a:spcPts val="400"/>
-              </a:spcAft>
-              <a:buNone/>
-            </a:pPr>
-            <a:r>
-              <a:rPr lang="en-US" sz="1300" u="sng" dirty="0">
-                <a:solidFill>
-                  <a:srgbClr val="2B8C83"/>
-                </a:solidFill>
-                <a:hlinkClick r:id="rId3" invalidUrl="" action="" tgtFrame="" tooltip="" history="1" highlightClick="0" endSnd="0">
-                  <a:extLst>
-                    <a:ext uri="{A12FA001-AC4F-418D-AE19-62706E023703}">
-                      <ahyp:hlinkClr xmlns:ahyp="http://schemas.microsoft.com/office/drawing/2018/hyperlinkcolor" val="tx"/>
-                    </a:ext>
-                  </a:extLst>
-                </a:hlinkClick>
-              </a:rPr>
-              <a:t>쌓이는 그림 아카이브</a:t>
+              <a:buNone/>
+            </a:pPr>
+            <a:r>
+              <a:rPr lang="en-US" sz="1100" dirty="0">
+                <a:solidFill>
+                  <a:srgbClr val="617287"/>
+                </a:solidFill>
+              </a:rPr>
+              <a:t>예: 30분마다 3–5분</a:t>
+            </a:r>
+            <a:endParaRPr lang="en-US" sz="1100" dirty="0"/>
+          </a:p>
+        </p:txBody>
+      </p:sp>
+      <p:sp>
+        <p:nvSpPr>
+          <p:cNvPr id="59" name="option-3-2"/>
+          <p:cNvSpPr/>
+          <p:nvPr/>
+        </p:nvSpPr>
+        <p:spPr>
+          <a:xfrm>
+            <a:off x="8823960" y="4480560"/>
+            <a:ext cx="2788920" cy="768096"/>
+          </a:xfrm>
+          <a:prstGeom prst="roundRect">
+            <a:avLst>
+              <a:gd name="adj" fmla="val 11905"/>
+            </a:avLst>
+          </a:prstGeom>
+          <a:solidFill>
+            <a:srgbClr val="EAF5F1"/>
+          </a:solidFill>
+          <a:ln w="25400">
+            <a:solidFill>
+              <a:srgbClr val="2B8C83"/>
+            </a:solidFill>
+            <a:prstDash val="solid"/>
+          </a:ln>
+        </p:spPr>
+      </p:sp>
+      <p:sp>
+        <p:nvSpPr>
+          <p:cNvPr id="60" name="checkbox"/>
+          <p:cNvSpPr/>
+          <p:nvPr/>
+        </p:nvSpPr>
+        <p:spPr>
+          <a:xfrm>
+            <a:off x="8961120" y="4727448"/>
+            <a:ext cx="237744" cy="237744"/>
+          </a:xfrm>
+          <a:prstGeom prst="rect">
+            <a:avLst/>
+          </a:prstGeom>
+          <a:solidFill>
+            <a:srgbClr val="FFFFFF"/>
+          </a:solidFill>
+          <a:ln w="15875">
+            <a:solidFill>
+              <a:srgbClr val="2B8C83"/>
+            </a:solidFill>
+            <a:prstDash val="solid"/>
+          </a:ln>
+        </p:spPr>
+      </p:sp>
+      <p:sp>
+        <p:nvSpPr>
+          <p:cNvPr id="61" name="Text 59"/>
+          <p:cNvSpPr txBox="1"/>
+          <p:nvPr/>
+        </p:nvSpPr>
+        <p:spPr>
+          <a:xfrm>
+            <a:off x="9299448" y="4553712"/>
+            <a:ext cx="1600200" cy="347472"/>
+          </a:xfrm>
+          <a:prstGeom prst="rect">
+            <a:avLst/>
+          </a:prstGeom>
+          <a:noFill/>
+          <a:ln/>
+        </p:spPr>
+        <p:txBody>
+          <a:bodyPr wrap="square" lIns="0" tIns="0" rIns="0" bIns="0" rtlCol="0" anchor="ctr"/>
+          <a:lstStyle/>
+          <a:p>
+            <a:pPr indent="0" marL="0">
+              <a:buNone/>
+            </a:pPr>
+            <a:r>
+              <a:rPr lang="en-US" sz="1300" b="1" dirty="0">
+                <a:solidFill>
+                  <a:srgbClr val="16243A"/>
+                </a:solidFill>
+              </a:rPr>
+              <a:t>정시 + 상시</a:t>
             </a:r>
             <a:endParaRPr lang="en-US" sz="1300" dirty="0"/>
           </a:p>
@@ -3210,7 +4236,569 @@
       </p:sp>
       <p:sp>
         <p:nvSpPr>
-          <p:cNvPr id="25" name="Slide Number Placeholder 0"/>
+          <p:cNvPr id="62" name="Text 60"/>
+          <p:cNvSpPr txBox="1"/>
+          <p:nvPr/>
+        </p:nvSpPr>
+        <p:spPr>
+          <a:xfrm>
+            <a:off x="9299448" y="4882896"/>
+            <a:ext cx="2194560" cy="292608"/>
+          </a:xfrm>
+          <a:prstGeom prst="rect">
+            <a:avLst/>
+          </a:prstGeom>
+          <a:noFill/>
+          <a:ln/>
+        </p:spPr>
+        <p:txBody>
+          <a:bodyPr wrap="square" lIns="0" tIns="0" rIns="0" bIns="0" rtlCol="0" anchor="ctr"/>
+          <a:lstStyle/>
+          <a:p>
+            <a:pPr indent="0" marL="0">
+              <a:buNone/>
+            </a:pPr>
+            <a:r>
+              <a:rPr lang="en-US" sz="1100" dirty="0">
+                <a:solidFill>
+                  <a:srgbClr val="617287"/>
+                </a:solidFill>
+              </a:rPr>
+              <a:t>평소 합류 + 정시 행진</a:t>
+            </a:r>
+            <a:endParaRPr lang="en-US" sz="1100" dirty="0"/>
+          </a:p>
+        </p:txBody>
+      </p:sp>
+      <p:sp>
+        <p:nvSpPr>
+          <p:cNvPr id="63" name="chip-제안"/>
+          <p:cNvSpPr txBox="1"/>
+          <p:nvPr/>
+        </p:nvSpPr>
+        <p:spPr>
+          <a:xfrm>
+            <a:off x="10954512" y="4572000"/>
+            <a:ext cx="548640" cy="292608"/>
+          </a:xfrm>
+          <a:prstGeom prst="roundRect">
+            <a:avLst>
+              <a:gd name="adj" fmla="val 25000"/>
+            </a:avLst>
+          </a:prstGeom>
+          <a:solidFill>
+            <a:srgbClr val="5DCDC1"/>
+          </a:solidFill>
+          <a:ln/>
+        </p:spPr>
+        <p:txBody>
+          <a:bodyPr wrap="square" lIns="0" tIns="0" rIns="0" bIns="0" rtlCol="0" anchor="ctr"/>
+          <a:lstStyle/>
+          <a:p>
+            <a:pPr algn="ctr" indent="0" marL="0">
+              <a:buNone/>
+            </a:pPr>
+            <a:r>
+              <a:rPr lang="en-US" sz="1100" b="1" dirty="0">
+                <a:solidFill>
+                  <a:srgbClr val="16243A"/>
+                </a:solidFill>
+              </a:rPr>
+              <a:t>제안</a:t>
+            </a:r>
+            <a:endParaRPr lang="en-US" sz="1100" dirty="0"/>
+          </a:p>
+        </p:txBody>
+      </p:sp>
+      <p:sp>
+        <p:nvSpPr>
+          <p:cNvPr id="64" name="decision-no"/>
+          <p:cNvSpPr txBox="1"/>
+          <p:nvPr/>
+        </p:nvSpPr>
+        <p:spPr>
+          <a:xfrm>
+            <a:off x="548640" y="5504688"/>
+            <a:ext cx="457200" cy="457200"/>
+          </a:xfrm>
+          <a:prstGeom prst="ellipse">
+            <a:avLst/>
+          </a:prstGeom>
+          <a:solidFill>
+            <a:srgbClr val="E8614D"/>
+          </a:solidFill>
+          <a:ln/>
+        </p:spPr>
+        <p:txBody>
+          <a:bodyPr wrap="square" lIns="0" tIns="0" rIns="0" bIns="0" rtlCol="0" anchor="ctr"/>
+          <a:lstStyle/>
+          <a:p>
+            <a:pPr algn="ctr" indent="0" marL="0">
+              <a:buNone/>
+            </a:pPr>
+            <a:r>
+              <a:rPr lang="en-US" sz="1800" b="1" dirty="0">
+                <a:solidFill>
+                  <a:srgbClr val="FFFFFF"/>
+                </a:solidFill>
+              </a:rPr>
+              <a:t>⑤</a:t>
+            </a:r>
+            <a:endParaRPr lang="en-US" sz="1800" dirty="0"/>
+          </a:p>
+        </p:txBody>
+      </p:sp>
+      <p:sp>
+        <p:nvSpPr>
+          <p:cNvPr id="65" name="Text 63"/>
+          <p:cNvSpPr txBox="1"/>
+          <p:nvPr/>
+        </p:nvSpPr>
+        <p:spPr>
+          <a:xfrm>
+            <a:off x="1143000" y="5458968"/>
+            <a:ext cx="1737360" cy="548640"/>
+          </a:xfrm>
+          <a:prstGeom prst="rect">
+            <a:avLst/>
+          </a:prstGeom>
+          <a:noFill/>
+          <a:ln/>
+        </p:spPr>
+        <p:txBody>
+          <a:bodyPr wrap="square" lIns="0" tIns="0" rIns="0" bIns="0" rtlCol="0" anchor="ctr"/>
+          <a:lstStyle/>
+          <a:p>
+            <a:pPr indent="0" marL="0">
+              <a:buNone/>
+            </a:pPr>
+            <a:r>
+              <a:rPr lang="en-US" sz="1700" b="1" dirty="0">
+                <a:solidFill>
+                  <a:srgbClr val="16243A"/>
+                </a:solidFill>
+              </a:rPr>
+              <a:t>보관 범위</a:t>
+            </a:r>
+            <a:endParaRPr lang="en-US" sz="1700" dirty="0"/>
+          </a:p>
+        </p:txBody>
+      </p:sp>
+      <p:sp>
+        <p:nvSpPr>
+          <p:cNvPr id="66" name="option-4-0"/>
+          <p:cNvSpPr/>
+          <p:nvPr/>
+        </p:nvSpPr>
+        <p:spPr>
+          <a:xfrm>
+            <a:off x="2971800" y="5349240"/>
+            <a:ext cx="2788920" cy="768096"/>
+          </a:xfrm>
+          <a:prstGeom prst="roundRect">
+            <a:avLst>
+              <a:gd name="adj" fmla="val 11905"/>
+            </a:avLst>
+          </a:prstGeom>
+          <a:solidFill>
+            <a:srgbClr val="FFFFFF"/>
+          </a:solidFill>
+          <a:ln w="12700">
+            <a:solidFill>
+              <a:srgbClr val="DFE6EB"/>
+            </a:solidFill>
+            <a:prstDash val="solid"/>
+          </a:ln>
+        </p:spPr>
+      </p:sp>
+      <p:sp>
+        <p:nvSpPr>
+          <p:cNvPr id="67" name="checkbox"/>
+          <p:cNvSpPr/>
+          <p:nvPr/>
+        </p:nvSpPr>
+        <p:spPr>
+          <a:xfrm>
+            <a:off x="3108960" y="5596128"/>
+            <a:ext cx="237744" cy="237744"/>
+          </a:xfrm>
+          <a:prstGeom prst="rect">
+            <a:avLst/>
+          </a:prstGeom>
+          <a:solidFill>
+            <a:srgbClr val="FFFFFF"/>
+          </a:solidFill>
+          <a:ln w="15875">
+            <a:solidFill>
+              <a:srgbClr val="617287"/>
+            </a:solidFill>
+            <a:prstDash val="solid"/>
+          </a:ln>
+        </p:spPr>
+      </p:sp>
+      <p:sp>
+        <p:nvSpPr>
+          <p:cNvPr id="68" name="Text 66"/>
+          <p:cNvSpPr txBox="1"/>
+          <p:nvPr/>
+        </p:nvSpPr>
+        <p:spPr>
+          <a:xfrm>
+            <a:off x="3447288" y="5422392"/>
+            <a:ext cx="2194560" cy="347472"/>
+          </a:xfrm>
+          <a:prstGeom prst="rect">
+            <a:avLst/>
+          </a:prstGeom>
+          <a:noFill/>
+          <a:ln/>
+        </p:spPr>
+        <p:txBody>
+          <a:bodyPr wrap="square" lIns="0" tIns="0" rIns="0" bIns="0" rtlCol="0" anchor="ctr"/>
+          <a:lstStyle/>
+          <a:p>
+            <a:pPr indent="0" marL="0">
+              <a:buNone/>
+            </a:pPr>
+            <a:r>
+              <a:rPr lang="en-US" sz="1300" b="1" dirty="0">
+                <a:solidFill>
+                  <a:srgbClr val="16243A"/>
+                </a:solidFill>
+              </a:rPr>
+              <a:t>QR 보관함</a:t>
+            </a:r>
+            <a:endParaRPr lang="en-US" sz="1300" dirty="0"/>
+          </a:p>
+        </p:txBody>
+      </p:sp>
+      <p:sp>
+        <p:nvSpPr>
+          <p:cNvPr id="69" name="Text 67"/>
+          <p:cNvSpPr txBox="1"/>
+          <p:nvPr/>
+        </p:nvSpPr>
+        <p:spPr>
+          <a:xfrm>
+            <a:off x="3447288" y="5751576"/>
+            <a:ext cx="2194560" cy="292608"/>
+          </a:xfrm>
+          <a:prstGeom prst="rect">
+            <a:avLst/>
+          </a:prstGeom>
+          <a:noFill/>
+          <a:ln/>
+        </p:spPr>
+        <p:txBody>
+          <a:bodyPr wrap="square" lIns="0" tIns="0" rIns="0" bIns="0" rtlCol="0" anchor="ctr"/>
+          <a:lstStyle/>
+          <a:p>
+            <a:pPr indent="0" marL="0">
+              <a:buNone/>
+            </a:pPr>
+            <a:r>
+              <a:rPr lang="en-US" sz="1100" dirty="0">
+                <a:solidFill>
+                  <a:srgbClr val="617287"/>
+                </a:solidFill>
+              </a:rPr>
+              <a:t>영상 · 이미지 받기</a:t>
+            </a:r>
+            <a:endParaRPr lang="en-US" sz="1100" dirty="0"/>
+          </a:p>
+        </p:txBody>
+      </p:sp>
+      <p:sp>
+        <p:nvSpPr>
+          <p:cNvPr id="70" name="option-4-1"/>
+          <p:cNvSpPr/>
+          <p:nvPr/>
+        </p:nvSpPr>
+        <p:spPr>
+          <a:xfrm>
+            <a:off x="5897880" y="5349240"/>
+            <a:ext cx="2788920" cy="768096"/>
+          </a:xfrm>
+          <a:prstGeom prst="roundRect">
+            <a:avLst>
+              <a:gd name="adj" fmla="val 11905"/>
+            </a:avLst>
+          </a:prstGeom>
+          <a:solidFill>
+            <a:srgbClr val="EAF5F1"/>
+          </a:solidFill>
+          <a:ln w="25400">
+            <a:solidFill>
+              <a:srgbClr val="2B8C83"/>
+            </a:solidFill>
+            <a:prstDash val="solid"/>
+          </a:ln>
+        </p:spPr>
+      </p:sp>
+      <p:sp>
+        <p:nvSpPr>
+          <p:cNvPr id="71" name="checkbox"/>
+          <p:cNvSpPr/>
+          <p:nvPr/>
+        </p:nvSpPr>
+        <p:spPr>
+          <a:xfrm>
+            <a:off x="6035040" y="5596128"/>
+            <a:ext cx="237744" cy="237744"/>
+          </a:xfrm>
+          <a:prstGeom prst="rect">
+            <a:avLst/>
+          </a:prstGeom>
+          <a:solidFill>
+            <a:srgbClr val="FFFFFF"/>
+          </a:solidFill>
+          <a:ln w="15875">
+            <a:solidFill>
+              <a:srgbClr val="2B8C83"/>
+            </a:solidFill>
+            <a:prstDash val="solid"/>
+          </a:ln>
+        </p:spPr>
+      </p:sp>
+      <p:sp>
+        <p:nvSpPr>
+          <p:cNvPr id="72" name="Text 70"/>
+          <p:cNvSpPr txBox="1"/>
+          <p:nvPr/>
+        </p:nvSpPr>
+        <p:spPr>
+          <a:xfrm>
+            <a:off x="6373368" y="5422392"/>
+            <a:ext cx="1600200" cy="347472"/>
+          </a:xfrm>
+          <a:prstGeom prst="rect">
+            <a:avLst/>
+          </a:prstGeom>
+          <a:noFill/>
+          <a:ln/>
+        </p:spPr>
+        <p:txBody>
+          <a:bodyPr wrap="square" lIns="0" tIns="0" rIns="0" bIns="0" rtlCol="0" anchor="ctr"/>
+          <a:lstStyle/>
+          <a:p>
+            <a:pPr indent="0" marL="0">
+              <a:buNone/>
+            </a:pPr>
+            <a:r>
+              <a:rPr lang="en-US" sz="1300" b="1" dirty="0">
+                <a:solidFill>
+                  <a:srgbClr val="16243A"/>
+                </a:solidFill>
+              </a:rPr>
+              <a:t>QR + 하루 한 장</a:t>
+            </a:r>
+            <a:endParaRPr lang="en-US" sz="1300" dirty="0"/>
+          </a:p>
+        </p:txBody>
+      </p:sp>
+      <p:sp>
+        <p:nvSpPr>
+          <p:cNvPr id="73" name="Text 71"/>
+          <p:cNvSpPr txBox="1"/>
+          <p:nvPr/>
+        </p:nvSpPr>
+        <p:spPr>
+          <a:xfrm>
+            <a:off x="6373368" y="5751576"/>
+            <a:ext cx="2194560" cy="292608"/>
+          </a:xfrm>
+          <a:prstGeom prst="rect">
+            <a:avLst/>
+          </a:prstGeom>
+          <a:noFill/>
+          <a:ln/>
+        </p:spPr>
+        <p:txBody>
+          <a:bodyPr wrap="square" lIns="0" tIns="0" rIns="0" bIns="0" rtlCol="0" anchor="ctr"/>
+          <a:lstStyle/>
+          <a:p>
+            <a:pPr indent="0" marL="0">
+              <a:buNone/>
+            </a:pPr>
+            <a:r>
+              <a:rPr lang="en-US" sz="1100" dirty="0">
+                <a:solidFill>
+                  <a:srgbClr val="617287"/>
+                </a:solidFill>
+              </a:rPr>
+              <a:t>날짜별 기록 추가</a:t>
+            </a:r>
+            <a:endParaRPr lang="en-US" sz="1100" dirty="0"/>
+          </a:p>
+        </p:txBody>
+      </p:sp>
+      <p:sp>
+        <p:nvSpPr>
+          <p:cNvPr id="74" name="chip-제안"/>
+          <p:cNvSpPr txBox="1"/>
+          <p:nvPr/>
+        </p:nvSpPr>
+        <p:spPr>
+          <a:xfrm>
+            <a:off x="8028432" y="5440680"/>
+            <a:ext cx="548640" cy="292608"/>
+          </a:xfrm>
+          <a:prstGeom prst="roundRect">
+            <a:avLst>
+              <a:gd name="adj" fmla="val 25000"/>
+            </a:avLst>
+          </a:prstGeom>
+          <a:solidFill>
+            <a:srgbClr val="5DCDC1"/>
+          </a:solidFill>
+          <a:ln/>
+        </p:spPr>
+        <p:txBody>
+          <a:bodyPr wrap="square" lIns="0" tIns="0" rIns="0" bIns="0" rtlCol="0" anchor="ctr"/>
+          <a:lstStyle/>
+          <a:p>
+            <a:pPr algn="ctr" indent="0" marL="0">
+              <a:buNone/>
+            </a:pPr>
+            <a:r>
+              <a:rPr lang="en-US" sz="1100" b="1" dirty="0">
+                <a:solidFill>
+                  <a:srgbClr val="16243A"/>
+                </a:solidFill>
+              </a:rPr>
+              <a:t>제안</a:t>
+            </a:r>
+            <a:endParaRPr lang="en-US" sz="1100" dirty="0"/>
+          </a:p>
+        </p:txBody>
+      </p:sp>
+      <p:sp>
+        <p:nvSpPr>
+          <p:cNvPr id="75" name="option-4-2"/>
+          <p:cNvSpPr/>
+          <p:nvPr/>
+        </p:nvSpPr>
+        <p:spPr>
+          <a:xfrm>
+            <a:off x="8823960" y="5349240"/>
+            <a:ext cx="2788920" cy="768096"/>
+          </a:xfrm>
+          <a:prstGeom prst="roundRect">
+            <a:avLst>
+              <a:gd name="adj" fmla="val 11905"/>
+            </a:avLst>
+          </a:prstGeom>
+          <a:solidFill>
+            <a:srgbClr val="FFFFFF"/>
+          </a:solidFill>
+          <a:ln w="12700">
+            <a:solidFill>
+              <a:srgbClr val="DFE6EB"/>
+            </a:solidFill>
+            <a:prstDash val="solid"/>
+          </a:ln>
+        </p:spPr>
+      </p:sp>
+      <p:sp>
+        <p:nvSpPr>
+          <p:cNvPr id="76" name="checkbox"/>
+          <p:cNvSpPr/>
+          <p:nvPr/>
+        </p:nvSpPr>
+        <p:spPr>
+          <a:xfrm>
+            <a:off x="8961120" y="5596128"/>
+            <a:ext cx="237744" cy="237744"/>
+          </a:xfrm>
+          <a:prstGeom prst="rect">
+            <a:avLst/>
+          </a:prstGeom>
+          <a:solidFill>
+            <a:srgbClr val="FFFFFF"/>
+          </a:solidFill>
+          <a:ln w="15875">
+            <a:solidFill>
+              <a:srgbClr val="617287"/>
+            </a:solidFill>
+            <a:prstDash val="solid"/>
+          </a:ln>
+        </p:spPr>
+      </p:sp>
+      <p:sp>
+        <p:nvSpPr>
+          <p:cNvPr id="77" name="Text 75"/>
+          <p:cNvSpPr txBox="1"/>
+          <p:nvPr/>
+        </p:nvSpPr>
+        <p:spPr>
+          <a:xfrm>
+            <a:off x="9299448" y="5422392"/>
+            <a:ext cx="2194560" cy="347472"/>
+          </a:xfrm>
+          <a:prstGeom prst="rect">
+            <a:avLst/>
+          </a:prstGeom>
+          <a:noFill/>
+          <a:ln/>
+        </p:spPr>
+        <p:txBody>
+          <a:bodyPr wrap="square" lIns="0" tIns="0" rIns="0" bIns="0" rtlCol="0" anchor="ctr"/>
+          <a:lstStyle/>
+          <a:p>
+            <a:pPr indent="0" marL="0">
+              <a:buNone/>
+            </a:pPr>
+            <a:r>
+              <a:rPr lang="en-US" sz="1300" b="1" dirty="0">
+                <a:solidFill>
+                  <a:srgbClr val="16243A"/>
+                </a:solidFill>
+              </a:rPr>
+              <a:t>QR + 하루 한 장 + 굿즈</a:t>
+            </a:r>
+            <a:endParaRPr lang="en-US" sz="1300" dirty="0"/>
+          </a:p>
+        </p:txBody>
+      </p:sp>
+      <p:sp>
+        <p:nvSpPr>
+          <p:cNvPr id="78" name="Text 76"/>
+          <p:cNvSpPr txBox="1"/>
+          <p:nvPr/>
+        </p:nvSpPr>
+        <p:spPr>
+          <a:xfrm>
+            <a:off x="9299448" y="5751576"/>
+            <a:ext cx="2194560" cy="292608"/>
+          </a:xfrm>
+          <a:prstGeom prst="rect">
+            <a:avLst/>
+          </a:prstGeom>
+          <a:noFill/>
+          <a:ln/>
+        </p:spPr>
+        <p:txBody>
+          <a:bodyPr wrap="square" lIns="0" tIns="0" rIns="0" bIns="0" rtlCol="0" anchor="ctr"/>
+          <a:lstStyle/>
+          <a:p>
+            <a:pPr indent="0" marL="0">
+              <a:buNone/>
+            </a:pPr>
+            <a:r>
+              <a:rPr lang="en-US" sz="1100" dirty="0">
+                <a:solidFill>
+                  <a:srgbClr val="617287"/>
+                </a:solidFill>
+              </a:rPr>
+              <a:t>현장 출력 포함</a:t>
+            </a:r>
+            <a:endParaRPr lang="en-US" sz="1100" dirty="0"/>
+          </a:p>
+        </p:txBody>
+      </p:sp>
+      <p:sp>
+        <p:nvSpPr>
+          <p:cNvPr id="79" name="Slide Number Placeholder 0"/>
           <p:cNvSpPr>
             <a:spLocks noGrp="1"/>
           </p:cNvSpPr>
@@ -3348,7 +4936,7 @@
                   <a:srgbClr val="617287"/>
                 </a:solidFill>
               </a:rPr>
-              <a:t>위 줄은 원안, 아래 줄은 이번에 더한 발전 방향</a:t>
+              <a:t>위 줄은 원안, 아래 줄은 발전 방향 · 빨간 표시는 결정이 필요한 단계</a:t>
             </a:r>
             <a:endParaRPr lang="en-US" sz="1500" dirty="0"/>
           </a:p>
@@ -3622,7 +5210,47 @@
       </p:sp>
       <p:sp>
         <p:nvSpPr>
-          <p:cNvPr id="12" name="arrow"/>
+          <p:cNvPr id="12" name="decision-badge"/>
+          <p:cNvSpPr txBox="1"/>
+          <p:nvPr/>
+        </p:nvSpPr>
+        <p:spPr>
+          <a:xfrm>
+            <a:off x="731520" y="5596128"/>
+            <a:ext cx="1005840" cy="292608"/>
+          </a:xfrm>
+          <a:prstGeom prst="roundRect">
+            <a:avLst>
+              <a:gd name="adj" fmla="val 25000"/>
+            </a:avLst>
+          </a:prstGeom>
+          <a:solidFill>
+            <a:srgbClr val="E8614D"/>
+          </a:solidFill>
+          <a:ln/>
+        </p:spPr>
+        <p:txBody>
+          <a:bodyPr wrap="square" lIns="0" tIns="0" rIns="0" bIns="0" rtlCol="0" anchor="ctr"/>
+          <a:lstStyle/>
+          <a:p>
+            <a:pPr algn="ctr" indent="0" marL="0">
+              <a:buNone/>
+            </a:pPr>
+            <a:r>
+              <a:rPr lang="en-US" sz="1100" b="1" dirty="0">
+                <a:solidFill>
+                  <a:srgbClr val="FFFFFF"/>
+                </a:solidFill>
+              </a:rPr>
+              <a:t>결정 ①</a:t>
+            </a:r>
+            <a:endParaRPr lang="en-US" sz="1100" dirty="0"/>
+          </a:p>
+        </p:txBody>
+      </p:sp>
+      <p:sp>
+        <p:nvSpPr>
+          <p:cNvPr id="13" name="arrow"/>
           <p:cNvSpPr/>
           <p:nvPr/>
         </p:nvSpPr>
@@ -3647,7 +5275,7 @@
       </p:sp>
       <p:sp>
         <p:nvSpPr>
-          <p:cNvPr id="13" name="step-card-02"/>
+          <p:cNvPr id="14" name="step-card-02"/>
           <p:cNvSpPr/>
           <p:nvPr/>
         </p:nvSpPr>
@@ -3674,7 +5302,7 @@
       </p:sp>
       <p:sp>
         <p:nvSpPr>
-          <p:cNvPr id="14" name="Text 12"/>
+          <p:cNvPr id="15" name="Text 13"/>
           <p:cNvSpPr txBox="1"/>
           <p:nvPr/>
         </p:nvSpPr>
@@ -3710,7 +5338,7 @@
       </p:sp>
       <p:sp>
         <p:nvSpPr>
-          <p:cNvPr id="15" name="Text 13"/>
+          <p:cNvPr id="16" name="Text 14"/>
           <p:cNvSpPr txBox="1"/>
           <p:nvPr/>
         </p:nvSpPr>
@@ -3746,7 +5374,7 @@
       </p:sp>
       <p:sp>
         <p:nvSpPr>
-          <p:cNvPr id="16" name="Text 14"/>
+          <p:cNvPr id="17" name="Text 15"/>
           <p:cNvSpPr txBox="1"/>
           <p:nvPr/>
         </p:nvSpPr>
@@ -3782,7 +5410,7 @@
       </p:sp>
       <p:sp>
         <p:nvSpPr>
-          <p:cNvPr id="17" name="Text 15"/>
+          <p:cNvPr id="18" name="Text 16"/>
           <p:cNvSpPr txBox="1"/>
           <p:nvPr/>
         </p:nvSpPr>
@@ -3818,7 +5446,7 @@
       </p:sp>
       <p:sp>
         <p:nvSpPr>
-          <p:cNvPr id="18" name="Shape 16"/>
+          <p:cNvPr id="19" name="Shape 17"/>
           <p:cNvSpPr/>
           <p:nvPr/>
         </p:nvSpPr>
@@ -3841,7 +5469,7 @@
       </p:sp>
       <p:sp>
         <p:nvSpPr>
-          <p:cNvPr id="19" name="Text 17"/>
+          <p:cNvPr id="20" name="Text 18"/>
           <p:cNvSpPr txBox="1"/>
           <p:nvPr/>
         </p:nvSpPr>
@@ -3877,7 +5505,7 @@
       </p:sp>
       <p:sp>
         <p:nvSpPr>
-          <p:cNvPr id="20" name="Text 18"/>
+          <p:cNvPr id="21" name="Text 19"/>
           <p:cNvSpPr txBox="1"/>
           <p:nvPr/>
         </p:nvSpPr>
@@ -3913,7 +5541,47 @@
       </p:sp>
       <p:sp>
         <p:nvSpPr>
-          <p:cNvPr id="21" name="arrow"/>
+          <p:cNvPr id="22" name="decision-badge"/>
+          <p:cNvSpPr txBox="1"/>
+          <p:nvPr/>
+        </p:nvSpPr>
+        <p:spPr>
+          <a:xfrm>
+            <a:off x="2990088" y="5596128"/>
+            <a:ext cx="1005840" cy="292608"/>
+          </a:xfrm>
+          <a:prstGeom prst="roundRect">
+            <a:avLst>
+              <a:gd name="adj" fmla="val 25000"/>
+            </a:avLst>
+          </a:prstGeom>
+          <a:solidFill>
+            <a:srgbClr val="E8614D"/>
+          </a:solidFill>
+          <a:ln/>
+        </p:spPr>
+        <p:txBody>
+          <a:bodyPr wrap="square" lIns="0" tIns="0" rIns="0" bIns="0" rtlCol="0" anchor="ctr"/>
+          <a:lstStyle/>
+          <a:p>
+            <a:pPr algn="ctr" indent="0" marL="0">
+              <a:buNone/>
+            </a:pPr>
+            <a:r>
+              <a:rPr lang="en-US" sz="1100" b="1" dirty="0">
+                <a:solidFill>
+                  <a:srgbClr val="FFFFFF"/>
+                </a:solidFill>
+              </a:rPr>
+              <a:t>결정 ②</a:t>
+            </a:r>
+            <a:endParaRPr lang="en-US" sz="1100" dirty="0"/>
+          </a:p>
+        </p:txBody>
+      </p:sp>
+      <p:sp>
+        <p:nvSpPr>
+          <p:cNvPr id="23" name="arrow"/>
           <p:cNvSpPr/>
           <p:nvPr/>
         </p:nvSpPr>
@@ -3938,7 +5606,7 @@
       </p:sp>
       <p:sp>
         <p:nvSpPr>
-          <p:cNvPr id="22" name="step-card-03"/>
+          <p:cNvPr id="24" name="step-card-03"/>
           <p:cNvSpPr/>
           <p:nvPr/>
         </p:nvSpPr>
@@ -3965,7 +5633,7 @@
       </p:sp>
       <p:sp>
         <p:nvSpPr>
-          <p:cNvPr id="23" name="Text 21"/>
+          <p:cNvPr id="25" name="Text 23"/>
           <p:cNvSpPr txBox="1"/>
           <p:nvPr/>
         </p:nvSpPr>
@@ -4001,7 +5669,7 @@
       </p:sp>
       <p:sp>
         <p:nvSpPr>
-          <p:cNvPr id="24" name="Text 22"/>
+          <p:cNvPr id="26" name="Text 24"/>
           <p:cNvSpPr txBox="1"/>
           <p:nvPr/>
         </p:nvSpPr>
@@ -4037,7 +5705,7 @@
       </p:sp>
       <p:sp>
         <p:nvSpPr>
-          <p:cNvPr id="25" name="Text 23"/>
+          <p:cNvPr id="27" name="Text 25"/>
           <p:cNvSpPr txBox="1"/>
           <p:nvPr/>
         </p:nvSpPr>
@@ -4073,7 +5741,7 @@
       </p:sp>
       <p:sp>
         <p:nvSpPr>
-          <p:cNvPr id="26" name="Text 24"/>
+          <p:cNvPr id="28" name="Text 26"/>
           <p:cNvSpPr txBox="1"/>
           <p:nvPr/>
         </p:nvSpPr>
@@ -4109,7 +5777,7 @@
       </p:sp>
       <p:sp>
         <p:nvSpPr>
-          <p:cNvPr id="27" name="Shape 25"/>
+          <p:cNvPr id="29" name="Shape 27"/>
           <p:cNvSpPr/>
           <p:nvPr/>
         </p:nvSpPr>
@@ -4132,7 +5800,7 @@
       </p:sp>
       <p:sp>
         <p:nvSpPr>
-          <p:cNvPr id="28" name="Text 26"/>
+          <p:cNvPr id="30" name="Text 28"/>
           <p:cNvSpPr txBox="1"/>
           <p:nvPr/>
         </p:nvSpPr>
@@ -4168,7 +5836,7 @@
       </p:sp>
       <p:sp>
         <p:nvSpPr>
-          <p:cNvPr id="29" name="Text 27"/>
+          <p:cNvPr id="31" name="Text 29"/>
           <p:cNvSpPr txBox="1"/>
           <p:nvPr/>
         </p:nvSpPr>
@@ -4204,7 +5872,47 @@
       </p:sp>
       <p:sp>
         <p:nvSpPr>
-          <p:cNvPr id="30" name="arrow"/>
+          <p:cNvPr id="32" name="decision-badge"/>
+          <p:cNvSpPr txBox="1"/>
+          <p:nvPr/>
+        </p:nvSpPr>
+        <p:spPr>
+          <a:xfrm>
+            <a:off x="5248656" y="5596128"/>
+            <a:ext cx="1005840" cy="292608"/>
+          </a:xfrm>
+          <a:prstGeom prst="roundRect">
+            <a:avLst>
+              <a:gd name="adj" fmla="val 25000"/>
+            </a:avLst>
+          </a:prstGeom>
+          <a:solidFill>
+            <a:srgbClr val="E8614D"/>
+          </a:solidFill>
+          <a:ln/>
+        </p:spPr>
+        <p:txBody>
+          <a:bodyPr wrap="square" lIns="0" tIns="0" rIns="0" bIns="0" rtlCol="0" anchor="ctr"/>
+          <a:lstStyle/>
+          <a:p>
+            <a:pPr algn="ctr" indent="0" marL="0">
+              <a:buNone/>
+            </a:pPr>
+            <a:r>
+              <a:rPr lang="en-US" sz="1100" b="1" dirty="0">
+                <a:solidFill>
+                  <a:srgbClr val="FFFFFF"/>
+                </a:solidFill>
+              </a:rPr>
+              <a:t>결정 ③</a:t>
+            </a:r>
+            <a:endParaRPr lang="en-US" sz="1100" dirty="0"/>
+          </a:p>
+        </p:txBody>
+      </p:sp>
+      <p:sp>
+        <p:nvSpPr>
+          <p:cNvPr id="33" name="arrow"/>
           <p:cNvSpPr/>
           <p:nvPr/>
         </p:nvSpPr>
@@ -4229,7 +5937,7 @@
       </p:sp>
       <p:sp>
         <p:nvSpPr>
-          <p:cNvPr id="31" name="step-card-04"/>
+          <p:cNvPr id="34" name="step-card-04"/>
           <p:cNvSpPr/>
           <p:nvPr/>
         </p:nvSpPr>
@@ -4256,7 +5964,7 @@
       </p:sp>
       <p:sp>
         <p:nvSpPr>
-          <p:cNvPr id="32" name="Text 30"/>
+          <p:cNvPr id="35" name="Text 33"/>
           <p:cNvSpPr txBox="1"/>
           <p:nvPr/>
         </p:nvSpPr>
@@ -4292,7 +6000,7 @@
       </p:sp>
       <p:sp>
         <p:nvSpPr>
-          <p:cNvPr id="33" name="Text 31"/>
+          <p:cNvPr id="36" name="Text 34"/>
           <p:cNvSpPr txBox="1"/>
           <p:nvPr/>
         </p:nvSpPr>
@@ -4328,7 +6036,7 @@
       </p:sp>
       <p:sp>
         <p:nvSpPr>
-          <p:cNvPr id="34" name="Text 32"/>
+          <p:cNvPr id="37" name="Text 35"/>
           <p:cNvSpPr txBox="1"/>
           <p:nvPr/>
         </p:nvSpPr>
@@ -4364,7 +6072,7 @@
       </p:sp>
       <p:sp>
         <p:nvSpPr>
-          <p:cNvPr id="35" name="Text 33"/>
+          <p:cNvPr id="38" name="Text 36"/>
           <p:cNvSpPr txBox="1"/>
           <p:nvPr/>
         </p:nvSpPr>
@@ -4400,7 +6108,7 @@
       </p:sp>
       <p:sp>
         <p:nvSpPr>
-          <p:cNvPr id="36" name="Shape 34"/>
+          <p:cNvPr id="39" name="Shape 37"/>
           <p:cNvSpPr/>
           <p:nvPr/>
         </p:nvSpPr>
@@ -4423,7 +6131,7 @@
       </p:sp>
       <p:sp>
         <p:nvSpPr>
-          <p:cNvPr id="37" name="Text 35"/>
+          <p:cNvPr id="40" name="Text 38"/>
           <p:cNvSpPr txBox="1"/>
           <p:nvPr/>
         </p:nvSpPr>
@@ -4459,7 +6167,7 @@
       </p:sp>
       <p:sp>
         <p:nvSpPr>
-          <p:cNvPr id="38" name="Text 36"/>
+          <p:cNvPr id="41" name="Text 39"/>
           <p:cNvSpPr txBox="1"/>
           <p:nvPr/>
         </p:nvSpPr>
@@ -4495,7 +6203,47 @@
       </p:sp>
       <p:sp>
         <p:nvSpPr>
-          <p:cNvPr id="39" name="arrow"/>
+          <p:cNvPr id="42" name="decision-badge"/>
+          <p:cNvSpPr txBox="1"/>
+          <p:nvPr/>
+        </p:nvSpPr>
+        <p:spPr>
+          <a:xfrm>
+            <a:off x="7507224" y="5596128"/>
+            <a:ext cx="1005840" cy="292608"/>
+          </a:xfrm>
+          <a:prstGeom prst="roundRect">
+            <a:avLst>
+              <a:gd name="adj" fmla="val 25000"/>
+            </a:avLst>
+          </a:prstGeom>
+          <a:solidFill>
+            <a:srgbClr val="E8614D"/>
+          </a:solidFill>
+          <a:ln/>
+        </p:spPr>
+        <p:txBody>
+          <a:bodyPr wrap="square" lIns="0" tIns="0" rIns="0" bIns="0" rtlCol="0" anchor="ctr"/>
+          <a:lstStyle/>
+          <a:p>
+            <a:pPr algn="ctr" indent="0" marL="0">
+              <a:buNone/>
+            </a:pPr>
+            <a:r>
+              <a:rPr lang="en-US" sz="1100" b="1" dirty="0">
+                <a:solidFill>
+                  <a:srgbClr val="FFFFFF"/>
+                </a:solidFill>
+              </a:rPr>
+              <a:t>결정 ④</a:t>
+            </a:r>
+            <a:endParaRPr lang="en-US" sz="1100" dirty="0"/>
+          </a:p>
+        </p:txBody>
+      </p:sp>
+      <p:sp>
+        <p:nvSpPr>
+          <p:cNvPr id="43" name="arrow"/>
           <p:cNvSpPr/>
           <p:nvPr/>
         </p:nvSpPr>
@@ -4520,7 +6268,7 @@
       </p:sp>
       <p:sp>
         <p:nvSpPr>
-          <p:cNvPr id="40" name="step-card-05"/>
+          <p:cNvPr id="44" name="step-card-05"/>
           <p:cNvSpPr/>
           <p:nvPr/>
         </p:nvSpPr>
@@ -4547,7 +6295,7 @@
       </p:sp>
       <p:sp>
         <p:nvSpPr>
-          <p:cNvPr id="41" name="Text 39"/>
+          <p:cNvPr id="45" name="Text 43"/>
           <p:cNvSpPr txBox="1"/>
           <p:nvPr/>
         </p:nvSpPr>
@@ -4583,7 +6331,7 @@
       </p:sp>
       <p:sp>
         <p:nvSpPr>
-          <p:cNvPr id="42" name="chip-NEW"/>
+          <p:cNvPr id="46" name="chip-NEW"/>
           <p:cNvSpPr txBox="1"/>
           <p:nvPr/>
         </p:nvSpPr>
@@ -4623,7 +6371,7 @@
       </p:sp>
       <p:sp>
         <p:nvSpPr>
-          <p:cNvPr id="43" name="Text 41"/>
+          <p:cNvPr id="47" name="Text 45"/>
           <p:cNvSpPr txBox="1"/>
           <p:nvPr/>
         </p:nvSpPr>
@@ -4659,7 +6407,7 @@
       </p:sp>
       <p:sp>
         <p:nvSpPr>
-          <p:cNvPr id="44" name="Text 42"/>
+          <p:cNvPr id="48" name="Text 46"/>
           <p:cNvSpPr txBox="1"/>
           <p:nvPr/>
         </p:nvSpPr>
@@ -4695,7 +6443,7 @@
       </p:sp>
       <p:sp>
         <p:nvSpPr>
-          <p:cNvPr id="45" name="Text 43"/>
+          <p:cNvPr id="49" name="Text 47"/>
           <p:cNvSpPr txBox="1"/>
           <p:nvPr/>
         </p:nvSpPr>
@@ -4731,7 +6479,7 @@
       </p:sp>
       <p:sp>
         <p:nvSpPr>
-          <p:cNvPr id="46" name="Shape 44"/>
+          <p:cNvPr id="50" name="Shape 48"/>
           <p:cNvSpPr/>
           <p:nvPr/>
         </p:nvSpPr>
@@ -4754,7 +6502,7 @@
       </p:sp>
       <p:sp>
         <p:nvSpPr>
-          <p:cNvPr id="47" name="Text 45"/>
+          <p:cNvPr id="51" name="Text 49"/>
           <p:cNvSpPr txBox="1"/>
           <p:nvPr/>
         </p:nvSpPr>
@@ -4790,7 +6538,7 @@
       </p:sp>
       <p:sp>
         <p:nvSpPr>
-          <p:cNvPr id="48" name="Text 46"/>
+          <p:cNvPr id="52" name="Text 50"/>
           <p:cNvSpPr txBox="1"/>
           <p:nvPr/>
         </p:nvSpPr>
@@ -4826,7 +6574,47 @@
       </p:sp>
       <p:sp>
         <p:nvSpPr>
-          <p:cNvPr id="25" name="Slide Number Placeholder 0"/>
+          <p:cNvPr id="53" name="decision-badge"/>
+          <p:cNvSpPr txBox="1"/>
+          <p:nvPr/>
+        </p:nvSpPr>
+        <p:spPr>
+          <a:xfrm>
+            <a:off x="9765792" y="5596128"/>
+            <a:ext cx="1005840" cy="292608"/>
+          </a:xfrm>
+          <a:prstGeom prst="roundRect">
+            <a:avLst>
+              <a:gd name="adj" fmla="val 25000"/>
+            </a:avLst>
+          </a:prstGeom>
+          <a:solidFill>
+            <a:srgbClr val="E8614D"/>
+          </a:solidFill>
+          <a:ln/>
+        </p:spPr>
+        <p:txBody>
+          <a:bodyPr wrap="square" lIns="0" tIns="0" rIns="0" bIns="0" rtlCol="0" anchor="ctr"/>
+          <a:lstStyle/>
+          <a:p>
+            <a:pPr algn="ctr" indent="0" marL="0">
+              <a:buNone/>
+            </a:pPr>
+            <a:r>
+              <a:rPr lang="en-US" sz="1100" b="1" dirty="0">
+                <a:solidFill>
+                  <a:srgbClr val="FFFFFF"/>
+                </a:solidFill>
+              </a:rPr>
+              <a:t>결정 ⑤</a:t>
+            </a:r>
+            <a:endParaRPr lang="en-US" sz="1100" dirty="0"/>
+          </a:p>
+        </p:txBody>
+      </p:sp>
+      <p:sp>
+        <p:nvSpPr>
+          <p:cNvPr id="54" name="Slide Number Placeholder 0"/>
           <p:cNvSpPr>
             <a:spLocks noGrp="1"/>
           </p:cNvSpPr>
@@ -5796,7 +7584,7 @@
       </p:sp>
       <p:sp>
         <p:nvSpPr>
-          <p:cNvPr id="25" name="Slide Number Placeholder 0"/>
+          <p:cNvPr id="27" name="Slide Number Placeholder 0"/>
           <p:cNvSpPr>
             <a:spLocks noGrp="1"/>
           </p:cNvSpPr>
@@ -6807,14 +8595,54 @@
       </p:sp>
       <p:sp>
         <p:nvSpPr>
-          <p:cNvPr id="28" name="Text 26"/>
+          <p:cNvPr id="28" name="decision-pill"/>
           <p:cNvSpPr txBox="1"/>
           <p:nvPr/>
         </p:nvSpPr>
         <p:spPr>
           <a:xfrm>
             <a:off x="548640" y="5870448"/>
-            <a:ext cx="11064240" cy="365760"/>
+            <a:ext cx="4206240" cy="384048"/>
+          </a:xfrm>
+          <a:prstGeom prst="roundRect">
+            <a:avLst>
+              <a:gd name="adj" fmla="val 23810"/>
+            </a:avLst>
+          </a:prstGeom>
+          <a:solidFill>
+            <a:srgbClr val="E8614D"/>
+          </a:solidFill>
+          <a:ln/>
+        </p:spPr>
+        <p:txBody>
+          <a:bodyPr wrap="square" lIns="0" tIns="0" rIns="0" bIns="0" rtlCol="0" anchor="ctr"/>
+          <a:lstStyle/>
+          <a:p>
+            <a:pPr algn="ctr" indent="0" marL="0">
+              <a:buNone/>
+            </a:pPr>
+            <a:r>
+              <a:rPr lang="en-US" sz="1300" b="1" dirty="0">
+                <a:solidFill>
+                  <a:srgbClr val="FFFFFF"/>
+                </a:solidFill>
+              </a:rPr>
+              <a:t>결정 ①  기본 도안 · A / B / C 중 선택</a:t>
+            </a:r>
+            <a:endParaRPr lang="en-US" sz="1300" dirty="0"/>
+          </a:p>
+        </p:txBody>
+      </p:sp>
+      <p:sp>
+        <p:nvSpPr>
+          <p:cNvPr id="29" name="Text 27"/>
+          <p:cNvSpPr txBox="1"/>
+          <p:nvPr/>
+        </p:nvSpPr>
+        <p:spPr>
+          <a:xfrm>
+            <a:off x="5029200" y="5870448"/>
+            <a:ext cx="6583680" cy="384048"/>
           </a:xfrm>
           <a:prstGeom prst="rect">
             <a:avLst/>
@@ -6830,9 +8658,9 @@
               <a:buNone/>
             </a:pPr>
             <a:r>
-              <a:rPr lang="en-US" sz="1300" b="1" dirty="0">
-                <a:solidFill>
-                  <a:srgbClr val="E8614D"/>
+              <a:rPr lang="en-US" sz="1200" b="1" dirty="0">
+                <a:solidFill>
+                  <a:srgbClr val="617287"/>
                 </a:solidFill>
               </a:rPr>
               <a:t>확인할 것  </a:t>
@@ -6841,20 +8669,20 @@
               <a:buNone/>
             </a:pPr>
             <a:r>
-              <a:rPr lang="en-US" sz="1300" dirty="0">
+              <a:rPr lang="en-US" sz="1200" dirty="0">
                 <a:solidFill>
                   <a:srgbClr val="16243A"/>
                 </a:solidFill>
               </a:rPr>
               <a:t>테이블 좌석 수 · 드로잉 시간(가정 3–5분) · A/B/C 중 기본안</a:t>
             </a:r>
-            <a:endParaRPr lang="en-US" sz="1300" dirty="0"/>
-          </a:p>
-        </p:txBody>
-      </p:sp>
-      <p:sp>
-        <p:nvSpPr>
-          <p:cNvPr id="25" name="Slide Number Placeholder 0"/>
+            <a:endParaRPr lang="en-US" sz="1200" dirty="0"/>
+          </a:p>
+        </p:txBody>
+      </p:sp>
+      <p:sp>
+        <p:nvSpPr>
+          <p:cNvPr id="30" name="Slide Number Placeholder 0"/>
           <p:cNvSpPr>
             <a:spLocks noGrp="1"/>
           </p:cNvSpPr>
@@ -6899,7 +8727,7 @@
       </p:sp>
       <p:grpSp>
         <p:nvGrpSpPr>
-          <p:cNvPr id="900" name="원안 그림"/>
+          <p:cNvPr id="31" name="원안 그림"/>
           <p:cNvGrpSpPr/>
           <p:nvPr/>
         </p:nvGrpSpPr>
@@ -6913,7 +8741,7 @@
         </p:grpSpPr>
         <p:sp>
           <p:nvSpPr>
-            <p:cNvPr id="901" name="Shape 18"/>
+            <p:cNvPr id="32" name="Shape 18"/>
             <p:cNvSpPr/>
             <p:nvPr/>
           </p:nvSpPr>
@@ -6942,7 +8770,7 @@
         </p:sp>
         <p:sp>
           <p:nvSpPr>
-            <p:cNvPr id="902" name="Shape 19"/>
+            <p:cNvPr id="33" name="Shape 19"/>
             <p:cNvSpPr/>
             <p:nvPr/>
           </p:nvSpPr>
@@ -6969,7 +8797,7 @@
         </p:sp>
         <p:sp>
           <p:nvSpPr>
-            <p:cNvPr id="903" name="Text 20"/>
+            <p:cNvPr id="34" name="Text 20"/>
             <p:cNvSpPr/>
             <p:nvPr/>
           </p:nvSpPr>
@@ -7010,7 +8838,7 @@
         </p:sp>
         <p:sp>
           <p:nvSpPr>
-            <p:cNvPr id="904" name="Shape 21"/>
+            <p:cNvPr id="35" name="Shape 21"/>
             <p:cNvSpPr/>
             <p:nvPr/>
           </p:nvSpPr>
@@ -7039,7 +8867,7 @@
         </p:sp>
         <p:sp>
           <p:nvSpPr>
-            <p:cNvPr id="905" name="Shape 22"/>
+            <p:cNvPr id="36" name="Shape 22"/>
             <p:cNvSpPr/>
             <p:nvPr/>
           </p:nvSpPr>
@@ -7066,7 +8894,7 @@
         </p:sp>
         <p:sp>
           <p:nvSpPr>
-            <p:cNvPr id="906" name="Shape 23"/>
+            <p:cNvPr id="37" name="Shape 23"/>
             <p:cNvSpPr/>
             <p:nvPr/>
           </p:nvSpPr>
@@ -7093,14 +8921,14 @@
         </p:sp>
         <p:sp>
           <p:nvSpPr>
-            <p:cNvPr id="907" name="Shape 24"/>
+            <p:cNvPr id="38" name="Shape 24"/>
             <p:cNvSpPr/>
             <p:nvPr/>
           </p:nvSpPr>
           <p:spPr>
-            <a:xfrm>
-              <a:off x="7782458" y="4676242"/>
-              <a:ext cx="-166421" cy="427939"/>
+            <a:xfrm flipH="1">
+              <a:off x="7616037" y="4676242"/>
+              <a:ext cx="166421" cy="427939"/>
             </a:xfrm>
             <a:prstGeom prst="line">
               <a:avLst>
@@ -7120,7 +8948,7 @@
         </p:sp>
         <p:sp>
           <p:nvSpPr>
-            <p:cNvPr id="908" name="Shape 25"/>
+            <p:cNvPr id="39" name="Shape 25"/>
             <p:cNvSpPr/>
             <p:nvPr/>
           </p:nvSpPr>
@@ -7147,7 +8975,7 @@
         </p:sp>
         <p:sp>
           <p:nvSpPr>
-            <p:cNvPr id="909" name="Shape 26"/>
+            <p:cNvPr id="40" name="Shape 26"/>
             <p:cNvSpPr/>
             <p:nvPr/>
           </p:nvSpPr>
@@ -7176,7 +9004,7 @@
         </p:sp>
         <p:sp>
           <p:nvSpPr>
-            <p:cNvPr id="910" name="Shape 27"/>
+            <p:cNvPr id="41" name="Shape 27"/>
             <p:cNvSpPr/>
             <p:nvPr/>
           </p:nvSpPr>
@@ -7205,7 +9033,7 @@
         </p:sp>
         <p:sp>
           <p:nvSpPr>
-            <p:cNvPr id="911" name="Shape 28"/>
+            <p:cNvPr id="42" name="Shape 28"/>
             <p:cNvSpPr/>
             <p:nvPr/>
           </p:nvSpPr>
@@ -7232,7 +9060,7 @@
         </p:sp>
         <p:sp>
           <p:nvSpPr>
-            <p:cNvPr id="912" name="Text 29"/>
+            <p:cNvPr id="43" name="Text 29"/>
             <p:cNvSpPr/>
             <p:nvPr/>
           </p:nvSpPr>
@@ -7273,7 +9101,7 @@
         </p:sp>
         <p:sp>
           <p:nvSpPr>
-            <p:cNvPr id="913" name="Shape 30"/>
+            <p:cNvPr id="44" name="Shape 30"/>
             <p:cNvSpPr/>
             <p:nvPr/>
           </p:nvSpPr>
@@ -7302,7 +9130,7 @@
         </p:sp>
         <p:sp>
           <p:nvSpPr>
-            <p:cNvPr id="914" name="Text 31"/>
+            <p:cNvPr id="45" name="Text 31"/>
             <p:cNvSpPr/>
             <p:nvPr/>
           </p:nvSpPr>
@@ -8310,14 +10138,54 @@
       </p:sp>
       <p:sp>
         <p:nvSpPr>
-          <p:cNvPr id="28" name="Text 26"/>
+          <p:cNvPr id="28" name="decision-pill"/>
           <p:cNvSpPr txBox="1"/>
           <p:nvPr/>
         </p:nvSpPr>
         <p:spPr>
           <a:xfrm>
             <a:off x="548640" y="5870448"/>
-            <a:ext cx="11064240" cy="365760"/>
+            <a:ext cx="4206240" cy="384048"/>
+          </a:xfrm>
+          <a:prstGeom prst="roundRect">
+            <a:avLst>
+              <a:gd name="adj" fmla="val 23810"/>
+            </a:avLst>
+          </a:prstGeom>
+          <a:solidFill>
+            <a:srgbClr val="E8614D"/>
+          </a:solidFill>
+          <a:ln/>
+        </p:spPr>
+        <p:txBody>
+          <a:bodyPr wrap="square" lIns="0" tIns="0" rIns="0" bIns="0" rtlCol="0" anchor="ctr"/>
+          <a:lstStyle/>
+          <a:p>
+            <a:pPr algn="ctr" indent="0" marL="0">
+              <a:buNone/>
+            </a:pPr>
+            <a:r>
+              <a:rPr lang="en-US" sz="1300" b="1" dirty="0">
+                <a:solidFill>
+                  <a:srgbClr val="FFFFFF"/>
+                </a:solidFill>
+              </a:rPr>
+              <a:t>결정 ②  캐릭터 방식 · 2D / 3D 중 선택</a:t>
+            </a:r>
+            <a:endParaRPr lang="en-US" sz="1300" dirty="0"/>
+          </a:p>
+        </p:txBody>
+      </p:sp>
+      <p:sp>
+        <p:nvSpPr>
+          <p:cNvPr id="29" name="Text 27"/>
+          <p:cNvSpPr txBox="1"/>
+          <p:nvPr/>
+        </p:nvSpPr>
+        <p:spPr>
+          <a:xfrm>
+            <a:off x="5029200" y="5870448"/>
+            <a:ext cx="6583680" cy="384048"/>
           </a:xfrm>
           <a:prstGeom prst="rect">
             <a:avLst/>
@@ -8333,9 +10201,9 @@
               <a:buNone/>
             </a:pPr>
             <a:r>
-              <a:rPr lang="en-US" sz="1300" b="1" dirty="0">
-                <a:solidFill>
-                  <a:srgbClr val="E8614D"/>
+              <a:rPr lang="en-US" sz="1200" b="1" dirty="0">
+                <a:solidFill>
+                  <a:srgbClr val="617287"/>
                 </a:solidFill>
               </a:rPr>
               <a:t>확인할 것  </a:t>
@@ -8344,20 +10212,20 @@
               <a:buNone/>
             </a:pPr>
             <a:r>
-              <a:rPr lang="en-US" sz="1300" dirty="0">
+              <a:rPr lang="en-US" sz="1200" dirty="0">
                 <a:solidFill>
                   <a:srgbClr val="16243A"/>
                 </a:solidFill>
               </a:rPr>
               <a:t>스캐너 대수 · 스캔부터 벽 등장까지 시간(가정 10초 이내) · 3D 변환 방식</a:t>
             </a:r>
-            <a:endParaRPr lang="en-US" sz="1300" dirty="0"/>
-          </a:p>
-        </p:txBody>
-      </p:sp>
-      <p:sp>
-        <p:nvSpPr>
-          <p:cNvPr id="25" name="Slide Number Placeholder 0"/>
+            <a:endParaRPr lang="en-US" sz="1200" dirty="0"/>
+          </a:p>
+        </p:txBody>
+      </p:sp>
+      <p:sp>
+        <p:nvSpPr>
+          <p:cNvPr id="30" name="Slide Number Placeholder 0"/>
           <p:cNvSpPr>
             <a:spLocks noGrp="1"/>
           </p:cNvSpPr>
@@ -8402,7 +10270,7 @@
       </p:sp>
       <p:grpSp>
         <p:nvGrpSpPr>
-          <p:cNvPr id="900" name="원안 그림"/>
+          <p:cNvPr id="31" name="원안 그림"/>
           <p:cNvGrpSpPr/>
           <p:nvPr/>
         </p:nvGrpSpPr>
@@ -8416,7 +10284,7 @@
         </p:grpSpPr>
         <p:sp>
           <p:nvSpPr>
-            <p:cNvPr id="901" name="Shape 18"/>
+            <p:cNvPr id="32" name="Shape 18"/>
             <p:cNvSpPr/>
             <p:nvPr/>
           </p:nvSpPr>
@@ -8445,7 +10313,7 @@
         </p:sp>
         <p:sp>
           <p:nvSpPr>
-            <p:cNvPr id="902" name="Shape 19"/>
+            <p:cNvPr id="33" name="Shape 19"/>
             <p:cNvSpPr/>
             <p:nvPr/>
           </p:nvSpPr>
@@ -8472,7 +10340,7 @@
         </p:sp>
         <p:sp>
           <p:nvSpPr>
-            <p:cNvPr id="903" name="Shape 20"/>
+            <p:cNvPr id="34" name="Shape 20"/>
             <p:cNvSpPr/>
             <p:nvPr/>
           </p:nvSpPr>
@@ -8501,7 +10369,7 @@
         </p:sp>
         <p:sp>
           <p:nvSpPr>
-            <p:cNvPr id="904" name="Shape 21"/>
+            <p:cNvPr id="35" name="Shape 21"/>
             <p:cNvSpPr/>
             <p:nvPr/>
           </p:nvSpPr>
@@ -8528,7 +10396,7 @@
         </p:sp>
         <p:sp>
           <p:nvSpPr>
-            <p:cNvPr id="905" name="Shape 22"/>
+            <p:cNvPr id="36" name="Shape 22"/>
             <p:cNvSpPr/>
             <p:nvPr/>
           </p:nvSpPr>
@@ -8555,14 +10423,14 @@
         </p:sp>
         <p:sp>
           <p:nvSpPr>
-            <p:cNvPr id="906" name="Shape 23"/>
+            <p:cNvPr id="37" name="Shape 23"/>
             <p:cNvSpPr/>
             <p:nvPr/>
           </p:nvSpPr>
           <p:spPr>
-            <a:xfrm>
-              <a:off x="6933255" y="4117726"/>
-              <a:ext cx="-101133" cy="260055"/>
+            <a:xfrm flipH="1">
+              <a:off x="6832122" y="4117726"/>
+              <a:ext cx="101133" cy="260055"/>
             </a:xfrm>
             <a:prstGeom prst="line">
               <a:avLst>
@@ -8582,7 +10450,7 @@
         </p:sp>
         <p:sp>
           <p:nvSpPr>
-            <p:cNvPr id="907" name="Shape 24"/>
+            <p:cNvPr id="38" name="Shape 24"/>
             <p:cNvSpPr/>
             <p:nvPr/>
           </p:nvSpPr>
@@ -8609,7 +10477,7 @@
         </p:sp>
         <p:sp>
           <p:nvSpPr>
-            <p:cNvPr id="908" name="Shape 25"/>
+            <p:cNvPr id="39" name="Shape 25"/>
             <p:cNvSpPr/>
             <p:nvPr/>
           </p:nvSpPr>
@@ -8638,7 +10506,7 @@
         </p:sp>
         <p:sp>
           <p:nvSpPr>
-            <p:cNvPr id="909" name="Shape 26"/>
+            <p:cNvPr id="40" name="Shape 26"/>
             <p:cNvSpPr/>
             <p:nvPr/>
           </p:nvSpPr>
@@ -8667,7 +10535,7 @@
         </p:sp>
         <p:sp>
           <p:nvSpPr>
-            <p:cNvPr id="910" name="Shape 27"/>
+            <p:cNvPr id="41" name="Shape 27"/>
             <p:cNvSpPr/>
             <p:nvPr/>
           </p:nvSpPr>
@@ -8696,7 +10564,7 @@
         </p:sp>
         <p:sp>
           <p:nvSpPr>
-            <p:cNvPr id="911" name="Shape 28"/>
+            <p:cNvPr id="42" name="Shape 28"/>
             <p:cNvSpPr/>
             <p:nvPr/>
           </p:nvSpPr>
@@ -8725,7 +10593,7 @@
         </p:sp>
         <p:sp>
           <p:nvSpPr>
-            <p:cNvPr id="912" name="Shape 29"/>
+            <p:cNvPr id="43" name="Shape 29"/>
             <p:cNvSpPr/>
             <p:nvPr/>
           </p:nvSpPr>
@@ -8754,7 +10622,7 @@
         </p:sp>
         <p:sp>
           <p:nvSpPr>
-            <p:cNvPr id="913" name="Shape 30"/>
+            <p:cNvPr id="44" name="Shape 30"/>
             <p:cNvSpPr/>
             <p:nvPr/>
           </p:nvSpPr>
@@ -8783,7 +10651,7 @@
         </p:sp>
         <p:sp>
           <p:nvSpPr>
-            <p:cNvPr id="914" name="Shape 31"/>
+            <p:cNvPr id="45" name="Shape 31"/>
             <p:cNvSpPr/>
             <p:nvPr/>
           </p:nvSpPr>
@@ -8810,7 +10678,7 @@
         </p:sp>
         <p:sp>
           <p:nvSpPr>
-            <p:cNvPr id="915" name="Shape 32"/>
+            <p:cNvPr id="46" name="Shape 32"/>
             <p:cNvSpPr/>
             <p:nvPr/>
           </p:nvSpPr>
@@ -8837,14 +10705,14 @@
         </p:sp>
         <p:sp>
           <p:nvSpPr>
-            <p:cNvPr id="916" name="Shape 33"/>
+            <p:cNvPr id="47" name="Shape 33"/>
             <p:cNvSpPr/>
             <p:nvPr/>
           </p:nvSpPr>
           <p:spPr>
-            <a:xfrm>
-              <a:off x="9800722" y="4031407"/>
-              <a:ext cx="-110094" cy="283098"/>
+            <a:xfrm flipH="1">
+              <a:off x="9690628" y="4031407"/>
+              <a:ext cx="110094" cy="283098"/>
             </a:xfrm>
             <a:prstGeom prst="line">
               <a:avLst>
@@ -8864,7 +10732,7 @@
         </p:sp>
         <p:sp>
           <p:nvSpPr>
-            <p:cNvPr id="917" name="Shape 34"/>
+            <p:cNvPr id="48" name="Shape 34"/>
             <p:cNvSpPr/>
             <p:nvPr/>
           </p:nvSpPr>
@@ -8891,7 +10759,7 @@
         </p:sp>
         <p:sp>
           <p:nvSpPr>
-            <p:cNvPr id="918" name="Shape 35"/>
+            <p:cNvPr id="49" name="Shape 35"/>
             <p:cNvSpPr/>
             <p:nvPr/>
           </p:nvSpPr>
@@ -8920,7 +10788,7 @@
         </p:sp>
         <p:sp>
           <p:nvSpPr>
-            <p:cNvPr id="919" name="Shape 36"/>
+            <p:cNvPr id="50" name="Shape 36"/>
             <p:cNvSpPr/>
             <p:nvPr/>
           </p:nvSpPr>
@@ -8949,7 +10817,7 @@
         </p:sp>
         <p:sp>
           <p:nvSpPr>
-            <p:cNvPr id="920" name="Text 37"/>
+            <p:cNvPr id="51" name="Text 37"/>
             <p:cNvSpPr/>
             <p:nvPr/>
           </p:nvSpPr>
@@ -8990,7 +10858,7 @@
         </p:sp>
         <p:sp>
           <p:nvSpPr>
-            <p:cNvPr id="921" name="Text 38"/>
+            <p:cNvPr id="52" name="Text 38"/>
             <p:cNvSpPr/>
             <p:nvPr/>
           </p:nvSpPr>
@@ -9998,14 +11866,54 @@
       </p:sp>
       <p:sp>
         <p:nvSpPr>
-          <p:cNvPr id="28" name="Text 26"/>
+          <p:cNvPr id="28" name="decision-pill"/>
           <p:cNvSpPr txBox="1"/>
           <p:nvPr/>
         </p:nvSpPr>
         <p:spPr>
           <a:xfrm>
             <a:off x="548640" y="5870448"/>
-            <a:ext cx="11064240" cy="365760"/>
+            <a:ext cx="4206240" cy="384048"/>
+          </a:xfrm>
+          <a:prstGeom prst="roundRect">
+            <a:avLst>
+              <a:gd name="adj" fmla="val 23810"/>
+            </a:avLst>
+          </a:prstGeom>
+          <a:solidFill>
+            <a:srgbClr val="E8614D"/>
+          </a:solidFill>
+          <a:ln/>
+        </p:spPr>
+        <p:txBody>
+          <a:bodyPr wrap="square" lIns="0" tIns="0" rIns="0" bIns="0" rtlCol="0" anchor="ctr"/>
+          <a:lstStyle/>
+          <a:p>
+            <a:pPr algn="ctr" indent="0" marL="0">
+              <a:buNone/>
+            </a:pPr>
+            <a:r>
+              <a:rPr lang="en-US" sz="1300" b="1" dirty="0">
+                <a:solidFill>
+                  <a:srgbClr val="FFFFFF"/>
+                </a:solidFill>
+              </a:rPr>
+              <a:t>결정 ③  배경 방식 · 3가지 중 선택</a:t>
+            </a:r>
+            <a:endParaRPr lang="en-US" sz="1300" dirty="0"/>
+          </a:p>
+        </p:txBody>
+      </p:sp>
+      <p:sp>
+        <p:nvSpPr>
+          <p:cNvPr id="29" name="Text 27"/>
+          <p:cNvSpPr txBox="1"/>
+          <p:nvPr/>
+        </p:nvSpPr>
+        <p:spPr>
+          <a:xfrm>
+            <a:off x="5029200" y="5870448"/>
+            <a:ext cx="6583680" cy="384048"/>
           </a:xfrm>
           <a:prstGeom prst="rect">
             <a:avLst/>
@@ -10021,9 +11929,9 @@
               <a:buNone/>
             </a:pPr>
             <a:r>
-              <a:rPr lang="en-US" sz="1300" b="1" dirty="0">
-                <a:solidFill>
-                  <a:srgbClr val="E8614D"/>
+              <a:rPr lang="en-US" sz="1200" b="1" dirty="0">
+                <a:solidFill>
+                  <a:srgbClr val="617287"/>
                 </a:solidFill>
               </a:rPr>
               <a:t>확인할 것  </a:t>
@@ -10032,20 +11940,20 @@
               <a:buNone/>
             </a:pPr>
             <a:r>
-              <a:rPr lang="en-US" sz="1300" dirty="0">
+              <a:rPr lang="en-US" sz="1200" dirty="0">
                 <a:solidFill>
                   <a:srgbClr val="16243A"/>
                 </a:solidFill>
               </a:rPr>
               <a:t>벽 크기 · 해상도 · 터치 센서 방식 · 동시 캐릭터 수(가정 30–40)</a:t>
             </a:r>
-            <a:endParaRPr lang="en-US" sz="1300" dirty="0"/>
-          </a:p>
-        </p:txBody>
-      </p:sp>
-      <p:sp>
-        <p:nvSpPr>
-          <p:cNvPr id="25" name="Slide Number Placeholder 0"/>
+            <a:endParaRPr lang="en-US" sz="1200" dirty="0"/>
+          </a:p>
+        </p:txBody>
+      </p:sp>
+      <p:sp>
+        <p:nvSpPr>
+          <p:cNvPr id="30" name="Slide Number Placeholder 0"/>
           <p:cNvSpPr>
             <a:spLocks noGrp="1"/>
           </p:cNvSpPr>
@@ -10090,7 +11998,7 @@
       </p:sp>
       <p:grpSp>
         <p:nvGrpSpPr>
-          <p:cNvPr id="900" name="원안 그림"/>
+          <p:cNvPr id="31" name="원안 그림"/>
           <p:cNvGrpSpPr/>
           <p:nvPr/>
         </p:nvGrpSpPr>
@@ -10104,7 +12012,7 @@
         </p:grpSpPr>
         <p:sp>
           <p:nvSpPr>
-            <p:cNvPr id="901" name="Shape 18"/>
+            <p:cNvPr id="32" name="Shape 18"/>
             <p:cNvSpPr/>
             <p:nvPr/>
           </p:nvSpPr>
@@ -10133,7 +12041,7 @@
         </p:sp>
         <p:sp>
           <p:nvSpPr>
-            <p:cNvPr id="902" name="Shape 19"/>
+            <p:cNvPr id="33" name="Shape 19"/>
             <p:cNvSpPr/>
             <p:nvPr/>
           </p:nvSpPr>
@@ -10162,7 +12070,7 @@
         </p:sp>
         <p:sp>
           <p:nvSpPr>
-            <p:cNvPr id="903" name="Shape 20"/>
+            <p:cNvPr id="34" name="Shape 20"/>
             <p:cNvSpPr/>
             <p:nvPr/>
           </p:nvSpPr>
@@ -10191,7 +12099,7 @@
         </p:sp>
         <p:sp>
           <p:nvSpPr>
-            <p:cNvPr id="904" name="Shape 21"/>
+            <p:cNvPr id="35" name="Shape 21"/>
             <p:cNvSpPr/>
             <p:nvPr/>
           </p:nvSpPr>
@@ -10220,7 +12128,7 @@
         </p:sp>
         <p:sp>
           <p:nvSpPr>
-            <p:cNvPr id="905" name="Shape 22"/>
+            <p:cNvPr id="36" name="Shape 22"/>
             <p:cNvSpPr/>
             <p:nvPr/>
           </p:nvSpPr>
@@ -10249,7 +12157,7 @@
         </p:sp>
         <p:sp>
           <p:nvSpPr>
-            <p:cNvPr id="906" name="Shape 23"/>
+            <p:cNvPr id="37" name="Shape 23"/>
             <p:cNvSpPr/>
             <p:nvPr/>
           </p:nvSpPr>
@@ -10276,7 +12184,7 @@
         </p:sp>
         <p:sp>
           <p:nvSpPr>
-            <p:cNvPr id="907" name="Shape 24"/>
+            <p:cNvPr id="38" name="Shape 24"/>
             <p:cNvSpPr/>
             <p:nvPr/>
           </p:nvSpPr>
@@ -10303,14 +12211,14 @@
         </p:sp>
         <p:sp>
           <p:nvSpPr>
-            <p:cNvPr id="908" name="Shape 25"/>
+            <p:cNvPr id="39" name="Shape 25"/>
             <p:cNvSpPr/>
             <p:nvPr/>
           </p:nvSpPr>
           <p:spPr>
-            <a:xfrm>
-              <a:off x="7787945" y="4058107"/>
-              <a:ext cx="-140818" cy="362102"/>
+            <a:xfrm flipH="1">
+              <a:off x="7647127" y="4058107"/>
+              <a:ext cx="140818" cy="362102"/>
             </a:xfrm>
             <a:prstGeom prst="line">
               <a:avLst>
@@ -10330,7 +12238,7 @@
         </p:sp>
         <p:sp>
           <p:nvSpPr>
-            <p:cNvPr id="909" name="Shape 26"/>
+            <p:cNvPr id="40" name="Shape 26"/>
             <p:cNvSpPr/>
             <p:nvPr/>
           </p:nvSpPr>
@@ -10357,7 +12265,7 @@
         </p:sp>
         <p:sp>
           <p:nvSpPr>
-            <p:cNvPr id="910" name="Shape 27"/>
+            <p:cNvPr id="41" name="Shape 27"/>
             <p:cNvSpPr/>
             <p:nvPr/>
           </p:nvSpPr>
@@ -10386,7 +12294,7 @@
         </p:sp>
         <p:sp>
           <p:nvSpPr>
-            <p:cNvPr id="911" name="Shape 28"/>
+            <p:cNvPr id="42" name="Shape 28"/>
             <p:cNvSpPr/>
             <p:nvPr/>
           </p:nvSpPr>
@@ -10415,7 +12323,7 @@
         </p:sp>
         <p:sp>
           <p:nvSpPr>
-            <p:cNvPr id="912" name="Shape 29"/>
+            <p:cNvPr id="43" name="Shape 29"/>
             <p:cNvSpPr/>
             <p:nvPr/>
           </p:nvSpPr>
@@ -10444,7 +12352,7 @@
         </p:sp>
         <p:sp>
           <p:nvSpPr>
-            <p:cNvPr id="913" name="Shape 30"/>
+            <p:cNvPr id="44" name="Shape 30"/>
             <p:cNvSpPr/>
             <p:nvPr/>
           </p:nvSpPr>
@@ -10471,7 +12379,7 @@
         </p:sp>
         <p:sp>
           <p:nvSpPr>
-            <p:cNvPr id="914" name="Shape 31"/>
+            <p:cNvPr id="45" name="Shape 31"/>
             <p:cNvSpPr/>
             <p:nvPr/>
           </p:nvSpPr>
@@ -10498,14 +12406,14 @@
         </p:sp>
         <p:sp>
           <p:nvSpPr>
-            <p:cNvPr id="915" name="Shape 32"/>
+            <p:cNvPr id="46" name="Shape 32"/>
             <p:cNvSpPr/>
             <p:nvPr/>
           </p:nvSpPr>
           <p:spPr>
-            <a:xfrm>
-              <a:off x="9530151" y="3962278"/>
-              <a:ext cx="-101133" cy="260055"/>
+            <a:xfrm flipH="1">
+              <a:off x="9429018" y="3962278"/>
+              <a:ext cx="101133" cy="260055"/>
             </a:xfrm>
             <a:prstGeom prst="line">
               <a:avLst>
@@ -10525,7 +12433,7 @@
         </p:sp>
         <p:sp>
           <p:nvSpPr>
-            <p:cNvPr id="916" name="Shape 33"/>
+            <p:cNvPr id="47" name="Shape 33"/>
             <p:cNvSpPr/>
             <p:nvPr/>
           </p:nvSpPr>
@@ -10552,7 +12460,7 @@
         </p:sp>
         <p:sp>
           <p:nvSpPr>
-            <p:cNvPr id="917" name="Shape 34"/>
+            <p:cNvPr id="48" name="Shape 34"/>
             <p:cNvSpPr/>
             <p:nvPr/>
           </p:nvSpPr>
@@ -10581,7 +12489,7 @@
         </p:sp>
         <p:sp>
           <p:nvSpPr>
-            <p:cNvPr id="918" name="Shape 35"/>
+            <p:cNvPr id="49" name="Shape 35"/>
             <p:cNvSpPr/>
             <p:nvPr/>
           </p:nvSpPr>
@@ -10610,7 +12518,7 @@
         </p:sp>
         <p:sp>
           <p:nvSpPr>
-            <p:cNvPr id="919" name="Shape 36"/>
+            <p:cNvPr id="50" name="Shape 36"/>
             <p:cNvSpPr/>
             <p:nvPr/>
           </p:nvSpPr>
@@ -10639,7 +12547,7 @@
         </p:sp>
         <p:sp>
           <p:nvSpPr>
-            <p:cNvPr id="920" name="Shape 37"/>
+            <p:cNvPr id="51" name="Shape 37"/>
             <p:cNvSpPr/>
             <p:nvPr/>
           </p:nvSpPr>
@@ -10668,7 +12576,7 @@
         </p:sp>
         <p:sp>
           <p:nvSpPr>
-            <p:cNvPr id="921" name="Text 38"/>
+            <p:cNvPr id="52" name="Text 38"/>
             <p:cNvSpPr/>
             <p:nvPr/>
           </p:nvSpPr>
@@ -11676,14 +13584,54 @@
       </p:sp>
       <p:sp>
         <p:nvSpPr>
-          <p:cNvPr id="28" name="Text 26"/>
+          <p:cNvPr id="28" name="decision-pill"/>
           <p:cNvSpPr txBox="1"/>
           <p:nvPr/>
         </p:nvSpPr>
         <p:spPr>
           <a:xfrm>
             <a:off x="548640" y="5870448"/>
-            <a:ext cx="11064240" cy="365760"/>
+            <a:ext cx="4206240" cy="384048"/>
+          </a:xfrm>
+          <a:prstGeom prst="roundRect">
+            <a:avLst>
+              <a:gd name="adj" fmla="val 23810"/>
+            </a:avLst>
+          </a:prstGeom>
+          <a:solidFill>
+            <a:srgbClr val="E8614D"/>
+          </a:solidFill>
+          <a:ln/>
+        </p:spPr>
+        <p:txBody>
+          <a:bodyPr wrap="square" lIns="0" tIns="0" rIns="0" bIns="0" rtlCol="0" anchor="ctr"/>
+          <a:lstStyle/>
+          <a:p>
+            <a:pPr algn="ctr" indent="0" marL="0">
+              <a:buNone/>
+            </a:pPr>
+            <a:r>
+              <a:rPr lang="en-US" sz="1300" b="1" dirty="0">
+                <a:solidFill>
+                  <a:srgbClr val="FFFFFF"/>
+                </a:solidFill>
+              </a:rPr>
+              <a:t>결정 ④  퍼레이드 운영 · 3가지 중 선택</a:t>
+            </a:r>
+            <a:endParaRPr lang="en-US" sz="1300" dirty="0"/>
+          </a:p>
+        </p:txBody>
+      </p:sp>
+      <p:sp>
+        <p:nvSpPr>
+          <p:cNvPr id="29" name="Text 27"/>
+          <p:cNvSpPr txBox="1"/>
+          <p:nvPr/>
+        </p:nvSpPr>
+        <p:spPr>
+          <a:xfrm>
+            <a:off x="5029200" y="5870448"/>
+            <a:ext cx="6583680" cy="384048"/>
           </a:xfrm>
           <a:prstGeom prst="rect">
             <a:avLst/>
@@ -11699,9 +13647,9 @@
               <a:buNone/>
             </a:pPr>
             <a:r>
-              <a:rPr lang="en-US" sz="1300" b="1" dirty="0">
-                <a:solidFill>
-                  <a:srgbClr val="E8614D"/>
+              <a:rPr lang="en-US" sz="1200" b="1" dirty="0">
+                <a:solidFill>
+                  <a:srgbClr val="617287"/>
                 </a:solidFill>
               </a:rPr>
               <a:t>확인할 것  </a:t>
@@ -11710,20 +13658,20 @@
               <a:buNone/>
             </a:pPr>
             <a:r>
-              <a:rPr lang="en-US" sz="1300" dirty="0">
+              <a:rPr lang="en-US" sz="1200" dirty="0">
                 <a:solidFill>
                   <a:srgbClr val="16243A"/>
                 </a:solidFill>
               </a:rPr>
               <a:t>파사드 해상도 · 비율 · 기존 영상 원본 형식(실시간 합성 가능 여부)</a:t>
             </a:r>
-            <a:endParaRPr lang="en-US" sz="1300" dirty="0"/>
-          </a:p>
-        </p:txBody>
-      </p:sp>
-      <p:sp>
-        <p:nvSpPr>
-          <p:cNvPr id="25" name="Slide Number Placeholder 0"/>
+            <a:endParaRPr lang="en-US" sz="1200" dirty="0"/>
+          </a:p>
+        </p:txBody>
+      </p:sp>
+      <p:sp>
+        <p:nvSpPr>
+          <p:cNvPr id="30" name="Slide Number Placeholder 0"/>
           <p:cNvSpPr>
             <a:spLocks noGrp="1"/>
           </p:cNvSpPr>
@@ -11768,7 +13716,7 @@
       </p:sp>
       <p:grpSp>
         <p:nvGrpSpPr>
-          <p:cNvPr id="900" name="원안 그림"/>
+          <p:cNvPr id="31" name="원안 그림"/>
           <p:cNvGrpSpPr/>
           <p:nvPr/>
         </p:nvGrpSpPr>
@@ -11782,7 +13730,7 @@
         </p:grpSpPr>
         <p:sp>
           <p:nvSpPr>
-            <p:cNvPr id="901" name="Shape 18"/>
+            <p:cNvPr id="32" name="Shape 18"/>
             <p:cNvSpPr/>
             <p:nvPr/>
           </p:nvSpPr>
@@ -11811,7 +13759,7 @@
         </p:sp>
         <p:sp>
           <p:nvSpPr>
-            <p:cNvPr id="902" name="Shape 19"/>
+            <p:cNvPr id="33" name="Shape 19"/>
             <p:cNvSpPr/>
             <p:nvPr/>
           </p:nvSpPr>
@@ -11840,7 +13788,7 @@
         </p:sp>
         <p:sp>
           <p:nvSpPr>
-            <p:cNvPr id="903" name="Shape 20"/>
+            <p:cNvPr id="34" name="Shape 20"/>
             <p:cNvSpPr/>
             <p:nvPr/>
           </p:nvSpPr>
@@ -11869,7 +13817,7 @@
         </p:sp>
         <p:sp>
           <p:nvSpPr>
-            <p:cNvPr id="904" name="Shape 21"/>
+            <p:cNvPr id="35" name="Shape 21"/>
             <p:cNvSpPr/>
             <p:nvPr/>
           </p:nvSpPr>
@@ -11898,7 +13846,7 @@
         </p:sp>
         <p:sp>
           <p:nvSpPr>
-            <p:cNvPr id="905" name="Shape 22"/>
+            <p:cNvPr id="36" name="Shape 22"/>
             <p:cNvSpPr/>
             <p:nvPr/>
           </p:nvSpPr>
@@ -11927,7 +13875,7 @@
         </p:sp>
         <p:sp>
           <p:nvSpPr>
-            <p:cNvPr id="906" name="Shape 23"/>
+            <p:cNvPr id="37" name="Shape 23"/>
             <p:cNvSpPr/>
             <p:nvPr/>
           </p:nvSpPr>
@@ -11956,7 +13904,7 @@
         </p:sp>
         <p:sp>
           <p:nvSpPr>
-            <p:cNvPr id="907" name="Shape 24"/>
+            <p:cNvPr id="38" name="Shape 24"/>
             <p:cNvSpPr/>
             <p:nvPr/>
           </p:nvSpPr>
@@ -11985,7 +13933,7 @@
         </p:sp>
         <p:sp>
           <p:nvSpPr>
-            <p:cNvPr id="908" name="Shape 25"/>
+            <p:cNvPr id="39" name="Shape 25"/>
             <p:cNvSpPr/>
             <p:nvPr/>
           </p:nvSpPr>
@@ -12014,7 +13962,7 @@
         </p:sp>
         <p:sp>
           <p:nvSpPr>
-            <p:cNvPr id="909" name="Shape 26"/>
+            <p:cNvPr id="40" name="Shape 26"/>
             <p:cNvSpPr/>
             <p:nvPr/>
           </p:nvSpPr>
@@ -12043,7 +13991,7 @@
         </p:sp>
         <p:sp>
           <p:nvSpPr>
-            <p:cNvPr id="910" name="Shape 27"/>
+            <p:cNvPr id="41" name="Shape 27"/>
             <p:cNvSpPr/>
             <p:nvPr/>
           </p:nvSpPr>
@@ -12070,7 +14018,7 @@
         </p:sp>
         <p:sp>
           <p:nvSpPr>
-            <p:cNvPr id="911" name="Shape 28"/>
+            <p:cNvPr id="42" name="Shape 28"/>
             <p:cNvSpPr/>
             <p:nvPr/>
           </p:nvSpPr>
@@ -12097,14 +14045,14 @@
         </p:sp>
         <p:sp>
           <p:nvSpPr>
-            <p:cNvPr id="912" name="Shape 29"/>
+            <p:cNvPr id="43" name="Shape 29"/>
             <p:cNvSpPr/>
             <p:nvPr/>
           </p:nvSpPr>
           <p:spPr>
-            <a:xfrm>
-              <a:off x="7044355" y="4589556"/>
-              <a:ext cx="-94732" cy="243596"/>
+            <a:xfrm flipH="1">
+              <a:off x="6949623" y="4589556"/>
+              <a:ext cx="94732" cy="243596"/>
             </a:xfrm>
             <a:prstGeom prst="line">
               <a:avLst>
@@ -12124,7 +14072,7 @@
         </p:sp>
         <p:sp>
           <p:nvSpPr>
-            <p:cNvPr id="913" name="Shape 30"/>
+            <p:cNvPr id="44" name="Shape 30"/>
             <p:cNvSpPr/>
             <p:nvPr/>
           </p:nvSpPr>
@@ -12151,7 +14099,7 @@
         </p:sp>
         <p:sp>
           <p:nvSpPr>
-            <p:cNvPr id="914" name="Shape 31"/>
+            <p:cNvPr id="45" name="Shape 31"/>
             <p:cNvSpPr/>
             <p:nvPr/>
           </p:nvSpPr>
@@ -12180,7 +14128,7 @@
         </p:sp>
         <p:sp>
           <p:nvSpPr>
-            <p:cNvPr id="915" name="Shape 32"/>
+            <p:cNvPr id="46" name="Shape 32"/>
             <p:cNvSpPr/>
             <p:nvPr/>
           </p:nvSpPr>
@@ -12209,7 +14157,7 @@
         </p:sp>
         <p:sp>
           <p:nvSpPr>
-            <p:cNvPr id="916" name="Shape 33"/>
+            <p:cNvPr id="47" name="Shape 33"/>
             <p:cNvSpPr/>
             <p:nvPr/>
           </p:nvSpPr>
@@ -12238,7 +14186,7 @@
         </p:sp>
         <p:sp>
           <p:nvSpPr>
-            <p:cNvPr id="917" name="Shape 34"/>
+            <p:cNvPr id="48" name="Shape 34"/>
             <p:cNvSpPr/>
             <p:nvPr/>
           </p:nvSpPr>
@@ -12265,7 +14213,7 @@
         </p:sp>
         <p:sp>
           <p:nvSpPr>
-            <p:cNvPr id="918" name="Shape 35"/>
+            <p:cNvPr id="49" name="Shape 35"/>
             <p:cNvSpPr/>
             <p:nvPr/>
           </p:nvSpPr>
@@ -12292,14 +14240,14 @@
         </p:sp>
         <p:sp>
           <p:nvSpPr>
-            <p:cNvPr id="919" name="Shape 36"/>
+            <p:cNvPr id="50" name="Shape 36"/>
             <p:cNvSpPr/>
             <p:nvPr/>
           </p:nvSpPr>
           <p:spPr>
-            <a:xfrm>
-              <a:off x="8532084" y="4514576"/>
-              <a:ext cx="-107533" cy="276515"/>
+            <a:xfrm flipH="1">
+              <a:off x="8424551" y="4514576"/>
+              <a:ext cx="107533" cy="276515"/>
             </a:xfrm>
             <a:prstGeom prst="line">
               <a:avLst>
@@ -12319,7 +14267,7 @@
         </p:sp>
         <p:sp>
           <p:nvSpPr>
-            <p:cNvPr id="920" name="Shape 37"/>
+            <p:cNvPr id="51" name="Shape 37"/>
             <p:cNvSpPr/>
             <p:nvPr/>
           </p:nvSpPr>
@@ -12346,7 +14294,7 @@
         </p:sp>
         <p:sp>
           <p:nvSpPr>
-            <p:cNvPr id="921" name="Shape 38"/>
+            <p:cNvPr id="52" name="Shape 38"/>
             <p:cNvSpPr/>
             <p:nvPr/>
           </p:nvSpPr>
@@ -12375,7 +14323,7 @@
         </p:sp>
         <p:sp>
           <p:nvSpPr>
-            <p:cNvPr id="922" name="Shape 39"/>
+            <p:cNvPr id="53" name="Shape 39"/>
             <p:cNvSpPr/>
             <p:nvPr/>
           </p:nvSpPr>
@@ -12404,7 +14352,7 @@
         </p:sp>
         <p:sp>
           <p:nvSpPr>
-            <p:cNvPr id="923" name="Shape 40"/>
+            <p:cNvPr id="54" name="Shape 40"/>
             <p:cNvSpPr/>
             <p:nvPr/>
           </p:nvSpPr>
@@ -12433,7 +14381,7 @@
         </p:sp>
         <p:sp>
           <p:nvSpPr>
-            <p:cNvPr id="924" name="Shape 41"/>
+            <p:cNvPr id="55" name="Shape 41"/>
             <p:cNvSpPr/>
             <p:nvPr/>
           </p:nvSpPr>
@@ -12460,7 +14408,7 @@
         </p:sp>
         <p:sp>
           <p:nvSpPr>
-            <p:cNvPr id="925" name="Shape 42"/>
+            <p:cNvPr id="56" name="Shape 42"/>
             <p:cNvSpPr/>
             <p:nvPr/>
           </p:nvSpPr>
@@ -12487,14 +14435,14 @@
         </p:sp>
         <p:sp>
           <p:nvSpPr>
-            <p:cNvPr id="926" name="Shape 43"/>
+            <p:cNvPr id="57" name="Shape 43"/>
             <p:cNvSpPr/>
             <p:nvPr/>
           </p:nvSpPr>
           <p:spPr>
-            <a:xfrm>
-              <a:off x="10140787" y="4561393"/>
-              <a:ext cx="-93452" cy="240304"/>
+            <a:xfrm flipH="1">
+              <a:off x="10047335" y="4561393"/>
+              <a:ext cx="93452" cy="240304"/>
             </a:xfrm>
             <a:prstGeom prst="line">
               <a:avLst>
@@ -12514,7 +14462,7 @@
         </p:sp>
         <p:sp>
           <p:nvSpPr>
-            <p:cNvPr id="927" name="Shape 44"/>
+            <p:cNvPr id="58" name="Shape 44"/>
             <p:cNvSpPr/>
             <p:nvPr/>
           </p:nvSpPr>
@@ -12541,7 +14489,7 @@
         </p:sp>
         <p:sp>
           <p:nvSpPr>
-            <p:cNvPr id="928" name="Shape 45"/>
+            <p:cNvPr id="59" name="Shape 45"/>
             <p:cNvSpPr/>
             <p:nvPr/>
           </p:nvSpPr>
@@ -12570,7 +14518,7 @@
         </p:sp>
         <p:sp>
           <p:nvSpPr>
-            <p:cNvPr id="929" name="Shape 46"/>
+            <p:cNvPr id="60" name="Shape 46"/>
             <p:cNvSpPr/>
             <p:nvPr/>
           </p:nvSpPr>
@@ -12599,7 +14547,7 @@
         </p:sp>
         <p:sp>
           <p:nvSpPr>
-            <p:cNvPr id="930" name="Text 47"/>
+            <p:cNvPr id="61" name="Text 47"/>
             <p:cNvSpPr/>
             <p:nvPr/>
           </p:nvSpPr>
@@ -12640,7 +14588,7 @@
         </p:sp>
         <p:sp>
           <p:nvSpPr>
-            <p:cNvPr id="931" name="Text 48"/>
+            <p:cNvPr id="62" name="Text 48"/>
             <p:cNvSpPr/>
             <p:nvPr/>
           </p:nvSpPr>
@@ -13550,14 +15498,54 @@
       </p:sp>
       <p:sp>
         <p:nvSpPr>
-          <p:cNvPr id="26" name="Text 24"/>
+          <p:cNvPr id="26" name="decision-pill"/>
           <p:cNvSpPr txBox="1"/>
           <p:nvPr/>
         </p:nvSpPr>
         <p:spPr>
           <a:xfrm>
             <a:off x="548640" y="5870448"/>
-            <a:ext cx="11064240" cy="365760"/>
+            <a:ext cx="4206240" cy="384048"/>
+          </a:xfrm>
+          <a:prstGeom prst="roundRect">
+            <a:avLst>
+              <a:gd name="adj" fmla="val 23810"/>
+            </a:avLst>
+          </a:prstGeom>
+          <a:solidFill>
+            <a:srgbClr val="E8614D"/>
+          </a:solidFill>
+          <a:ln/>
+        </p:spPr>
+        <p:txBody>
+          <a:bodyPr wrap="square" lIns="0" tIns="0" rIns="0" bIns="0" rtlCol="0" anchor="ctr"/>
+          <a:lstStyle/>
+          <a:p>
+            <a:pPr algn="ctr" indent="0" marL="0">
+              <a:buNone/>
+            </a:pPr>
+            <a:r>
+              <a:rPr lang="en-US" sz="1300" b="1" dirty="0">
+                <a:solidFill>
+                  <a:srgbClr val="FFFFFF"/>
+                </a:solidFill>
+              </a:rPr>
+              <a:t>결정 ⑤  보관 범위 · 3가지 중 선택</a:t>
+            </a:r>
+            <a:endParaRPr lang="en-US" sz="1300" dirty="0"/>
+          </a:p>
+        </p:txBody>
+      </p:sp>
+      <p:sp>
+        <p:nvSpPr>
+          <p:cNvPr id="27" name="Text 25"/>
+          <p:cNvSpPr txBox="1"/>
+          <p:nvPr/>
+        </p:nvSpPr>
+        <p:spPr>
+          <a:xfrm>
+            <a:off x="5029200" y="5870448"/>
+            <a:ext cx="6583680" cy="384048"/>
           </a:xfrm>
           <a:prstGeom prst="rect">
             <a:avLst/>
@@ -13573,9 +15561,9 @@
               <a:buNone/>
             </a:pPr>
             <a:r>
-              <a:rPr lang="en-US" sz="1300" b="1" dirty="0">
-                <a:solidFill>
-                  <a:srgbClr val="E8614D"/>
+              <a:rPr lang="en-US" sz="1200" b="1" dirty="0">
+                <a:solidFill>
+                  <a:srgbClr val="617287"/>
                 </a:solidFill>
               </a:rPr>
               <a:t>확인할 것  </a:t>
@@ -13584,20 +15572,20 @@
               <a:buNone/>
             </a:pPr>
             <a:r>
-              <a:rPr lang="en-US" sz="1300" dirty="0">
+              <a:rPr lang="en-US" sz="1200" dirty="0">
                 <a:solidFill>
                   <a:srgbClr val="16243A"/>
                 </a:solidFill>
               </a:rPr>
               <a:t>QR 보관함 플랫폼 · 출력 장비 · 개인정보 처리 기준</a:t>
             </a:r>
-            <a:endParaRPr lang="en-US" sz="1300" dirty="0"/>
-          </a:p>
-        </p:txBody>
-      </p:sp>
-      <p:sp>
-        <p:nvSpPr>
-          <p:cNvPr id="25" name="Slide Number Placeholder 0"/>
+            <a:endParaRPr lang="en-US" sz="1200" dirty="0"/>
+          </a:p>
+        </p:txBody>
+      </p:sp>
+      <p:sp>
+        <p:nvSpPr>
+          <p:cNvPr id="28" name="Slide Number Placeholder 0"/>
           <p:cNvSpPr>
             <a:spLocks noGrp="1"/>
           </p:cNvSpPr>
@@ -13743,7 +15731,7 @@
       </p:sp>
       <p:graphicFrame>
         <p:nvGraphicFramePr>
-          <p:cNvPr id="10" name="ops-table"/>
+          <p:cNvPr id="4" name="ops-table"/>
           <p:cNvGraphicFramePr>
             <a:graphicFrameLocks noGrp="1"/>
           </p:cNvGraphicFramePr>
@@ -14920,7 +16908,7 @@
       </p:sp>
       <p:sp>
         <p:nvSpPr>
-          <p:cNvPr id="25" name="Slide Number Placeholder 0"/>
+          <p:cNvPr id="6" name="Slide Number Placeholder 0"/>
           <p:cNvSpPr>
             <a:spLocks noGrp="1"/>
           </p:cNvSpPr>

</xml_diff>